<commit_message>
Finalized model output and created poster
</commit_message>
<xml_diff>
--- a/Project1_ML.pptx
+++ b/Project1_ML.pptx
@@ -115,7 +115,7 @@
 <file path=ppt/revisionInfo.xml><?xml version="1.0" encoding="utf-8"?>
 <p1510:revInfo xmlns:a="http://schemas.openxmlformats.org/drawingml/2006/main" xmlns:r="http://schemas.openxmlformats.org/officeDocument/2006/relationships" xmlns:p1510="http://schemas.microsoft.com/office/powerpoint/2015/10/main">
   <p1510:revLst>
-    <p1510:client id="{90B53FFB-8E3A-BF4B-AA9C-0AE78C617D6F}" v="61" dt="2026-10-04T00:23:25.021"/>
+    <p1510:client id="{90B53FFB-8E3A-BF4B-AA9C-0AE78C617D6F}" v="487" dt="2026-10-04T04:03:13.226"/>
   </p1510:revLst>
 </p1510:revInfo>
 </file>
@@ -124,19 +124,43 @@
 <pc:chgInfo xmlns:a="http://schemas.openxmlformats.org/drawingml/2006/main" xmlns:r="http://schemas.openxmlformats.org/officeDocument/2006/relationships" xmlns:ac="http://schemas.microsoft.com/office/drawing/2013/main/command" xmlns:pc="http://schemas.microsoft.com/office/powerpoint/2013/main/command">
   <pc:docChgLst>
     <pc:chgData name="Muyuan Li" userId="02573e01-306c-4233-b7d3-57f5fe21f9bc" providerId="ADAL" clId="{CAA0BD58-D522-5466-B6F1-179DCA91B97E}"/>
-    <pc:docChg chg="custSel modSld">
-      <pc:chgData name="Muyuan Li" userId="02573e01-306c-4233-b7d3-57f5fe21f9bc" providerId="ADAL" clId="{CAA0BD58-D522-5466-B6F1-179DCA91B97E}" dt="2026-10-04T00:23:47.042" v="147" actId="1076"/>
+    <pc:docChg chg="undo redo custSel modSld">
+      <pc:chgData name="Muyuan Li" userId="02573e01-306c-4233-b7d3-57f5fe21f9bc" providerId="ADAL" clId="{CAA0BD58-D522-5466-B6F1-179DCA91B97E}" dt="2026-10-04T04:05:17.174" v="2773" actId="20577"/>
       <pc:docMkLst>
         <pc:docMk/>
       </pc:docMkLst>
       <pc:sldChg chg="addSp delSp modSp mod">
-        <pc:chgData name="Muyuan Li" userId="02573e01-306c-4233-b7d3-57f5fe21f9bc" providerId="ADAL" clId="{CAA0BD58-D522-5466-B6F1-179DCA91B97E}" dt="2026-10-04T00:23:47.042" v="147" actId="1076"/>
+        <pc:chgData name="Muyuan Li" userId="02573e01-306c-4233-b7d3-57f5fe21f9bc" providerId="ADAL" clId="{CAA0BD58-D522-5466-B6F1-179DCA91B97E}" dt="2026-10-04T04:05:17.174" v="2773" actId="20577"/>
         <pc:sldMkLst>
           <pc:docMk/>
           <pc:sldMk cId="2254363796" sldId="256"/>
         </pc:sldMkLst>
+        <pc:spChg chg="mod">
+          <ac:chgData name="Muyuan Li" userId="02573e01-306c-4233-b7d3-57f5fe21f9bc" providerId="ADAL" clId="{CAA0BD58-D522-5466-B6F1-179DCA91B97E}" dt="2026-10-04T03:59:07.431" v="2476" actId="1076"/>
+          <ac:spMkLst>
+            <pc:docMk/>
+            <pc:sldMk cId="2254363796" sldId="256"/>
+            <ac:spMk id="7" creationId="{50044E32-8AD6-34E7-995A-548678FF52D6}"/>
+          </ac:spMkLst>
+        </pc:spChg>
+        <pc:spChg chg="mod">
+          <ac:chgData name="Muyuan Li" userId="02573e01-306c-4233-b7d3-57f5fe21f9bc" providerId="ADAL" clId="{CAA0BD58-D522-5466-B6F1-179DCA91B97E}" dt="2026-10-04T03:59:20.466" v="2478" actId="1076"/>
+          <ac:spMkLst>
+            <pc:docMk/>
+            <pc:sldMk cId="2254363796" sldId="256"/>
+            <ac:spMk id="8" creationId="{8A5F7463-F890-5031-2E41-CCC439EEAB82}"/>
+          </ac:spMkLst>
+        </pc:spChg>
+        <pc:spChg chg="mod">
+          <ac:chgData name="Muyuan Li" userId="02573e01-306c-4233-b7d3-57f5fe21f9bc" providerId="ADAL" clId="{CAA0BD58-D522-5466-B6F1-179DCA91B97E}" dt="2026-10-04T03:58:22.362" v="2466" actId="1076"/>
+          <ac:spMkLst>
+            <pc:docMk/>
+            <pc:sldMk cId="2254363796" sldId="256"/>
+            <ac:spMk id="9" creationId="{4354D671-4CE0-F2E1-782D-C6D09B629473}"/>
+          </ac:spMkLst>
+        </pc:spChg>
         <pc:spChg chg="add mod">
-          <ac:chgData name="Muyuan Li" userId="02573e01-306c-4233-b7d3-57f5fe21f9bc" providerId="ADAL" clId="{CAA0BD58-D522-5466-B6F1-179DCA91B97E}" dt="2026-10-04T00:21:14.893" v="67" actId="122"/>
+          <ac:chgData name="Muyuan Li" userId="02573e01-306c-4233-b7d3-57f5fe21f9bc" providerId="ADAL" clId="{CAA0BD58-D522-5466-B6F1-179DCA91B97E}" dt="2026-10-04T03:18:25.553" v="1910" actId="1036"/>
           <ac:spMkLst>
             <pc:docMk/>
             <pc:sldMk cId="2254363796" sldId="256"/>
@@ -184,11 +208,299 @@
           </ac:spMkLst>
         </pc:spChg>
         <pc:spChg chg="add mod">
-          <ac:chgData name="Muyuan Li" userId="02573e01-306c-4233-b7d3-57f5fe21f9bc" providerId="ADAL" clId="{CAA0BD58-D522-5466-B6F1-179DCA91B97E}" dt="2026-10-04T00:23:14.042" v="133" actId="14100"/>
+          <ac:chgData name="Muyuan Li" userId="02573e01-306c-4233-b7d3-57f5fe21f9bc" providerId="ADAL" clId="{CAA0BD58-D522-5466-B6F1-179DCA91B97E}" dt="2026-10-04T02:39:58.308" v="1141" actId="113"/>
           <ac:spMkLst>
             <pc:docMk/>
             <pc:sldMk cId="2254363796" sldId="256"/>
             <ac:spMk id="19" creationId="{8C64EC19-0139-B836-9FB6-6B01746E3DEC}"/>
+          </ac:spMkLst>
+        </pc:spChg>
+        <pc:spChg chg="add mod">
+          <ac:chgData name="Muyuan Li" userId="02573e01-306c-4233-b7d3-57f5fe21f9bc" providerId="ADAL" clId="{CAA0BD58-D522-5466-B6F1-179DCA91B97E}" dt="2026-10-04T02:55:32.026" v="1552" actId="1036"/>
+          <ac:spMkLst>
+            <pc:docMk/>
+            <pc:sldMk cId="2254363796" sldId="256"/>
+            <ac:spMk id="21" creationId="{64963BAA-912D-5FC0-C390-B49EFA05A969}"/>
+          </ac:spMkLst>
+        </pc:spChg>
+        <pc:spChg chg="add mod">
+          <ac:chgData name="Muyuan Li" userId="02573e01-306c-4233-b7d3-57f5fe21f9bc" providerId="ADAL" clId="{CAA0BD58-D522-5466-B6F1-179DCA91B97E}" dt="2026-10-04T02:13:08.760" v="194"/>
+          <ac:spMkLst>
+            <pc:docMk/>
+            <pc:sldMk cId="2254363796" sldId="256"/>
+            <ac:spMk id="23" creationId="{A4BC86EA-9A98-AC08-B0BA-6899736F3FED}"/>
+          </ac:spMkLst>
+        </pc:spChg>
+        <pc:spChg chg="add mod">
+          <ac:chgData name="Muyuan Li" userId="02573e01-306c-4233-b7d3-57f5fe21f9bc" providerId="ADAL" clId="{CAA0BD58-D522-5466-B6F1-179DCA91B97E}" dt="2026-10-04T02:13:08.760" v="194"/>
+          <ac:spMkLst>
+            <pc:docMk/>
+            <pc:sldMk cId="2254363796" sldId="256"/>
+            <ac:spMk id="24" creationId="{01D4FA09-3325-A116-B3DE-F66F1829572D}"/>
+          </ac:spMkLst>
+        </pc:spChg>
+        <pc:spChg chg="add mod">
+          <ac:chgData name="Muyuan Li" userId="02573e01-306c-4233-b7d3-57f5fe21f9bc" providerId="ADAL" clId="{CAA0BD58-D522-5466-B6F1-179DCA91B97E}" dt="2026-10-04T02:14:54.083" v="231"/>
+          <ac:spMkLst>
+            <pc:docMk/>
+            <pc:sldMk cId="2254363796" sldId="256"/>
+            <ac:spMk id="26" creationId="{8443DB1A-6509-EA7D-73D6-2E910711C576}"/>
+          </ac:spMkLst>
+        </pc:spChg>
+        <pc:spChg chg="add mod">
+          <ac:chgData name="Muyuan Li" userId="02573e01-306c-4233-b7d3-57f5fe21f9bc" providerId="ADAL" clId="{CAA0BD58-D522-5466-B6F1-179DCA91B97E}" dt="2026-10-04T02:14:54.083" v="231"/>
+          <ac:spMkLst>
+            <pc:docMk/>
+            <pc:sldMk cId="2254363796" sldId="256"/>
+            <ac:spMk id="27" creationId="{98E9EFE7-F85D-3BBF-021F-1FA9AB25E1FB}"/>
+          </ac:spMkLst>
+        </pc:spChg>
+        <pc:spChg chg="add del mod topLvl">
+          <ac:chgData name="Muyuan Li" userId="02573e01-306c-4233-b7d3-57f5fe21f9bc" providerId="ADAL" clId="{CAA0BD58-D522-5466-B6F1-179DCA91B97E}" dt="2026-10-04T02:15:30.843" v="254" actId="478"/>
+          <ac:spMkLst>
+            <pc:docMk/>
+            <pc:sldMk cId="2254363796" sldId="256"/>
+            <ac:spMk id="29" creationId="{90721D31-4B82-CF22-ACE5-AB0D9FA1CC86}"/>
+          </ac:spMkLst>
+        </pc:spChg>
+        <pc:spChg chg="add del mod topLvl">
+          <ac:chgData name="Muyuan Li" userId="02573e01-306c-4233-b7d3-57f5fe21f9bc" providerId="ADAL" clId="{CAA0BD58-D522-5466-B6F1-179DCA91B97E}" dt="2026-10-04T02:15:27.119" v="251" actId="478"/>
+          <ac:spMkLst>
+            <pc:docMk/>
+            <pc:sldMk cId="2254363796" sldId="256"/>
+            <ac:spMk id="30" creationId="{10795EC0-F140-5FC5-21A3-E5230F5900FD}"/>
+          </ac:spMkLst>
+        </pc:spChg>
+        <pc:spChg chg="add mod">
+          <ac:chgData name="Muyuan Li" userId="02573e01-306c-4233-b7d3-57f5fe21f9bc" providerId="ADAL" clId="{CAA0BD58-D522-5466-B6F1-179DCA91B97E}" dt="2026-10-04T02:55:39.180" v="1553" actId="1076"/>
+          <ac:spMkLst>
+            <pc:docMk/>
+            <pc:sldMk cId="2254363796" sldId="256"/>
+            <ac:spMk id="31" creationId="{A3DE8E7F-5AF2-9B70-44D8-8C1C2B6B0EC8}"/>
+          </ac:spMkLst>
+        </pc:spChg>
+        <pc:spChg chg="add mod">
+          <ac:chgData name="Muyuan Li" userId="02573e01-306c-4233-b7d3-57f5fe21f9bc" providerId="ADAL" clId="{CAA0BD58-D522-5466-B6F1-179DCA91B97E}" dt="2026-10-04T02:55:43.730" v="1554" actId="1076"/>
+          <ac:spMkLst>
+            <pc:docMk/>
+            <pc:sldMk cId="2254363796" sldId="256"/>
+            <ac:spMk id="32" creationId="{96E2AF48-E58A-079D-DBA8-D5FC11BE81C2}"/>
+          </ac:spMkLst>
+        </pc:spChg>
+        <pc:spChg chg="add mod">
+          <ac:chgData name="Muyuan Li" userId="02573e01-306c-4233-b7d3-57f5fe21f9bc" providerId="ADAL" clId="{CAA0BD58-D522-5466-B6F1-179DCA91B97E}" dt="2026-10-04T02:56:06.164" v="1558" actId="1076"/>
+          <ac:spMkLst>
+            <pc:docMk/>
+            <pc:sldMk cId="2254363796" sldId="256"/>
+            <ac:spMk id="33" creationId="{168B7169-0D8F-C3E8-0ECC-FC72C94C1F61}"/>
+          </ac:spMkLst>
+        </pc:spChg>
+        <pc:spChg chg="add mod">
+          <ac:chgData name="Muyuan Li" userId="02573e01-306c-4233-b7d3-57f5fe21f9bc" providerId="ADAL" clId="{CAA0BD58-D522-5466-B6F1-179DCA91B97E}" dt="2026-10-04T02:56:19.682" v="1560" actId="1076"/>
+          <ac:spMkLst>
+            <pc:docMk/>
+            <pc:sldMk cId="2254363796" sldId="256"/>
+            <ac:spMk id="34" creationId="{1D201D78-C395-54A0-40EF-650FEFC801DF}"/>
+          </ac:spMkLst>
+        </pc:spChg>
+        <pc:spChg chg="add mod">
+          <ac:chgData name="Muyuan Li" userId="02573e01-306c-4233-b7d3-57f5fe21f9bc" providerId="ADAL" clId="{CAA0BD58-D522-5466-B6F1-179DCA91B97E}" dt="2026-10-04T03:47:09.326" v="2330" actId="20577"/>
+          <ac:spMkLst>
+            <pc:docMk/>
+            <pc:sldMk cId="2254363796" sldId="256"/>
+            <ac:spMk id="35" creationId="{75B2C6E6-20FF-EB81-74FA-E6645B446254}"/>
+          </ac:spMkLst>
+        </pc:spChg>
+        <pc:spChg chg="add mod topLvl">
+          <ac:chgData name="Muyuan Li" userId="02573e01-306c-4233-b7d3-57f5fe21f9bc" providerId="ADAL" clId="{CAA0BD58-D522-5466-B6F1-179DCA91B97E}" dt="2026-10-04T03:57:51.432" v="2459" actId="14100"/>
+          <ac:spMkLst>
+            <pc:docMk/>
+            <pc:sldMk cId="2254363796" sldId="256"/>
+            <ac:spMk id="37" creationId="{8A21A21B-E0D8-4545-8A63-7C29DE3B36A8}"/>
+          </ac:spMkLst>
+        </pc:spChg>
+        <pc:spChg chg="add del mod topLvl">
+          <ac:chgData name="Muyuan Li" userId="02573e01-306c-4233-b7d3-57f5fe21f9bc" providerId="ADAL" clId="{CAA0BD58-D522-5466-B6F1-179DCA91B97E}" dt="2026-10-04T02:26:26.416" v="644" actId="478"/>
+          <ac:spMkLst>
+            <pc:docMk/>
+            <pc:sldMk cId="2254363796" sldId="256"/>
+            <ac:spMk id="38" creationId="{E2773CDA-730B-1169-D02C-70358E129963}"/>
+          </ac:spMkLst>
+        </pc:spChg>
+        <pc:spChg chg="add del mod">
+          <ac:chgData name="Muyuan Li" userId="02573e01-306c-4233-b7d3-57f5fe21f9bc" providerId="ADAL" clId="{CAA0BD58-D522-5466-B6F1-179DCA91B97E}" dt="2026-10-04T02:30:24.254" v="717" actId="478"/>
+          <ac:spMkLst>
+            <pc:docMk/>
+            <pc:sldMk cId="2254363796" sldId="256"/>
+            <ac:spMk id="39" creationId="{FFAB302F-C3C9-8C43-6133-B3DDCB444C67}"/>
+          </ac:spMkLst>
+        </pc:spChg>
+        <pc:spChg chg="add del mod">
+          <ac:chgData name="Muyuan Li" userId="02573e01-306c-4233-b7d3-57f5fe21f9bc" providerId="ADAL" clId="{CAA0BD58-D522-5466-B6F1-179DCA91B97E}" dt="2026-10-04T02:30:13.045" v="716" actId="478"/>
+          <ac:spMkLst>
+            <pc:docMk/>
+            <pc:sldMk cId="2254363796" sldId="256"/>
+            <ac:spMk id="40" creationId="{2C08F451-150B-74A0-C96A-62C37D6200F7}"/>
+          </ac:spMkLst>
+        </pc:spChg>
+        <pc:spChg chg="add mod">
+          <ac:chgData name="Muyuan Li" userId="02573e01-306c-4233-b7d3-57f5fe21f9bc" providerId="ADAL" clId="{CAA0BD58-D522-5466-B6F1-179DCA91B97E}" dt="2026-10-04T02:30:27.248" v="718"/>
+          <ac:spMkLst>
+            <pc:docMk/>
+            <pc:sldMk cId="2254363796" sldId="256"/>
+            <ac:spMk id="42" creationId="{82F3FBDC-AAB8-A227-762E-A869A80004F7}"/>
+          </ac:spMkLst>
+        </pc:spChg>
+        <pc:spChg chg="add mod">
+          <ac:chgData name="Muyuan Li" userId="02573e01-306c-4233-b7d3-57f5fe21f9bc" providerId="ADAL" clId="{CAA0BD58-D522-5466-B6F1-179DCA91B97E}" dt="2026-10-04T03:43:31.742" v="2257" actId="20577"/>
+          <ac:spMkLst>
+            <pc:docMk/>
+            <pc:sldMk cId="2254363796" sldId="256"/>
+            <ac:spMk id="43" creationId="{E0F461F7-D034-B3C0-FF9B-07E8BECFEFDD}"/>
+          </ac:spMkLst>
+        </pc:spChg>
+        <pc:spChg chg="add del mod topLvl">
+          <ac:chgData name="Muyuan Li" userId="02573e01-306c-4233-b7d3-57f5fe21f9bc" providerId="ADAL" clId="{CAA0BD58-D522-5466-B6F1-179DCA91B97E}" dt="2026-10-04T02:44:08.237" v="1166" actId="478"/>
+          <ac:spMkLst>
+            <pc:docMk/>
+            <pc:sldMk cId="2254363796" sldId="256"/>
+            <ac:spMk id="45" creationId="{D3D7602F-B1C7-B0E8-42F0-1585E73839A2}"/>
+          </ac:spMkLst>
+        </pc:spChg>
+        <pc:spChg chg="add mod topLvl">
+          <ac:chgData name="Muyuan Li" userId="02573e01-306c-4233-b7d3-57f5fe21f9bc" providerId="ADAL" clId="{CAA0BD58-D522-5466-B6F1-179DCA91B97E}" dt="2026-10-04T03:55:42.395" v="2381" actId="1038"/>
+          <ac:spMkLst>
+            <pc:docMk/>
+            <pc:sldMk cId="2254363796" sldId="256"/>
+            <ac:spMk id="46" creationId="{7DE1D0F5-717B-7A37-FBFB-DA7D9B774396}"/>
+          </ac:spMkLst>
+        </pc:spChg>
+        <pc:spChg chg="add mod">
+          <ac:chgData name="Muyuan Li" userId="02573e01-306c-4233-b7d3-57f5fe21f9bc" providerId="ADAL" clId="{CAA0BD58-D522-5466-B6F1-179DCA91B97E}" dt="2026-10-04T02:44:56.093" v="1180"/>
+          <ac:spMkLst>
+            <pc:docMk/>
+            <pc:sldMk cId="2254363796" sldId="256"/>
+            <ac:spMk id="48" creationId="{0DB3E0CD-8894-4D92-CB43-DEB09D76A583}"/>
+          </ac:spMkLst>
+        </pc:spChg>
+        <pc:spChg chg="add mod">
+          <ac:chgData name="Muyuan Li" userId="02573e01-306c-4233-b7d3-57f5fe21f9bc" providerId="ADAL" clId="{CAA0BD58-D522-5466-B6F1-179DCA91B97E}" dt="2026-10-04T02:44:56.093" v="1180"/>
+          <ac:spMkLst>
+            <pc:docMk/>
+            <pc:sldMk cId="2254363796" sldId="256"/>
+            <ac:spMk id="49" creationId="{6D885D76-7042-DCA4-CC37-6D26D38A6E1F}"/>
+          </ac:spMkLst>
+        </pc:spChg>
+        <pc:spChg chg="add mod">
+          <ac:chgData name="Muyuan Li" userId="02573e01-306c-4233-b7d3-57f5fe21f9bc" providerId="ADAL" clId="{CAA0BD58-D522-5466-B6F1-179DCA91B97E}" dt="2026-10-04T03:21:20.401" v="1980" actId="1076"/>
+          <ac:spMkLst>
+            <pc:docMk/>
+            <pc:sldMk cId="2254363796" sldId="256"/>
+            <ac:spMk id="50" creationId="{630353C5-4BB3-6ECB-AC51-D3493CF4559F}"/>
+          </ac:spMkLst>
+        </pc:spChg>
+        <pc:spChg chg="add mod">
+          <ac:chgData name="Muyuan Li" userId="02573e01-306c-4233-b7d3-57f5fe21f9bc" providerId="ADAL" clId="{CAA0BD58-D522-5466-B6F1-179DCA91B97E}" dt="2026-10-04T02:48:57.405" v="1286"/>
+          <ac:spMkLst>
+            <pc:docMk/>
+            <pc:sldMk cId="2254363796" sldId="256"/>
+            <ac:spMk id="52" creationId="{3DF5929E-5364-947E-398C-1C35FB60BEA8}"/>
+          </ac:spMkLst>
+        </pc:spChg>
+        <pc:spChg chg="add mod">
+          <ac:chgData name="Muyuan Li" userId="02573e01-306c-4233-b7d3-57f5fe21f9bc" providerId="ADAL" clId="{CAA0BD58-D522-5466-B6F1-179DCA91B97E}" dt="2026-10-04T02:49:28.149" v="1296" actId="1035"/>
+          <ac:spMkLst>
+            <pc:docMk/>
+            <pc:sldMk cId="2254363796" sldId="256"/>
+            <ac:spMk id="53" creationId="{043FBC30-ED76-5386-6ECC-6974158D3DF8}"/>
+          </ac:spMkLst>
+        </pc:spChg>
+        <pc:spChg chg="mod">
+          <ac:chgData name="Muyuan Li" userId="02573e01-306c-4233-b7d3-57f5fe21f9bc" providerId="ADAL" clId="{CAA0BD58-D522-5466-B6F1-179DCA91B97E}" dt="2026-10-04T02:52:41.977" v="1445" actId="207"/>
+          <ac:spMkLst>
+            <pc:docMk/>
+            <pc:sldMk cId="2254363796" sldId="256"/>
+            <ac:spMk id="55" creationId="{6912814A-9D52-5975-5241-3EAA74EA42E3}"/>
+          </ac:spMkLst>
+        </pc:spChg>
+        <pc:spChg chg="mod">
+          <ac:chgData name="Muyuan Li" userId="02573e01-306c-4233-b7d3-57f5fe21f9bc" providerId="ADAL" clId="{CAA0BD58-D522-5466-B6F1-179DCA91B97E}" dt="2026-10-04T02:52:28.833" v="1353" actId="1076"/>
+          <ac:spMkLst>
+            <pc:docMk/>
+            <pc:sldMk cId="2254363796" sldId="256"/>
+            <ac:spMk id="56" creationId="{1F45248A-0214-B952-1895-FDA04CFACFF3}"/>
+          </ac:spMkLst>
+        </pc:spChg>
+        <pc:spChg chg="add mod">
+          <ac:chgData name="Muyuan Li" userId="02573e01-306c-4233-b7d3-57f5fe21f9bc" providerId="ADAL" clId="{CAA0BD58-D522-5466-B6F1-179DCA91B97E}" dt="2026-10-04T03:58:17.882" v="2465" actId="1076"/>
+          <ac:spMkLst>
+            <pc:docMk/>
+            <pc:sldMk cId="2254363796" sldId="256"/>
+            <ac:spMk id="57" creationId="{F2C9370C-5F7A-87AF-A4A5-D9791D9FA94F}"/>
+          </ac:spMkLst>
+        </pc:spChg>
+        <pc:spChg chg="add mod">
+          <ac:chgData name="Muyuan Li" userId="02573e01-306c-4233-b7d3-57f5fe21f9bc" providerId="ADAL" clId="{CAA0BD58-D522-5466-B6F1-179DCA91B97E}" dt="2026-10-04T03:16:35.550" v="1881" actId="767"/>
+          <ac:spMkLst>
+            <pc:docMk/>
+            <pc:sldMk cId="2254363796" sldId="256"/>
+            <ac:spMk id="58" creationId="{FEC11E17-E065-5941-CE42-B6D3A4DF4B61}"/>
+          </ac:spMkLst>
+        </pc:spChg>
+        <pc:spChg chg="add mod">
+          <ac:chgData name="Muyuan Li" userId="02573e01-306c-4233-b7d3-57f5fe21f9bc" providerId="ADAL" clId="{CAA0BD58-D522-5466-B6F1-179DCA91B97E}" dt="2026-10-04T03:58:08.565" v="2462" actId="14100"/>
+          <ac:spMkLst>
+            <pc:docMk/>
+            <pc:sldMk cId="2254363796" sldId="256"/>
+            <ac:spMk id="59" creationId="{2A63506B-CE5B-F017-8A9F-7B9E68AD5292}"/>
+          </ac:spMkLst>
+        </pc:spChg>
+        <pc:spChg chg="add mod">
+          <ac:chgData name="Muyuan Li" userId="02573e01-306c-4233-b7d3-57f5fe21f9bc" providerId="ADAL" clId="{CAA0BD58-D522-5466-B6F1-179DCA91B97E}" dt="2026-10-04T03:58:32.830" v="2468" actId="14100"/>
+          <ac:spMkLst>
+            <pc:docMk/>
+            <pc:sldMk cId="2254363796" sldId="256"/>
+            <ac:spMk id="60" creationId="{13EF09E5-0607-B1F1-F7C5-E1DD501A546D}"/>
+          </ac:spMkLst>
+        </pc:spChg>
+        <pc:spChg chg="add mod">
+          <ac:chgData name="Muyuan Li" userId="02573e01-306c-4233-b7d3-57f5fe21f9bc" providerId="ADAL" clId="{CAA0BD58-D522-5466-B6F1-179DCA91B97E}" dt="2026-10-04T03:59:03.785" v="2475" actId="1076"/>
+          <ac:spMkLst>
+            <pc:docMk/>
+            <pc:sldMk cId="2254363796" sldId="256"/>
+            <ac:spMk id="61" creationId="{78060164-7FB2-140B-184D-64A573D43F53}"/>
+          </ac:spMkLst>
+        </pc:spChg>
+        <pc:spChg chg="add mod">
+          <ac:chgData name="Muyuan Li" userId="02573e01-306c-4233-b7d3-57f5fe21f9bc" providerId="ADAL" clId="{CAA0BD58-D522-5466-B6F1-179DCA91B97E}" dt="2026-10-04T03:24:32.689" v="2020" actId="1076"/>
+          <ac:spMkLst>
+            <pc:docMk/>
+            <pc:sldMk cId="2254363796" sldId="256"/>
+            <ac:spMk id="62" creationId="{918C2D8C-4B89-0F62-F711-B650DCE380BA}"/>
+          </ac:spMkLst>
+        </pc:spChg>
+        <pc:spChg chg="add mod">
+          <ac:chgData name="Muyuan Li" userId="02573e01-306c-4233-b7d3-57f5fe21f9bc" providerId="ADAL" clId="{CAA0BD58-D522-5466-B6F1-179DCA91B97E}" dt="2026-10-04T04:05:17.174" v="2773" actId="20577"/>
+          <ac:spMkLst>
+            <pc:docMk/>
+            <pc:sldMk cId="2254363796" sldId="256"/>
+            <ac:spMk id="63" creationId="{E798CF97-6B28-7CEF-8896-0D767DA2B450}"/>
+          </ac:spMkLst>
+        </pc:spChg>
+        <pc:spChg chg="add del mod">
+          <ac:chgData name="Muyuan Li" userId="02573e01-306c-4233-b7d3-57f5fe21f9bc" providerId="ADAL" clId="{CAA0BD58-D522-5466-B6F1-179DCA91B97E}" dt="2026-10-04T03:49:10.193" v="2346" actId="478"/>
+          <ac:spMkLst>
+            <pc:docMk/>
+            <pc:sldMk cId="2254363796" sldId="256"/>
+            <ac:spMk id="64" creationId="{F44A9E11-4D55-0338-FF7A-E0324580C394}"/>
+          </ac:spMkLst>
+        </pc:spChg>
+        <pc:spChg chg="add mod">
+          <ac:chgData name="Muyuan Li" userId="02573e01-306c-4233-b7d3-57f5fe21f9bc" providerId="ADAL" clId="{CAA0BD58-D522-5466-B6F1-179DCA91B97E}" dt="2026-10-04T03:59:14.617" v="2477" actId="14100"/>
+          <ac:spMkLst>
+            <pc:docMk/>
+            <pc:sldMk cId="2254363796" sldId="256"/>
+            <ac:spMk id="65" creationId="{323056C3-62F8-FEAA-4D64-4D95D744EDA7}"/>
           </ac:spMkLst>
         </pc:spChg>
         <pc:grpChg chg="add del mod">
@@ -200,7 +512,7 @@
           </ac:grpSpMkLst>
         </pc:grpChg>
         <pc:grpChg chg="add mod">
-          <ac:chgData name="Muyuan Li" userId="02573e01-306c-4233-b7d3-57f5fe21f9bc" providerId="ADAL" clId="{CAA0BD58-D522-5466-B6F1-179DCA91B97E}" dt="2026-10-04T00:23:41.340" v="146" actId="1036"/>
+          <ac:chgData name="Muyuan Li" userId="02573e01-306c-4233-b7d3-57f5fe21f9bc" providerId="ADAL" clId="{CAA0BD58-D522-5466-B6F1-179DCA91B97E}" dt="2026-10-04T03:55:29.445" v="2372" actId="14100"/>
           <ac:grpSpMkLst>
             <pc:docMk/>
             <pc:sldMk cId="2254363796" sldId="256"/>
@@ -208,21 +520,125 @@
           </ac:grpSpMkLst>
         </pc:grpChg>
         <pc:grpChg chg="add mod">
-          <ac:chgData name="Muyuan Li" userId="02573e01-306c-4233-b7d3-57f5fe21f9bc" providerId="ADAL" clId="{CAA0BD58-D522-5466-B6F1-179DCA91B97E}" dt="2026-10-04T00:23:47.042" v="147" actId="1076"/>
+          <ac:chgData name="Muyuan Li" userId="02573e01-306c-4233-b7d3-57f5fe21f9bc" providerId="ADAL" clId="{CAA0BD58-D522-5466-B6F1-179DCA91B97E}" dt="2026-10-04T03:55:25.878" v="2371" actId="1076"/>
           <ac:grpSpMkLst>
             <pc:docMk/>
             <pc:sldMk cId="2254363796" sldId="256"/>
             <ac:grpSpMk id="17" creationId="{93DA8051-0E05-BA93-8433-36AF49ABD2BA}"/>
           </ac:grpSpMkLst>
         </pc:grpChg>
-        <pc:graphicFrameChg chg="mod">
-          <ac:chgData name="Muyuan Li" userId="02573e01-306c-4233-b7d3-57f5fe21f9bc" providerId="ADAL" clId="{CAA0BD58-D522-5466-B6F1-179DCA91B97E}" dt="2026-10-04T00:23:25.021" v="134" actId="113"/>
+        <pc:grpChg chg="add del mod">
+          <ac:chgData name="Muyuan Li" userId="02573e01-306c-4233-b7d3-57f5fe21f9bc" providerId="ADAL" clId="{CAA0BD58-D522-5466-B6F1-179DCA91B97E}" dt="2026-10-04T02:15:32.758" v="255" actId="478"/>
+          <ac:grpSpMkLst>
+            <pc:docMk/>
+            <pc:sldMk cId="2254363796" sldId="256"/>
+            <ac:grpSpMk id="22" creationId="{636A2BCC-16C7-D31B-6703-5CD8A0A29533}"/>
+          </ac:grpSpMkLst>
+        </pc:grpChg>
+        <pc:grpChg chg="add mod">
+          <ac:chgData name="Muyuan Li" userId="02573e01-306c-4233-b7d3-57f5fe21f9bc" providerId="ADAL" clId="{CAA0BD58-D522-5466-B6F1-179DCA91B97E}" dt="2026-10-04T02:14:54.083" v="231"/>
+          <ac:grpSpMkLst>
+            <pc:docMk/>
+            <pc:sldMk cId="2254363796" sldId="256"/>
+            <ac:grpSpMk id="25" creationId="{897069DB-31BB-EE5E-34F3-BA1E3D52A871}"/>
+          </ac:grpSpMkLst>
+        </pc:grpChg>
+        <pc:grpChg chg="add del mod">
+          <ac:chgData name="Muyuan Li" userId="02573e01-306c-4233-b7d3-57f5fe21f9bc" providerId="ADAL" clId="{CAA0BD58-D522-5466-B6F1-179DCA91B97E}" dt="2026-10-04T02:15:27.119" v="251" actId="478"/>
+          <ac:grpSpMkLst>
+            <pc:docMk/>
+            <pc:sldMk cId="2254363796" sldId="256"/>
+            <ac:grpSpMk id="28" creationId="{15F41E5B-0A1F-54B4-1F56-2E9DFE83802C}"/>
+          </ac:grpSpMkLst>
+        </pc:grpChg>
+        <pc:grpChg chg="add del mod">
+          <ac:chgData name="Muyuan Li" userId="02573e01-306c-4233-b7d3-57f5fe21f9bc" providerId="ADAL" clId="{CAA0BD58-D522-5466-B6F1-179DCA91B97E}" dt="2026-10-04T02:26:26.416" v="644" actId="478"/>
+          <ac:grpSpMkLst>
+            <pc:docMk/>
+            <pc:sldMk cId="2254363796" sldId="256"/>
+            <ac:grpSpMk id="36" creationId="{24F943B0-8942-423D-BEE8-E958CE5B1AFB}"/>
+          </ac:grpSpMkLst>
+        </pc:grpChg>
+        <pc:grpChg chg="add mod">
+          <ac:chgData name="Muyuan Li" userId="02573e01-306c-4233-b7d3-57f5fe21f9bc" providerId="ADAL" clId="{CAA0BD58-D522-5466-B6F1-179DCA91B97E}" dt="2026-10-04T03:57:55.566" v="2460" actId="1076"/>
+          <ac:grpSpMkLst>
+            <pc:docMk/>
+            <pc:sldMk cId="2254363796" sldId="256"/>
+            <ac:grpSpMk id="41" creationId="{2E638973-A36C-7D09-C2A1-9CA434F208C5}"/>
+          </ac:grpSpMkLst>
+        </pc:grpChg>
+        <pc:grpChg chg="add del mod">
+          <ac:chgData name="Muyuan Li" userId="02573e01-306c-4233-b7d3-57f5fe21f9bc" providerId="ADAL" clId="{CAA0BD58-D522-5466-B6F1-179DCA91B97E}" dt="2026-10-04T02:44:08.237" v="1166" actId="478"/>
+          <ac:grpSpMkLst>
+            <pc:docMk/>
+            <pc:sldMk cId="2254363796" sldId="256"/>
+            <ac:grpSpMk id="44" creationId="{F0FFF01A-1EE7-DEB5-EAD9-272FA4DBA1D3}"/>
+          </ac:grpSpMkLst>
+        </pc:grpChg>
+        <pc:grpChg chg="add mod">
+          <ac:chgData name="Muyuan Li" userId="02573e01-306c-4233-b7d3-57f5fe21f9bc" providerId="ADAL" clId="{CAA0BD58-D522-5466-B6F1-179DCA91B97E}" dt="2026-10-04T02:44:56.093" v="1180"/>
+          <ac:grpSpMkLst>
+            <pc:docMk/>
+            <pc:sldMk cId="2254363796" sldId="256"/>
+            <ac:grpSpMk id="47" creationId="{5A7DEDC3-1760-9B63-A044-66A0EC4FAFEB}"/>
+          </ac:grpSpMkLst>
+        </pc:grpChg>
+        <pc:grpChg chg="add mod">
+          <ac:chgData name="Muyuan Li" userId="02573e01-306c-4233-b7d3-57f5fe21f9bc" providerId="ADAL" clId="{CAA0BD58-D522-5466-B6F1-179DCA91B97E}" dt="2026-10-04T02:58:10.794" v="1583" actId="1037"/>
+          <ac:grpSpMkLst>
+            <pc:docMk/>
+            <pc:sldMk cId="2254363796" sldId="256"/>
+            <ac:grpSpMk id="51" creationId="{EADF9F0D-E6D6-5B05-A0A6-9C2113F948C8}"/>
+          </ac:grpSpMkLst>
+        </pc:grpChg>
+        <pc:grpChg chg="add mod">
+          <ac:chgData name="Muyuan Li" userId="02573e01-306c-4233-b7d3-57f5fe21f9bc" providerId="ADAL" clId="{CAA0BD58-D522-5466-B6F1-179DCA91B97E}" dt="2026-10-04T03:21:07.386" v="1978" actId="14100"/>
+          <ac:grpSpMkLst>
+            <pc:docMk/>
+            <pc:sldMk cId="2254363796" sldId="256"/>
+            <ac:grpSpMk id="54" creationId="{CC4539D4-1BB6-6956-8A8A-27F6876F8BD3}"/>
+          </ac:grpSpMkLst>
+        </pc:grpChg>
+        <pc:graphicFrameChg chg="mod modGraphic">
+          <ac:chgData name="Muyuan Li" userId="02573e01-306c-4233-b7d3-57f5fe21f9bc" providerId="ADAL" clId="{CAA0BD58-D522-5466-B6F1-179DCA91B97E}" dt="2026-10-04T03:44:03.902" v="2261" actId="403"/>
           <ac:graphicFrameMkLst>
             <pc:docMk/>
             <pc:sldMk cId="2254363796" sldId="256"/>
             <ac:graphicFrameMk id="6" creationId="{225449A6-BB6E-AD3F-E4B5-3496FB17820F}"/>
           </ac:graphicFrameMkLst>
         </pc:graphicFrameChg>
+        <pc:picChg chg="add mod">
+          <ac:chgData name="Muyuan Li" userId="02573e01-306c-4233-b7d3-57f5fe21f9bc" providerId="ADAL" clId="{CAA0BD58-D522-5466-B6F1-179DCA91B97E}" dt="2026-10-04T03:58:25.797" v="2467" actId="1076"/>
+          <ac:picMkLst>
+            <pc:docMk/>
+            <pc:sldMk cId="2254363796" sldId="256"/>
+            <ac:picMk id="20" creationId="{387C9C44-345E-5BB8-2CD6-28A9093AB0A0}"/>
+          </ac:picMkLst>
+        </pc:picChg>
+        <pc:picChg chg="add del mod">
+          <ac:chgData name="Muyuan Li" userId="02573e01-306c-4233-b7d3-57f5fe21f9bc" providerId="ADAL" clId="{CAA0BD58-D522-5466-B6F1-179DCA91B97E}" dt="2026-10-04T03:51:46.883" v="2356" actId="478"/>
+          <ac:picMkLst>
+            <pc:docMk/>
+            <pc:sldMk cId="2254363796" sldId="256"/>
+            <ac:picMk id="67" creationId="{F7893310-672A-DE5A-03A6-729F7F5C5749}"/>
+          </ac:picMkLst>
+        </pc:picChg>
+        <pc:picChg chg="add del mod">
+          <ac:chgData name="Muyuan Li" userId="02573e01-306c-4233-b7d3-57f5fe21f9bc" providerId="ADAL" clId="{CAA0BD58-D522-5466-B6F1-179DCA91B97E}" dt="2026-10-04T03:51:49.188" v="2357" actId="478"/>
+          <ac:picMkLst>
+            <pc:docMk/>
+            <pc:sldMk cId="2254363796" sldId="256"/>
+            <ac:picMk id="69" creationId="{C68CB05F-27BF-FF5B-4985-C3FFCEFB4575}"/>
+          </ac:picMkLst>
+        </pc:picChg>
+        <pc:picChg chg="add mod modCrop">
+          <ac:chgData name="Muyuan Li" userId="02573e01-306c-4233-b7d3-57f5fe21f9bc" providerId="ADAL" clId="{CAA0BD58-D522-5466-B6F1-179DCA91B97E}" dt="2026-10-04T03:55:17.012" v="2370" actId="1076"/>
+          <ac:picMkLst>
+            <pc:docMk/>
+            <pc:sldMk cId="2254363796" sldId="256"/>
+            <ac:picMk id="70" creationId="{C5F96D71-DCD3-CB0E-AE44-430191729F31}"/>
+          </ac:picMkLst>
+        </pc:picChg>
       </pc:sldChg>
     </pc:docChg>
   </pc:docChgLst>
@@ -1026,31 +1442,43 @@
       </dgm:t>
     </dgm:pt>
     <dgm:pt modelId="{2318B206-D751-A042-A4AA-C7F496612EE1}">
-      <dgm:prSet phldrT="[Text]"/>
+      <dgm:prSet phldrT="[Text]" custT="1"/>
       <dgm:spPr/>
       <dgm:t>
         <a:bodyPr/>
         <a:lstStyle/>
         <a:p>
           <a:r>
-            <a:rPr lang="en-US" b="1" dirty="0"/>
+            <a:rPr lang="en-US" sz="1600" b="1" dirty="0">
+              <a:latin typeface="Times New Roman" panose="02020603050405020304" pitchFamily="18" charset="0"/>
+              <a:cs typeface="Times New Roman" panose="02020603050405020304" pitchFamily="18" charset="0"/>
+            </a:rPr>
             <a:t>Raw data set</a:t>
           </a:r>
           <a:r>
-            <a:rPr lang="en-US" dirty="0"/>
+            <a:rPr lang="en-US" sz="1600" dirty="0">
+              <a:latin typeface="Times New Roman" panose="02020603050405020304" pitchFamily="18" charset="0"/>
+              <a:cs typeface="Times New Roman" panose="02020603050405020304" pitchFamily="18" charset="0"/>
+            </a:rPr>
             <a:t>: </a:t>
           </a:r>
         </a:p>
         <a:p>
           <a:r>
-            <a:rPr lang="en-US" b="1" dirty="0"/>
+            <a:rPr lang="en-US" sz="1600" b="1" dirty="0">
+              <a:latin typeface="Times New Roman" panose="02020603050405020304" pitchFamily="18" charset="0"/>
+              <a:cs typeface="Times New Roman" panose="02020603050405020304" pitchFamily="18" charset="0"/>
+            </a:rPr>
             <a:t>9087 cows</a:t>
           </a:r>
         </a:p>
         <a:p>
           <a:r>
-            <a:rPr lang="en-US" dirty="0"/>
-            <a:t>~8.5 M records</a:t>
+            <a:rPr lang="en-US" sz="1600" dirty="0">
+              <a:latin typeface="Times New Roman" panose="02020603050405020304" pitchFamily="18" charset="0"/>
+              <a:cs typeface="Times New Roman" panose="02020603050405020304" pitchFamily="18" charset="0"/>
+            </a:rPr>
+            <a:t>~ 8.5 M records</a:t>
           </a:r>
         </a:p>
       </dgm:t>
@@ -1062,7 +1490,10 @@
         <a:bodyPr/>
         <a:lstStyle/>
         <a:p>
-          <a:endParaRPr lang="en-US"/>
+          <a:endParaRPr lang="en-US">
+            <a:latin typeface="Times New Roman" panose="02020603050405020304" pitchFamily="18" charset="0"/>
+            <a:cs typeface="Times New Roman" panose="02020603050405020304" pitchFamily="18" charset="0"/>
+          </a:endParaRPr>
         </a:p>
       </dgm:t>
     </dgm:pt>
@@ -1073,18 +1504,36 @@
         <a:bodyPr/>
         <a:lstStyle/>
         <a:p>
-          <a:endParaRPr lang="en-US"/>
+          <a:endParaRPr lang="en-US">
+            <a:latin typeface="Times New Roman" panose="02020603050405020304" pitchFamily="18" charset="0"/>
+            <a:cs typeface="Times New Roman" panose="02020603050405020304" pitchFamily="18" charset="0"/>
+          </a:endParaRPr>
         </a:p>
       </dgm:t>
     </dgm:pt>
     <dgm:pt modelId="{2297DCA0-C834-1D4A-AEBD-CBACB04AD8AA}">
-      <dgm:prSet phldrT="[Text]" phldr="1"/>
+      <dgm:prSet phldrT="[Text]" custT="1"/>
       <dgm:spPr/>
       <dgm:t>
         <a:bodyPr/>
         <a:lstStyle/>
         <a:p>
-          <a:endParaRPr lang="en-US"/>
+          <a:r>
+            <a:rPr lang="en-US" sz="1600" b="1" dirty="0">
+              <a:latin typeface="Times New Roman" panose="02020603050405020304" pitchFamily="18" charset="0"/>
+              <a:cs typeface="Times New Roman" panose="02020603050405020304" pitchFamily="18" charset="0"/>
+            </a:rPr>
+            <a:t>9087 cows</a:t>
+          </a:r>
+        </a:p>
+        <a:p>
+          <a:r>
+            <a:rPr lang="en-US" sz="1600" dirty="0">
+              <a:latin typeface="Times New Roman" panose="02020603050405020304" pitchFamily="18" charset="0"/>
+              <a:cs typeface="Times New Roman" panose="02020603050405020304" pitchFamily="18" charset="0"/>
+            </a:rPr>
+            <a:t>~ 6.8 M records</a:t>
+          </a:r>
         </a:p>
       </dgm:t>
     </dgm:pt>
@@ -1095,7 +1544,10 @@
         <a:bodyPr/>
         <a:lstStyle/>
         <a:p>
-          <a:endParaRPr lang="en-US"/>
+          <a:endParaRPr lang="en-US">
+            <a:latin typeface="Times New Roman" panose="02020603050405020304" pitchFamily="18" charset="0"/>
+            <a:cs typeface="Times New Roman" panose="02020603050405020304" pitchFamily="18" charset="0"/>
+          </a:endParaRPr>
         </a:p>
       </dgm:t>
     </dgm:pt>
@@ -1106,18 +1558,36 @@
         <a:bodyPr/>
         <a:lstStyle/>
         <a:p>
-          <a:endParaRPr lang="en-US"/>
+          <a:endParaRPr lang="en-US">
+            <a:latin typeface="Times New Roman" panose="02020603050405020304" pitchFamily="18" charset="0"/>
+            <a:cs typeface="Times New Roman" panose="02020603050405020304" pitchFamily="18" charset="0"/>
+          </a:endParaRPr>
         </a:p>
       </dgm:t>
     </dgm:pt>
     <dgm:pt modelId="{603E90E9-E711-AC4A-B075-54E168063216}">
-      <dgm:prSet phldrT="[Text]" phldr="1"/>
+      <dgm:prSet phldrT="[Text]" custT="1"/>
       <dgm:spPr/>
       <dgm:t>
         <a:bodyPr/>
         <a:lstStyle/>
         <a:p>
-          <a:endParaRPr lang="en-US"/>
+          <a:r>
+            <a:rPr lang="en-US" sz="1600" b="1" dirty="0">
+              <a:latin typeface="Times New Roman" panose="02020603050405020304" pitchFamily="18" charset="0"/>
+              <a:cs typeface="Times New Roman" panose="02020603050405020304" pitchFamily="18" charset="0"/>
+            </a:rPr>
+            <a:t>9011 cows</a:t>
+          </a:r>
+        </a:p>
+        <a:p>
+          <a:r>
+            <a:rPr lang="en-US" sz="1600" dirty="0">
+              <a:latin typeface="Times New Roman" panose="02020603050405020304" pitchFamily="18" charset="0"/>
+              <a:cs typeface="Times New Roman" panose="02020603050405020304" pitchFamily="18" charset="0"/>
+            </a:rPr>
+            <a:t>~ 6 M records</a:t>
+          </a:r>
         </a:p>
       </dgm:t>
     </dgm:pt>
@@ -1128,7 +1598,10 @@
         <a:bodyPr/>
         <a:lstStyle/>
         <a:p>
-          <a:endParaRPr lang="en-US"/>
+          <a:endParaRPr lang="en-US">
+            <a:latin typeface="Times New Roman" panose="02020603050405020304" pitchFamily="18" charset="0"/>
+            <a:cs typeface="Times New Roman" panose="02020603050405020304" pitchFamily="18" charset="0"/>
+          </a:endParaRPr>
         </a:p>
       </dgm:t>
     </dgm:pt>
@@ -1139,18 +1612,36 @@
         <a:bodyPr/>
         <a:lstStyle/>
         <a:p>
-          <a:endParaRPr lang="en-US"/>
+          <a:endParaRPr lang="en-US">
+            <a:latin typeface="Times New Roman" panose="02020603050405020304" pitchFamily="18" charset="0"/>
+            <a:cs typeface="Times New Roman" panose="02020603050405020304" pitchFamily="18" charset="0"/>
+          </a:endParaRPr>
         </a:p>
       </dgm:t>
     </dgm:pt>
     <dgm:pt modelId="{026F7429-D30E-654F-B84B-6C8987734135}">
-      <dgm:prSet phldrT="[Text]" phldr="1"/>
+      <dgm:prSet phldrT="[Text]" custT="1"/>
       <dgm:spPr/>
       <dgm:t>
         <a:bodyPr/>
         <a:lstStyle/>
         <a:p>
-          <a:endParaRPr lang="en-US"/>
+          <a:r>
+            <a:rPr lang="en-US" sz="1400" b="1" dirty="0">
+              <a:latin typeface="Times New Roman" panose="02020603050405020304" pitchFamily="18" charset="0"/>
+              <a:cs typeface="Times New Roman" panose="02020603050405020304" pitchFamily="18" charset="0"/>
+            </a:rPr>
+            <a:t>450 cows</a:t>
+          </a:r>
+        </a:p>
+        <a:p>
+          <a:r>
+            <a:rPr lang="en-US" sz="1400" dirty="0">
+              <a:latin typeface="Times New Roman" panose="02020603050405020304" pitchFamily="18" charset="0"/>
+              <a:cs typeface="Times New Roman" panose="02020603050405020304" pitchFamily="18" charset="0"/>
+            </a:rPr>
+            <a:t>~ 0.31 M records</a:t>
+          </a:r>
         </a:p>
       </dgm:t>
     </dgm:pt>
@@ -1161,7 +1652,10 @@
         <a:bodyPr/>
         <a:lstStyle/>
         <a:p>
-          <a:endParaRPr lang="en-US"/>
+          <a:endParaRPr lang="en-US">
+            <a:latin typeface="Times New Roman" panose="02020603050405020304" pitchFamily="18" charset="0"/>
+            <a:cs typeface="Times New Roman" panose="02020603050405020304" pitchFamily="18" charset="0"/>
+          </a:endParaRPr>
         </a:p>
       </dgm:t>
     </dgm:pt>
@@ -1172,18 +1666,36 @@
         <a:bodyPr/>
         <a:lstStyle/>
         <a:p>
-          <a:endParaRPr lang="en-US"/>
+          <a:endParaRPr lang="en-US">
+            <a:latin typeface="Times New Roman" panose="02020603050405020304" pitchFamily="18" charset="0"/>
+            <a:cs typeface="Times New Roman" panose="02020603050405020304" pitchFamily="18" charset="0"/>
+          </a:endParaRPr>
         </a:p>
       </dgm:t>
     </dgm:pt>
     <dgm:pt modelId="{678827E7-7104-3C47-9553-693041A90286}">
-      <dgm:prSet phldrT="[Text]" phldr="1"/>
+      <dgm:prSet phldrT="[Text]" custT="1"/>
       <dgm:spPr/>
       <dgm:t>
         <a:bodyPr/>
         <a:lstStyle/>
         <a:p>
-          <a:endParaRPr lang="en-US"/>
+          <a:r>
+            <a:rPr lang="en-US" sz="1200" b="1" dirty="0">
+              <a:latin typeface="Times New Roman" panose="02020603050405020304" pitchFamily="18" charset="0"/>
+              <a:cs typeface="Times New Roman" panose="02020603050405020304" pitchFamily="18" charset="0"/>
+            </a:rPr>
+            <a:t>448 cows</a:t>
+          </a:r>
+        </a:p>
+        <a:p>
+          <a:r>
+            <a:rPr lang="en-US" sz="1200" dirty="0">
+              <a:latin typeface="Times New Roman" panose="02020603050405020304" pitchFamily="18" charset="0"/>
+              <a:cs typeface="Times New Roman" panose="02020603050405020304" pitchFamily="18" charset="0"/>
+            </a:rPr>
+            <a:t>~ 0.31 M records</a:t>
+          </a:r>
         </a:p>
       </dgm:t>
     </dgm:pt>
@@ -1194,7 +1706,10 @@
         <a:bodyPr/>
         <a:lstStyle/>
         <a:p>
-          <a:endParaRPr lang="en-US"/>
+          <a:endParaRPr lang="en-US">
+            <a:latin typeface="Times New Roman" panose="02020603050405020304" pitchFamily="18" charset="0"/>
+            <a:cs typeface="Times New Roman" panose="02020603050405020304" pitchFamily="18" charset="0"/>
+          </a:endParaRPr>
         </a:p>
       </dgm:t>
     </dgm:pt>
@@ -1205,18 +1720,45 @@
         <a:bodyPr/>
         <a:lstStyle/>
         <a:p>
-          <a:endParaRPr lang="en-US"/>
+          <a:endParaRPr lang="en-US">
+            <a:latin typeface="Times New Roman" panose="02020603050405020304" pitchFamily="18" charset="0"/>
+            <a:cs typeface="Times New Roman" panose="02020603050405020304" pitchFamily="18" charset="0"/>
+          </a:endParaRPr>
         </a:p>
       </dgm:t>
     </dgm:pt>
     <dgm:pt modelId="{8FEF1A5C-0ACE-3849-9D96-E14CE662C40A}">
-      <dgm:prSet phldrT="[Text]" phldr="1"/>
+      <dgm:prSet phldrT="[Text]" custT="1"/>
       <dgm:spPr/>
       <dgm:t>
         <a:bodyPr/>
         <a:lstStyle/>
         <a:p>
-          <a:endParaRPr lang="en-US"/>
+          <a:r>
+            <a:rPr lang="en-US" sz="1200" b="1" dirty="0">
+              <a:latin typeface="Times New Roman" panose="02020603050405020304" pitchFamily="18" charset="0"/>
+              <a:cs typeface="Times New Roman" panose="02020603050405020304" pitchFamily="18" charset="0"/>
+            </a:rPr>
+            <a:t>Train set</a:t>
+          </a:r>
+        </a:p>
+        <a:p>
+          <a:r>
+            <a:rPr lang="en-US" sz="1200" b="1" dirty="0">
+              <a:latin typeface="Times New Roman" panose="02020603050405020304" pitchFamily="18" charset="0"/>
+              <a:cs typeface="Times New Roman" panose="02020603050405020304" pitchFamily="18" charset="0"/>
+            </a:rPr>
+            <a:t>448 cows</a:t>
+          </a:r>
+        </a:p>
+        <a:p>
+          <a:r>
+            <a:rPr lang="en-US" sz="1200" dirty="0">
+              <a:latin typeface="Times New Roman" panose="02020603050405020304" pitchFamily="18" charset="0"/>
+              <a:cs typeface="Times New Roman" panose="02020603050405020304" pitchFamily="18" charset="0"/>
+            </a:rPr>
+            <a:t>~ 0.25 M records (80%; same cows older records)</a:t>
+          </a:r>
         </a:p>
       </dgm:t>
     </dgm:pt>
@@ -1227,7 +1769,10 @@
         <a:bodyPr/>
         <a:lstStyle/>
         <a:p>
-          <a:endParaRPr lang="en-US"/>
+          <a:endParaRPr lang="en-US">
+            <a:latin typeface="Times New Roman" panose="02020603050405020304" pitchFamily="18" charset="0"/>
+            <a:cs typeface="Times New Roman" panose="02020603050405020304" pitchFamily="18" charset="0"/>
+          </a:endParaRPr>
         </a:p>
       </dgm:t>
     </dgm:pt>
@@ -1238,18 +1783,27 @@
         <a:bodyPr/>
         <a:lstStyle/>
         <a:p>
-          <a:endParaRPr lang="en-US"/>
+          <a:endParaRPr lang="en-US">
+            <a:latin typeface="Times New Roman" panose="02020603050405020304" pitchFamily="18" charset="0"/>
+            <a:cs typeface="Times New Roman" panose="02020603050405020304" pitchFamily="18" charset="0"/>
+          </a:endParaRPr>
         </a:p>
       </dgm:t>
     </dgm:pt>
     <dgm:pt modelId="{D3DCC99D-1062-2E48-9E3F-A640EAC95511}">
-      <dgm:prSet phldrT="[Text]" phldr="1"/>
+      <dgm:prSet phldrT="[Text]" custT="1"/>
       <dgm:spPr/>
       <dgm:t>
         <a:bodyPr/>
         <a:lstStyle/>
         <a:p>
-          <a:endParaRPr lang="en-US"/>
+          <a:r>
+            <a:rPr lang="en-US" sz="1200" b="1" dirty="0">
+              <a:latin typeface="Times New Roman" panose="02020603050405020304" pitchFamily="18" charset="0"/>
+              <a:cs typeface="Times New Roman" panose="02020603050405020304" pitchFamily="18" charset="0"/>
+            </a:rPr>
+            <a:t>Feature engineering – randomized search</a:t>
+          </a:r>
         </a:p>
       </dgm:t>
     </dgm:pt>
@@ -1260,7 +1814,10 @@
         <a:bodyPr/>
         <a:lstStyle/>
         <a:p>
-          <a:endParaRPr lang="en-US"/>
+          <a:endParaRPr lang="en-US">
+            <a:latin typeface="Times New Roman" panose="02020603050405020304" pitchFamily="18" charset="0"/>
+            <a:cs typeface="Times New Roman" panose="02020603050405020304" pitchFamily="18" charset="0"/>
+          </a:endParaRPr>
         </a:p>
       </dgm:t>
     </dgm:pt>
@@ -1271,7 +1828,10 @@
         <a:bodyPr/>
         <a:lstStyle/>
         <a:p>
-          <a:endParaRPr lang="en-US"/>
+          <a:endParaRPr lang="en-US">
+            <a:latin typeface="Times New Roman" panose="02020603050405020304" pitchFamily="18" charset="0"/>
+            <a:cs typeface="Times New Roman" panose="02020603050405020304" pitchFamily="18" charset="0"/>
+          </a:endParaRPr>
         </a:p>
       </dgm:t>
     </dgm:pt>
@@ -1292,7 +1852,7 @@
       <dgm:spPr/>
     </dgm:pt>
     <dgm:pt modelId="{2F389860-34B6-D647-9527-94DE13E6CDEE}" type="pres">
-      <dgm:prSet presAssocID="{9327581E-E333-9740-80AF-8F7684358E7A}" presName="sibTrans" presStyleLbl="sibTrans2D1" presStyleIdx="0" presStyleCnt="6"/>
+      <dgm:prSet presAssocID="{9327581E-E333-9740-80AF-8F7684358E7A}" presName="sibTrans" presStyleLbl="sibTrans2D1" presStyleIdx="0" presStyleCnt="6" custScaleX="125063"/>
       <dgm:spPr/>
     </dgm:pt>
     <dgm:pt modelId="{129F80BE-FFE7-CB4F-9389-7A870E9ECA93}" type="pres">
@@ -1300,7 +1860,7 @@
       <dgm:spPr/>
     </dgm:pt>
     <dgm:pt modelId="{F1DCF891-B3F9-924B-A427-97798FBECA9C}" type="pres">
-      <dgm:prSet presAssocID="{2297DCA0-C834-1D4A-AEBD-CBACB04AD8AA}" presName="node" presStyleLbl="node1" presStyleIdx="1" presStyleCnt="7">
+      <dgm:prSet presAssocID="{2297DCA0-C834-1D4A-AEBD-CBACB04AD8AA}" presName="node" presStyleLbl="node1" presStyleIdx="1" presStyleCnt="7" custScaleY="66766">
         <dgm:presLayoutVars>
           <dgm:bulletEnabled val="1"/>
         </dgm:presLayoutVars>
@@ -1308,7 +1868,7 @@
       <dgm:spPr/>
     </dgm:pt>
     <dgm:pt modelId="{5A392C4F-0F82-2042-A3B8-98E0ADC70004}" type="pres">
-      <dgm:prSet presAssocID="{5F504CD8-473B-024B-BFB0-B102F4EF3647}" presName="sibTrans" presStyleLbl="sibTrans2D1" presStyleIdx="1" presStyleCnt="6"/>
+      <dgm:prSet presAssocID="{5F504CD8-473B-024B-BFB0-B102F4EF3647}" presName="sibTrans" presStyleLbl="sibTrans2D1" presStyleIdx="1" presStyleCnt="6" custScaleX="124464"/>
       <dgm:spPr/>
     </dgm:pt>
     <dgm:pt modelId="{D897E4CD-D17C-A249-87A7-F0BD16D3EB8A}" type="pres">
@@ -1316,7 +1876,7 @@
       <dgm:spPr/>
     </dgm:pt>
     <dgm:pt modelId="{7128D90E-EA1C-5A49-A5CB-358F0F56600D}" type="pres">
-      <dgm:prSet presAssocID="{603E90E9-E711-AC4A-B075-54E168063216}" presName="node" presStyleLbl="node1" presStyleIdx="2" presStyleCnt="7">
+      <dgm:prSet presAssocID="{603E90E9-E711-AC4A-B075-54E168063216}" presName="node" presStyleLbl="node1" presStyleIdx="2" presStyleCnt="7" custScaleY="63061">
         <dgm:presLayoutVars>
           <dgm:bulletEnabled val="1"/>
         </dgm:presLayoutVars>
@@ -1332,7 +1892,7 @@
       <dgm:spPr/>
     </dgm:pt>
     <dgm:pt modelId="{9F524941-7A89-6D4D-A311-EA8C15B7B605}" type="pres">
-      <dgm:prSet presAssocID="{026F7429-D30E-654F-B84B-6C8987734135}" presName="node" presStyleLbl="node1" presStyleIdx="3" presStyleCnt="7">
+      <dgm:prSet presAssocID="{026F7429-D30E-654F-B84B-6C8987734135}" presName="node" presStyleLbl="node1" presStyleIdx="3" presStyleCnt="7" custScaleX="72979" custScaleY="67999">
         <dgm:presLayoutVars>
           <dgm:bulletEnabled val="1"/>
         </dgm:presLayoutVars>
@@ -1348,7 +1908,7 @@
       <dgm:spPr/>
     </dgm:pt>
     <dgm:pt modelId="{87784E64-F689-6E4F-9054-EDFCCC761DEC}" type="pres">
-      <dgm:prSet presAssocID="{678827E7-7104-3C47-9553-693041A90286}" presName="node" presStyleLbl="node1" presStyleIdx="4" presStyleCnt="7">
+      <dgm:prSet presAssocID="{678827E7-7104-3C47-9553-693041A90286}" presName="node" presStyleLbl="node1" presStyleIdx="4" presStyleCnt="7" custScaleX="72979" custScaleY="67999" custLinFactNeighborY="1631">
         <dgm:presLayoutVars>
           <dgm:bulletEnabled val="1"/>
         </dgm:presLayoutVars>
@@ -1356,7 +1916,7 @@
       <dgm:spPr/>
     </dgm:pt>
     <dgm:pt modelId="{60A5F579-8817-964E-BDCF-1F0522C69BD4}" type="pres">
-      <dgm:prSet presAssocID="{C56DF35B-B71D-CD4A-B6F6-15BBBE59878D}" presName="sibTrans" presStyleLbl="sibTrans2D1" presStyleIdx="4" presStyleCnt="6"/>
+      <dgm:prSet presAssocID="{C56DF35B-B71D-CD4A-B6F6-15BBBE59878D}" presName="sibTrans" presStyleLbl="sibTrans2D1" presStyleIdx="4" presStyleCnt="6" custScaleX="117058" custScaleY="52494" custLinFactNeighborX="2072" custLinFactNeighborY="4224"/>
       <dgm:spPr/>
     </dgm:pt>
     <dgm:pt modelId="{B76EC6C5-C83C-BB45-967A-BFFA480B8AD0}" type="pres">
@@ -1364,7 +1924,7 @@
       <dgm:spPr/>
     </dgm:pt>
     <dgm:pt modelId="{2B1B973E-ADE0-8C49-BFF4-FDB5967037DE}" type="pres">
-      <dgm:prSet presAssocID="{8FEF1A5C-0ACE-3849-9D96-E14CE662C40A}" presName="node" presStyleLbl="node1" presStyleIdx="5" presStyleCnt="7">
+      <dgm:prSet presAssocID="{8FEF1A5C-0ACE-3849-9D96-E14CE662C40A}" presName="node" presStyleLbl="node1" presStyleIdx="5" presStyleCnt="7" custScaleX="72979" custScaleY="77360" custLinFactNeighborY="26080">
         <dgm:presLayoutVars>
           <dgm:bulletEnabled val="1"/>
         </dgm:presLayoutVars>
@@ -1372,7 +1932,7 @@
       <dgm:spPr/>
     </dgm:pt>
     <dgm:pt modelId="{26677FBF-9A1B-634D-9BB1-A8FCD65A0E38}" type="pres">
-      <dgm:prSet presAssocID="{F29809D3-74A5-094B-9847-547C288E516D}" presName="sibTrans" presStyleLbl="sibTrans2D1" presStyleIdx="5" presStyleCnt="6"/>
+      <dgm:prSet presAssocID="{F29809D3-74A5-094B-9847-547C288E516D}" presName="sibTrans" presStyleLbl="sibTrans2D1" presStyleIdx="5" presStyleCnt="6" custScaleX="117273" custLinFactX="-20155" custLinFactNeighborX="-100000" custLinFactNeighborY="2495"/>
       <dgm:spPr/>
     </dgm:pt>
     <dgm:pt modelId="{33FE50B5-054B-3049-94F9-D6E39056EDA4}" type="pres">
@@ -1380,7 +1940,7 @@
       <dgm:spPr/>
     </dgm:pt>
     <dgm:pt modelId="{0BC5DB9D-6CA0-F744-B03B-293B7D6321C2}" type="pres">
-      <dgm:prSet presAssocID="{D3DCC99D-1062-2E48-9E3F-A640EAC95511}" presName="node" presStyleLbl="node1" presStyleIdx="6" presStyleCnt="7">
+      <dgm:prSet presAssocID="{D3DCC99D-1062-2E48-9E3F-A640EAC95511}" presName="node" presStyleLbl="node1" presStyleIdx="6" presStyleCnt="7" custScaleX="72979" custScaleY="67999">
         <dgm:presLayoutVars>
           <dgm:bulletEnabled val="1"/>
         </dgm:presLayoutVars>
@@ -1391,49 +1951,49 @@
   <dgm:cxnLst>
     <dgm:cxn modelId="{14CAE001-6BAD-4746-AE00-9C9478737573}" type="presOf" srcId="{D9E0DB29-B812-0340-977B-C186900F6F5F}" destId="{9832284A-FC4C-B54D-9A24-074AFD27F0C9}" srcOrd="0" destOrd="0" presId="urn:microsoft.com/office/officeart/2005/8/layout/process2"/>
     <dgm:cxn modelId="{3511B803-787D-DE4B-8E74-4A8E716AF7FB}" type="presOf" srcId="{8FEF1A5C-0ACE-3849-9D96-E14CE662C40A}" destId="{2B1B973E-ADE0-8C49-BFF4-FDB5967037DE}" srcOrd="0" destOrd="0" presId="urn:microsoft.com/office/officeart/2005/8/layout/process2"/>
+    <dgm:cxn modelId="{5C09B30D-EEA3-C34F-A5BB-C310EA89688E}" type="presOf" srcId="{C56DF35B-B71D-CD4A-B6F6-15BBBE59878D}" destId="{B76EC6C5-C83C-BB45-967A-BFFA480B8AD0}" srcOrd="1" destOrd="0" presId="urn:microsoft.com/office/officeart/2005/8/layout/process2"/>
     <dgm:cxn modelId="{3476F70E-BAC5-2E4C-A40A-15F69C906DC1}" type="presOf" srcId="{026F7429-D30E-654F-B84B-6C8987734135}" destId="{9F524941-7A89-6D4D-A311-EA8C15B7B605}" srcOrd="0" destOrd="0" presId="urn:microsoft.com/office/officeart/2005/8/layout/process2"/>
     <dgm:cxn modelId="{8F13A910-55D3-D74E-9E85-359DEA5ECFC1}" type="presOf" srcId="{603E90E9-E711-AC4A-B075-54E168063216}" destId="{7128D90E-EA1C-5A49-A5CB-358F0F56600D}" srcOrd="0" destOrd="0" presId="urn:microsoft.com/office/officeart/2005/8/layout/process2"/>
     <dgm:cxn modelId="{7CDA4C13-F692-3C4D-BB78-0FE561581CDA}" srcId="{9410D3BF-0532-3E46-AC64-E8AD39B46A71}" destId="{603E90E9-E711-AC4A-B075-54E168063216}" srcOrd="2" destOrd="0" parTransId="{5175BFE8-FA0B-DB42-BF26-C4D161516515}" sibTransId="{88D84755-2FCB-254A-B3EA-E4FBB34EE01A}"/>
     <dgm:cxn modelId="{622D0426-72D3-BA44-88CA-CDCD77BE0772}" srcId="{9410D3BF-0532-3E46-AC64-E8AD39B46A71}" destId="{2318B206-D751-A042-A4AA-C7F496612EE1}" srcOrd="0" destOrd="0" parTransId="{8AFA4FA8-E293-DE4E-A56E-172B2F46C9C9}" sibTransId="{9327581E-E333-9740-80AF-8F7684358E7A}"/>
+    <dgm:cxn modelId="{81E21628-3FEE-534F-A012-2E76AAD0AA34}" type="presOf" srcId="{F29809D3-74A5-094B-9847-547C288E516D}" destId="{33FE50B5-054B-3049-94F9-D6E39056EDA4}" srcOrd="1" destOrd="0" presId="urn:microsoft.com/office/officeart/2005/8/layout/process2"/>
     <dgm:cxn modelId="{D3493033-945C-304D-8B77-28CC1E2D8C3D}" type="presOf" srcId="{C56DF35B-B71D-CD4A-B6F6-15BBBE59878D}" destId="{60A5F579-8817-964E-BDCF-1F0522C69BD4}" srcOrd="0" destOrd="0" presId="urn:microsoft.com/office/officeart/2005/8/layout/process2"/>
-    <dgm:cxn modelId="{788E3A3D-07DF-994E-A9A0-880C43C9E492}" type="presOf" srcId="{F29809D3-74A5-094B-9847-547C288E516D}" destId="{33FE50B5-054B-3049-94F9-D6E39056EDA4}" srcOrd="1" destOrd="0" presId="urn:microsoft.com/office/officeart/2005/8/layout/process2"/>
     <dgm:cxn modelId="{70B4C149-EA9C-FE4D-8B01-C84F21A7F44B}" srcId="{9410D3BF-0532-3E46-AC64-E8AD39B46A71}" destId="{2297DCA0-C834-1D4A-AEBD-CBACB04AD8AA}" srcOrd="1" destOrd="0" parTransId="{777F7FEE-855E-964E-9A4F-AE77AB58C2F9}" sibTransId="{5F504CD8-473B-024B-BFB0-B102F4EF3647}"/>
+    <dgm:cxn modelId="{FD38D756-C4E5-7B4E-B12E-46DC9A429F8A}" type="presOf" srcId="{9327581E-E333-9740-80AF-8F7684358E7A}" destId="{129F80BE-FFE7-CB4F-9389-7A870E9ECA93}" srcOrd="1" destOrd="0" presId="urn:microsoft.com/office/officeart/2005/8/layout/process2"/>
     <dgm:cxn modelId="{599AB25C-650C-ED4F-80B8-A42A8A6E828A}" type="presOf" srcId="{9410D3BF-0532-3E46-AC64-E8AD39B46A71}" destId="{507105E2-007C-C649-AADB-179864AEA3CB}" srcOrd="0" destOrd="0" presId="urn:microsoft.com/office/officeart/2005/8/layout/process2"/>
     <dgm:cxn modelId="{A6450861-7A1F-A742-B452-7EE5AF47E0DB}" type="presOf" srcId="{9327581E-E333-9740-80AF-8F7684358E7A}" destId="{2F389860-34B6-D647-9527-94DE13E6CDEE}" srcOrd="0" destOrd="0" presId="urn:microsoft.com/office/officeart/2005/8/layout/process2"/>
-    <dgm:cxn modelId="{2C56B977-F309-9A41-AAB1-F3E3494EFF47}" type="presOf" srcId="{C56DF35B-B71D-CD4A-B6F6-15BBBE59878D}" destId="{B76EC6C5-C83C-BB45-967A-BFFA480B8AD0}" srcOrd="1" destOrd="0" presId="urn:microsoft.com/office/officeart/2005/8/layout/process2"/>
     <dgm:cxn modelId="{87ECAA7C-328B-AA44-9C77-F5A4779D1591}" type="presOf" srcId="{2297DCA0-C834-1D4A-AEBD-CBACB04AD8AA}" destId="{F1DCF891-B3F9-924B-A427-97798FBECA9C}" srcOrd="0" destOrd="0" presId="urn:microsoft.com/office/officeart/2005/8/layout/process2"/>
-    <dgm:cxn modelId="{7895597F-E691-0242-8E79-E64859AB81CF}" type="presOf" srcId="{D9E0DB29-B812-0340-977B-C186900F6F5F}" destId="{A1E24BD5-3137-6B4F-A564-1484F757CD2B}" srcOrd="1" destOrd="0" presId="urn:microsoft.com/office/officeart/2005/8/layout/process2"/>
     <dgm:cxn modelId="{BB39EF82-AA44-4C40-AAE6-72BDA6DB5E94}" srcId="{9410D3BF-0532-3E46-AC64-E8AD39B46A71}" destId="{678827E7-7104-3C47-9553-693041A90286}" srcOrd="4" destOrd="0" parTransId="{600F5CC7-081B-5847-8650-2484AC7D4A76}" sibTransId="{C56DF35B-B71D-CD4A-B6F6-15BBBE59878D}"/>
     <dgm:cxn modelId="{8BB45C95-F2B4-2E4C-A690-36472C2303B7}" type="presOf" srcId="{2318B206-D751-A042-A4AA-C7F496612EE1}" destId="{DB61925C-5AAD-584B-8B79-72E6E02ECE4C}" srcOrd="0" destOrd="0" presId="urn:microsoft.com/office/officeart/2005/8/layout/process2"/>
     <dgm:cxn modelId="{7B816B9D-25E4-B444-A51E-8B8F238A9370}" srcId="{9410D3BF-0532-3E46-AC64-E8AD39B46A71}" destId="{8FEF1A5C-0ACE-3849-9D96-E14CE662C40A}" srcOrd="5" destOrd="0" parTransId="{32734F6D-F338-5F4C-AE90-FFEDDCCDEF23}" sibTransId="{F29809D3-74A5-094B-9847-547C288E516D}"/>
     <dgm:cxn modelId="{1DDBBE9D-5D8C-CF4B-B6B0-BC4EA79D55F5}" type="presOf" srcId="{88D84755-2FCB-254A-B3EA-E4FBB34EE01A}" destId="{BAC1D5B0-1E4F-6C4D-8E53-3F1D1FD640C7}" srcOrd="0" destOrd="0" presId="urn:microsoft.com/office/officeart/2005/8/layout/process2"/>
+    <dgm:cxn modelId="{22F53AA7-DE20-2141-BDB2-063D1266A69B}" type="presOf" srcId="{D9E0DB29-B812-0340-977B-C186900F6F5F}" destId="{A1E24BD5-3137-6B4F-A564-1484F757CD2B}" srcOrd="1" destOrd="0" presId="urn:microsoft.com/office/officeart/2005/8/layout/process2"/>
     <dgm:cxn modelId="{16A898A9-0BAC-9044-80E2-1F1B29E962E5}" type="presOf" srcId="{5F504CD8-473B-024B-BFB0-B102F4EF3647}" destId="{5A392C4F-0F82-2042-A3B8-98E0ADC70004}" srcOrd="0" destOrd="0" presId="urn:microsoft.com/office/officeart/2005/8/layout/process2"/>
-    <dgm:cxn modelId="{9401FEAA-4D87-3A44-9084-356C976E183E}" type="presOf" srcId="{9327581E-E333-9740-80AF-8F7684358E7A}" destId="{129F80BE-FFE7-CB4F-9389-7A870E9ECA93}" srcOrd="1" destOrd="0" presId="urn:microsoft.com/office/officeart/2005/8/layout/process2"/>
     <dgm:cxn modelId="{313D48AB-5BDD-184F-9C5A-0EB4A4F458D5}" srcId="{9410D3BF-0532-3E46-AC64-E8AD39B46A71}" destId="{026F7429-D30E-654F-B84B-6C8987734135}" srcOrd="3" destOrd="0" parTransId="{B41FEBBF-B46E-1E4D-8973-DE1FE5A8A5BE}" sibTransId="{D9E0DB29-B812-0340-977B-C186900F6F5F}"/>
     <dgm:cxn modelId="{A3D947B4-40B4-D64D-AD27-A6CD1B13F4FA}" srcId="{9410D3BF-0532-3E46-AC64-E8AD39B46A71}" destId="{D3DCC99D-1062-2E48-9E3F-A640EAC95511}" srcOrd="6" destOrd="0" parTransId="{38C4E7C9-BFAB-2941-BD52-4A7C934D2EBE}" sibTransId="{03868540-C123-5945-86DA-50D288AFA5DA}"/>
-    <dgm:cxn modelId="{E1DDFECA-7B8B-C64F-8384-EACF5A0532E9}" type="presOf" srcId="{88D84755-2FCB-254A-B3EA-E4FBB34EE01A}" destId="{B0C5A956-C517-F641-B966-D00733391F6A}" srcOrd="1" destOrd="0" presId="urn:microsoft.com/office/officeart/2005/8/layout/process2"/>
     <dgm:cxn modelId="{C7B198CE-2317-3D4E-ACB6-C106E87F4755}" type="presOf" srcId="{678827E7-7104-3C47-9553-693041A90286}" destId="{87784E64-F689-6E4F-9054-EDFCCC761DEC}" srcOrd="0" destOrd="0" presId="urn:microsoft.com/office/officeart/2005/8/layout/process2"/>
+    <dgm:cxn modelId="{94A628D1-28E1-9A42-AAE6-1F132B521ACF}" type="presOf" srcId="{5F504CD8-473B-024B-BFB0-B102F4EF3647}" destId="{D897E4CD-D17C-A249-87A7-F0BD16D3EB8A}" srcOrd="1" destOrd="0" presId="urn:microsoft.com/office/officeart/2005/8/layout/process2"/>
     <dgm:cxn modelId="{184C93D4-C494-7145-9CC6-A8BE5AECCF9D}" type="presOf" srcId="{F29809D3-74A5-094B-9847-547C288E516D}" destId="{26677FBF-9A1B-634D-9BB1-A8FCD65A0E38}" srcOrd="0" destOrd="0" presId="urn:microsoft.com/office/officeart/2005/8/layout/process2"/>
-    <dgm:cxn modelId="{C7BFCAD9-0859-EA47-9592-BA8C2448FCF6}" type="presOf" srcId="{5F504CD8-473B-024B-BFB0-B102F4EF3647}" destId="{D897E4CD-D17C-A249-87A7-F0BD16D3EB8A}" srcOrd="1" destOrd="0" presId="urn:microsoft.com/office/officeart/2005/8/layout/process2"/>
     <dgm:cxn modelId="{2B3BD1E5-8E98-2E46-B2A8-2C4382BFF3C3}" type="presOf" srcId="{D3DCC99D-1062-2E48-9E3F-A640EAC95511}" destId="{0BC5DB9D-6CA0-F744-B03B-293B7D6321C2}" srcOrd="0" destOrd="0" presId="urn:microsoft.com/office/officeart/2005/8/layout/process2"/>
+    <dgm:cxn modelId="{00506CFB-B657-E244-8A71-9060ED893182}" type="presOf" srcId="{88D84755-2FCB-254A-B3EA-E4FBB34EE01A}" destId="{B0C5A956-C517-F641-B966-D00733391F6A}" srcOrd="1" destOrd="0" presId="urn:microsoft.com/office/officeart/2005/8/layout/process2"/>
     <dgm:cxn modelId="{548322BE-1310-A645-B0A8-55375294DFFC}" type="presParOf" srcId="{507105E2-007C-C649-AADB-179864AEA3CB}" destId="{DB61925C-5AAD-584B-8B79-72E6E02ECE4C}" srcOrd="0" destOrd="0" presId="urn:microsoft.com/office/officeart/2005/8/layout/process2"/>
     <dgm:cxn modelId="{DF715F42-2606-C447-9090-A69C5417C4E9}" type="presParOf" srcId="{507105E2-007C-C649-AADB-179864AEA3CB}" destId="{2F389860-34B6-D647-9527-94DE13E6CDEE}" srcOrd="1" destOrd="0" presId="urn:microsoft.com/office/officeart/2005/8/layout/process2"/>
-    <dgm:cxn modelId="{4302C397-7C58-7445-85DB-68B23DEE9D78}" type="presParOf" srcId="{2F389860-34B6-D647-9527-94DE13E6CDEE}" destId="{129F80BE-FFE7-CB4F-9389-7A870E9ECA93}" srcOrd="0" destOrd="0" presId="urn:microsoft.com/office/officeart/2005/8/layout/process2"/>
+    <dgm:cxn modelId="{C24F25AB-C890-CD4E-8EDE-807A527F0B75}" type="presParOf" srcId="{2F389860-34B6-D647-9527-94DE13E6CDEE}" destId="{129F80BE-FFE7-CB4F-9389-7A870E9ECA93}" srcOrd="0" destOrd="0" presId="urn:microsoft.com/office/officeart/2005/8/layout/process2"/>
     <dgm:cxn modelId="{977B5174-28FA-0A4D-B630-42E499C3A14A}" type="presParOf" srcId="{507105E2-007C-C649-AADB-179864AEA3CB}" destId="{F1DCF891-B3F9-924B-A427-97798FBECA9C}" srcOrd="2" destOrd="0" presId="urn:microsoft.com/office/officeart/2005/8/layout/process2"/>
     <dgm:cxn modelId="{C319B51B-48CD-AB45-B931-D77889EE26EA}" type="presParOf" srcId="{507105E2-007C-C649-AADB-179864AEA3CB}" destId="{5A392C4F-0F82-2042-A3B8-98E0ADC70004}" srcOrd="3" destOrd="0" presId="urn:microsoft.com/office/officeart/2005/8/layout/process2"/>
-    <dgm:cxn modelId="{9E27FEE8-66FE-9249-B4DF-C40347D8C940}" type="presParOf" srcId="{5A392C4F-0F82-2042-A3B8-98E0ADC70004}" destId="{D897E4CD-D17C-A249-87A7-F0BD16D3EB8A}" srcOrd="0" destOrd="0" presId="urn:microsoft.com/office/officeart/2005/8/layout/process2"/>
+    <dgm:cxn modelId="{385D4F56-272F-0A48-B99A-2213121B5384}" type="presParOf" srcId="{5A392C4F-0F82-2042-A3B8-98E0ADC70004}" destId="{D897E4CD-D17C-A249-87A7-F0BD16D3EB8A}" srcOrd="0" destOrd="0" presId="urn:microsoft.com/office/officeart/2005/8/layout/process2"/>
     <dgm:cxn modelId="{E37C18B5-A520-C04E-85AA-17C6D30F2AFA}" type="presParOf" srcId="{507105E2-007C-C649-AADB-179864AEA3CB}" destId="{7128D90E-EA1C-5A49-A5CB-358F0F56600D}" srcOrd="4" destOrd="0" presId="urn:microsoft.com/office/officeart/2005/8/layout/process2"/>
     <dgm:cxn modelId="{D6634B4C-A241-7047-A8D7-F17647C02916}" type="presParOf" srcId="{507105E2-007C-C649-AADB-179864AEA3CB}" destId="{BAC1D5B0-1E4F-6C4D-8E53-3F1D1FD640C7}" srcOrd="5" destOrd="0" presId="urn:microsoft.com/office/officeart/2005/8/layout/process2"/>
-    <dgm:cxn modelId="{C8CE3FBC-39CC-ED44-8F05-AD94ADD03BCD}" type="presParOf" srcId="{BAC1D5B0-1E4F-6C4D-8E53-3F1D1FD640C7}" destId="{B0C5A956-C517-F641-B966-D00733391F6A}" srcOrd="0" destOrd="0" presId="urn:microsoft.com/office/officeart/2005/8/layout/process2"/>
+    <dgm:cxn modelId="{7ABD41B9-4BC9-EA4A-8429-2C0C581ADBE9}" type="presParOf" srcId="{BAC1D5B0-1E4F-6C4D-8E53-3F1D1FD640C7}" destId="{B0C5A956-C517-F641-B966-D00733391F6A}" srcOrd="0" destOrd="0" presId="urn:microsoft.com/office/officeart/2005/8/layout/process2"/>
     <dgm:cxn modelId="{E8DBCF1C-659D-794C-A8AE-8735A57F7593}" type="presParOf" srcId="{507105E2-007C-C649-AADB-179864AEA3CB}" destId="{9F524941-7A89-6D4D-A311-EA8C15B7B605}" srcOrd="6" destOrd="0" presId="urn:microsoft.com/office/officeart/2005/8/layout/process2"/>
     <dgm:cxn modelId="{B97AE426-CC22-084A-9EC9-945A720EB16B}" type="presParOf" srcId="{507105E2-007C-C649-AADB-179864AEA3CB}" destId="{9832284A-FC4C-B54D-9A24-074AFD27F0C9}" srcOrd="7" destOrd="0" presId="urn:microsoft.com/office/officeart/2005/8/layout/process2"/>
-    <dgm:cxn modelId="{149EC195-F9B0-7E42-B2E5-D520E40C54F3}" type="presParOf" srcId="{9832284A-FC4C-B54D-9A24-074AFD27F0C9}" destId="{A1E24BD5-3137-6B4F-A564-1484F757CD2B}" srcOrd="0" destOrd="0" presId="urn:microsoft.com/office/officeart/2005/8/layout/process2"/>
+    <dgm:cxn modelId="{BAF33927-7DA6-B149-8841-74F581824C43}" type="presParOf" srcId="{9832284A-FC4C-B54D-9A24-074AFD27F0C9}" destId="{A1E24BD5-3137-6B4F-A564-1484F757CD2B}" srcOrd="0" destOrd="0" presId="urn:microsoft.com/office/officeart/2005/8/layout/process2"/>
     <dgm:cxn modelId="{5CACAFC3-E83C-214B-A5DD-AE5A6A83A610}" type="presParOf" srcId="{507105E2-007C-C649-AADB-179864AEA3CB}" destId="{87784E64-F689-6E4F-9054-EDFCCC761DEC}" srcOrd="8" destOrd="0" presId="urn:microsoft.com/office/officeart/2005/8/layout/process2"/>
     <dgm:cxn modelId="{258F9B7E-DDA4-7C47-AB37-6A8C2675ED4F}" type="presParOf" srcId="{507105E2-007C-C649-AADB-179864AEA3CB}" destId="{60A5F579-8817-964E-BDCF-1F0522C69BD4}" srcOrd="9" destOrd="0" presId="urn:microsoft.com/office/officeart/2005/8/layout/process2"/>
-    <dgm:cxn modelId="{1E039A80-E78E-9443-8014-B762A0611702}" type="presParOf" srcId="{60A5F579-8817-964E-BDCF-1F0522C69BD4}" destId="{B76EC6C5-C83C-BB45-967A-BFFA480B8AD0}" srcOrd="0" destOrd="0" presId="urn:microsoft.com/office/officeart/2005/8/layout/process2"/>
+    <dgm:cxn modelId="{0BAE6467-E716-1C4E-AB95-A9518DFA1256}" type="presParOf" srcId="{60A5F579-8817-964E-BDCF-1F0522C69BD4}" destId="{B76EC6C5-C83C-BB45-967A-BFFA480B8AD0}" srcOrd="0" destOrd="0" presId="urn:microsoft.com/office/officeart/2005/8/layout/process2"/>
     <dgm:cxn modelId="{50BF2B17-12D5-6D45-A08F-936791272B84}" type="presParOf" srcId="{507105E2-007C-C649-AADB-179864AEA3CB}" destId="{2B1B973E-ADE0-8C49-BFF4-FDB5967037DE}" srcOrd="10" destOrd="0" presId="urn:microsoft.com/office/officeart/2005/8/layout/process2"/>
     <dgm:cxn modelId="{08225119-1001-1041-99CB-8E13B66E3F24}" type="presParOf" srcId="{507105E2-007C-C649-AADB-179864AEA3CB}" destId="{26677FBF-9A1B-634D-9BB1-A8FCD65A0E38}" srcOrd="11" destOrd="0" presId="urn:microsoft.com/office/officeart/2005/8/layout/process2"/>
-    <dgm:cxn modelId="{77D3344B-9BB7-0843-8C49-32A6ADAD485A}" type="presParOf" srcId="{26677FBF-9A1B-634D-9BB1-A8FCD65A0E38}" destId="{33FE50B5-054B-3049-94F9-D6E39056EDA4}" srcOrd="0" destOrd="0" presId="urn:microsoft.com/office/officeart/2005/8/layout/process2"/>
+    <dgm:cxn modelId="{13ADC149-43B2-AA47-AD03-318708AE26DD}" type="presParOf" srcId="{26677FBF-9A1B-634D-9BB1-A8FCD65A0E38}" destId="{33FE50B5-054B-3049-94F9-D6E39056EDA4}" srcOrd="0" destOrd="0" presId="urn:microsoft.com/office/officeart/2005/8/layout/process2"/>
     <dgm:cxn modelId="{9D743ACF-75A6-754D-8205-A77865A6A8F6}" type="presParOf" srcId="{507105E2-007C-C649-AADB-179864AEA3CB}" destId="{0BC5DB9D-6CA0-F744-B03B-293B7D6321C2}" srcOrd="12" destOrd="0" presId="urn:microsoft.com/office/officeart/2005/8/layout/process2"/>
   </dgm:cxnLst>
   <dgm:bg/>
@@ -1464,8 +2024,8 @@
       </dsp:nvSpPr>
       <dsp:spPr>
         <a:xfrm>
-          <a:off x="636670" y="1075"/>
-          <a:ext cx="1585590" cy="880883"/>
+          <a:off x="276907" y="8659"/>
+          <a:ext cx="2305115" cy="1152631"/>
         </a:xfrm>
         <a:prstGeom prst="roundRect">
           <a:avLst>
@@ -1537,12 +2097,12 @@
         </a:fontRef>
       </dsp:style>
       <dsp:txBody>
-        <a:bodyPr spcFirstLastPara="0" vert="horz" wrap="square" lIns="49530" tIns="49530" rIns="49530" bIns="49530" numCol="1" spcCol="1270" anchor="ctr" anchorCtr="0">
+        <a:bodyPr spcFirstLastPara="0" vert="horz" wrap="square" lIns="60960" tIns="60960" rIns="60960" bIns="60960" numCol="1" spcCol="1270" anchor="ctr" anchorCtr="0">
           <a:noAutofit/>
         </a:bodyPr>
         <a:lstStyle/>
         <a:p>
-          <a:pPr marL="0" lvl="0" indent="0" algn="ctr" defTabSz="577850">
+          <a:pPr marL="0" lvl="0" indent="0" algn="ctr" defTabSz="711200">
             <a:lnSpc>
               <a:spcPct val="90000"/>
             </a:lnSpc>
@@ -1555,16 +2115,22 @@
             <a:buNone/>
           </a:pPr>
           <a:r>
-            <a:rPr lang="en-US" sz="1300" b="1" kern="1200" dirty="0"/>
+            <a:rPr lang="en-US" sz="1600" b="1" kern="1200" dirty="0">
+              <a:latin typeface="Times New Roman" panose="02020603050405020304" pitchFamily="18" charset="0"/>
+              <a:cs typeface="Times New Roman" panose="02020603050405020304" pitchFamily="18" charset="0"/>
+            </a:rPr>
             <a:t>Raw data set</a:t>
           </a:r>
           <a:r>
-            <a:rPr lang="en-US" sz="1300" kern="1200" dirty="0"/>
+            <a:rPr lang="en-US" sz="1600" kern="1200" dirty="0">
+              <a:latin typeface="Times New Roman" panose="02020603050405020304" pitchFamily="18" charset="0"/>
+              <a:cs typeface="Times New Roman" panose="02020603050405020304" pitchFamily="18" charset="0"/>
+            </a:rPr>
             <a:t>: </a:t>
           </a:r>
         </a:p>
         <a:p>
-          <a:pPr marL="0" lvl="0" indent="0" algn="ctr" defTabSz="577850">
+          <a:pPr marL="0" lvl="0" indent="0" algn="ctr" defTabSz="711200">
             <a:lnSpc>
               <a:spcPct val="90000"/>
             </a:lnSpc>
@@ -1577,12 +2143,15 @@
             <a:buNone/>
           </a:pPr>
           <a:r>
-            <a:rPr lang="en-US" sz="1300" b="1" kern="1200" dirty="0"/>
+            <a:rPr lang="en-US" sz="1600" b="1" kern="1200" dirty="0">
+              <a:latin typeface="Times New Roman" panose="02020603050405020304" pitchFamily="18" charset="0"/>
+              <a:cs typeface="Times New Roman" panose="02020603050405020304" pitchFamily="18" charset="0"/>
+            </a:rPr>
             <a:t>9087 cows</a:t>
           </a:r>
         </a:p>
         <a:p>
-          <a:pPr marL="0" lvl="0" indent="0" algn="ctr" defTabSz="577850">
+          <a:pPr marL="0" lvl="0" indent="0" algn="ctr" defTabSz="711200">
             <a:lnSpc>
               <a:spcPct val="90000"/>
             </a:lnSpc>
@@ -1595,14 +2164,17 @@
             <a:buNone/>
           </a:pPr>
           <a:r>
-            <a:rPr lang="en-US" sz="1300" kern="1200" dirty="0"/>
-            <a:t>~8.5 M records</a:t>
+            <a:rPr lang="en-US" sz="1600" kern="1200" dirty="0">
+              <a:latin typeface="Times New Roman" panose="02020603050405020304" pitchFamily="18" charset="0"/>
+              <a:cs typeface="Times New Roman" panose="02020603050405020304" pitchFamily="18" charset="0"/>
+            </a:rPr>
+            <a:t>~ 8.5 M records</a:t>
           </a:r>
         </a:p>
       </dsp:txBody>
       <dsp:txXfrm>
-        <a:off x="662470" y="26875"/>
-        <a:ext cx="1533990" cy="829283"/>
+        <a:off x="310666" y="42418"/>
+        <a:ext cx="2237597" cy="1085113"/>
       </dsp:txXfrm>
     </dsp:sp>
     <dsp:sp modelId="{2F389860-34B6-D647-9527-94DE13E6CDEE}">
@@ -1612,8 +2184,8 @@
       </dsp:nvSpPr>
       <dsp:spPr>
         <a:xfrm rot="5400000">
-          <a:off x="1264299" y="903981"/>
-          <a:ext cx="330331" cy="396397"/>
+          <a:off x="1159181" y="1190106"/>
+          <a:ext cx="540568" cy="518684"/>
         </a:xfrm>
         <a:prstGeom prst="rightArrow">
           <a:avLst>
@@ -1684,7 +2256,7 @@
         </a:bodyPr>
         <a:lstStyle/>
         <a:p>
-          <a:pPr marL="0" lvl="0" indent="0" algn="ctr" defTabSz="488950">
+          <a:pPr marL="0" lvl="0" indent="0" algn="ctr" defTabSz="1333500">
             <a:lnSpc>
               <a:spcPct val="90000"/>
             </a:lnSpc>
@@ -1696,12 +2268,15 @@
             </a:spcAft>
             <a:buNone/>
           </a:pPr>
-          <a:endParaRPr lang="en-US" sz="1100" kern="1200"/>
+          <a:endParaRPr lang="en-US" sz="3000" kern="1200">
+            <a:latin typeface="Times New Roman" panose="02020603050405020304" pitchFamily="18" charset="0"/>
+            <a:cs typeface="Times New Roman" panose="02020603050405020304" pitchFamily="18" charset="0"/>
+          </a:endParaRPr>
         </a:p>
       </dsp:txBody>
       <dsp:txXfrm rot="-5400000">
-        <a:off x="1310546" y="937014"/>
-        <a:ext cx="237839" cy="231232"/>
+        <a:off x="1273860" y="1179165"/>
+        <a:ext cx="311210" cy="384963"/>
       </dsp:txXfrm>
     </dsp:sp>
     <dsp:sp modelId="{F1DCF891-B3F9-924B-A427-97798FBECA9C}">
@@ -1711,8 +2286,8 @@
       </dsp:nvSpPr>
       <dsp:spPr>
         <a:xfrm>
-          <a:off x="636670" y="1322400"/>
-          <a:ext cx="1585590" cy="880883"/>
+          <a:off x="276907" y="1737606"/>
+          <a:ext cx="2305115" cy="769565"/>
         </a:xfrm>
         <a:prstGeom prst="roundRect">
           <a:avLst>
@@ -1784,12 +2359,12 @@
         </a:fontRef>
       </dsp:style>
       <dsp:txBody>
-        <a:bodyPr spcFirstLastPara="0" vert="horz" wrap="square" lIns="49530" tIns="49530" rIns="49530" bIns="49530" numCol="1" spcCol="1270" anchor="ctr" anchorCtr="0">
+        <a:bodyPr spcFirstLastPara="0" vert="horz" wrap="square" lIns="60960" tIns="60960" rIns="60960" bIns="60960" numCol="1" spcCol="1270" anchor="ctr" anchorCtr="0">
           <a:noAutofit/>
         </a:bodyPr>
         <a:lstStyle/>
         <a:p>
-          <a:pPr marL="0" lvl="0" indent="0" algn="ctr" defTabSz="577850">
+          <a:pPr marL="0" lvl="0" indent="0" algn="ctr" defTabSz="711200">
             <a:lnSpc>
               <a:spcPct val="90000"/>
             </a:lnSpc>
@@ -1801,12 +2376,39 @@
             </a:spcAft>
             <a:buNone/>
           </a:pPr>
-          <a:endParaRPr lang="en-US" sz="1300" kern="1200"/>
+          <a:r>
+            <a:rPr lang="en-US" sz="1600" b="1" kern="1200" dirty="0">
+              <a:latin typeface="Times New Roman" panose="02020603050405020304" pitchFamily="18" charset="0"/>
+              <a:cs typeface="Times New Roman" panose="02020603050405020304" pitchFamily="18" charset="0"/>
+            </a:rPr>
+            <a:t>9087 cows</a:t>
+          </a:r>
+        </a:p>
+        <a:p>
+          <a:pPr marL="0" lvl="0" indent="0" algn="ctr" defTabSz="711200">
+            <a:lnSpc>
+              <a:spcPct val="90000"/>
+            </a:lnSpc>
+            <a:spcBef>
+              <a:spcPct val="0"/>
+            </a:spcBef>
+            <a:spcAft>
+              <a:spcPct val="35000"/>
+            </a:spcAft>
+            <a:buNone/>
+          </a:pPr>
+          <a:r>
+            <a:rPr lang="en-US" sz="1600" kern="1200" dirty="0">
+              <a:latin typeface="Times New Roman" panose="02020603050405020304" pitchFamily="18" charset="0"/>
+              <a:cs typeface="Times New Roman" panose="02020603050405020304" pitchFamily="18" charset="0"/>
+            </a:rPr>
+            <a:t>~ 6.8 M records</a:t>
+          </a:r>
         </a:p>
       </dsp:txBody>
       <dsp:txXfrm>
-        <a:off x="662470" y="1348200"/>
-        <a:ext cx="1533990" cy="829283"/>
+        <a:off x="299447" y="1760146"/>
+        <a:ext cx="2260035" cy="724485"/>
       </dsp:txXfrm>
     </dsp:sp>
     <dsp:sp modelId="{5A392C4F-0F82-2042-A3B8-98E0ADC70004}">
@@ -1816,8 +2418,8 @@
       </dsp:nvSpPr>
       <dsp:spPr>
         <a:xfrm rot="5400000">
-          <a:off x="1264299" y="2225306"/>
-          <a:ext cx="330331" cy="396397"/>
+          <a:off x="1160475" y="2535988"/>
+          <a:ext cx="537979" cy="518684"/>
         </a:xfrm>
         <a:prstGeom prst="rightArrow">
           <a:avLst>
@@ -1888,7 +2490,7 @@
         </a:bodyPr>
         <a:lstStyle/>
         <a:p>
-          <a:pPr marL="0" lvl="0" indent="0" algn="ctr" defTabSz="488950">
+          <a:pPr marL="0" lvl="0" indent="0" algn="ctr" defTabSz="1333500">
             <a:lnSpc>
               <a:spcPct val="90000"/>
             </a:lnSpc>
@@ -1900,12 +2502,15 @@
             </a:spcAft>
             <a:buNone/>
           </a:pPr>
-          <a:endParaRPr lang="en-US" sz="1100" kern="1200"/>
+          <a:endParaRPr lang="en-US" sz="3000" kern="1200">
+            <a:latin typeface="Times New Roman" panose="02020603050405020304" pitchFamily="18" charset="0"/>
+            <a:cs typeface="Times New Roman" panose="02020603050405020304" pitchFamily="18" charset="0"/>
+          </a:endParaRPr>
         </a:p>
       </dsp:txBody>
       <dsp:txXfrm rot="-5400000">
-        <a:off x="1310546" y="2258339"/>
-        <a:ext cx="237839" cy="231232"/>
+        <a:off x="1273860" y="2526341"/>
+        <a:ext cx="311210" cy="382374"/>
       </dsp:txXfrm>
     </dsp:sp>
     <dsp:sp modelId="{7128D90E-EA1C-5A49-A5CB-358F0F56600D}">
@@ -1915,8 +2520,8 @@
       </dsp:nvSpPr>
       <dsp:spPr>
         <a:xfrm>
-          <a:off x="636670" y="2643725"/>
-          <a:ext cx="1585590" cy="880883"/>
+          <a:off x="276907" y="3083488"/>
+          <a:ext cx="2305115" cy="726860"/>
         </a:xfrm>
         <a:prstGeom prst="roundRect">
           <a:avLst>
@@ -1988,12 +2593,12 @@
         </a:fontRef>
       </dsp:style>
       <dsp:txBody>
-        <a:bodyPr spcFirstLastPara="0" vert="horz" wrap="square" lIns="49530" tIns="49530" rIns="49530" bIns="49530" numCol="1" spcCol="1270" anchor="ctr" anchorCtr="0">
+        <a:bodyPr spcFirstLastPara="0" vert="horz" wrap="square" lIns="60960" tIns="60960" rIns="60960" bIns="60960" numCol="1" spcCol="1270" anchor="ctr" anchorCtr="0">
           <a:noAutofit/>
         </a:bodyPr>
         <a:lstStyle/>
         <a:p>
-          <a:pPr marL="0" lvl="0" indent="0" algn="ctr" defTabSz="577850">
+          <a:pPr marL="0" lvl="0" indent="0" algn="ctr" defTabSz="711200">
             <a:lnSpc>
               <a:spcPct val="90000"/>
             </a:lnSpc>
@@ -2005,12 +2610,39 @@
             </a:spcAft>
             <a:buNone/>
           </a:pPr>
-          <a:endParaRPr lang="en-US" sz="1300" kern="1200"/>
+          <a:r>
+            <a:rPr lang="en-US" sz="1600" b="1" kern="1200" dirty="0">
+              <a:latin typeface="Times New Roman" panose="02020603050405020304" pitchFamily="18" charset="0"/>
+              <a:cs typeface="Times New Roman" panose="02020603050405020304" pitchFamily="18" charset="0"/>
+            </a:rPr>
+            <a:t>9011 cows</a:t>
+          </a:r>
+        </a:p>
+        <a:p>
+          <a:pPr marL="0" lvl="0" indent="0" algn="ctr" defTabSz="711200">
+            <a:lnSpc>
+              <a:spcPct val="90000"/>
+            </a:lnSpc>
+            <a:spcBef>
+              <a:spcPct val="0"/>
+            </a:spcBef>
+            <a:spcAft>
+              <a:spcPct val="35000"/>
+            </a:spcAft>
+            <a:buNone/>
+          </a:pPr>
+          <a:r>
+            <a:rPr lang="en-US" sz="1600" kern="1200" dirty="0">
+              <a:latin typeface="Times New Roman" panose="02020603050405020304" pitchFamily="18" charset="0"/>
+              <a:cs typeface="Times New Roman" panose="02020603050405020304" pitchFamily="18" charset="0"/>
+            </a:rPr>
+            <a:t>~ 6 M records</a:t>
+          </a:r>
         </a:p>
       </dsp:txBody>
       <dsp:txXfrm>
-        <a:off x="662470" y="2669525"/>
-        <a:ext cx="1533990" cy="829283"/>
+        <a:off x="298196" y="3104777"/>
+        <a:ext cx="2262537" cy="684282"/>
       </dsp:txXfrm>
     </dsp:sp>
     <dsp:sp modelId="{BAC1D5B0-1E4F-6C4D-8E53-3F1D1FD640C7}">
@@ -2020,8 +2652,8 @@
       </dsp:nvSpPr>
       <dsp:spPr>
         <a:xfrm rot="5400000">
-          <a:off x="1264299" y="3546631"/>
-          <a:ext cx="330331" cy="396397"/>
+          <a:off x="1213347" y="3839165"/>
+          <a:ext cx="432236" cy="518684"/>
         </a:xfrm>
         <a:prstGeom prst="rightArrow">
           <a:avLst>
@@ -2092,7 +2724,7 @@
         </a:bodyPr>
         <a:lstStyle/>
         <a:p>
-          <a:pPr marL="0" lvl="0" indent="0" algn="ctr" defTabSz="488950">
+          <a:pPr marL="0" lvl="0" indent="0" algn="ctr" defTabSz="1022350">
             <a:lnSpc>
               <a:spcPct val="90000"/>
             </a:lnSpc>
@@ -2104,12 +2736,15 @@
             </a:spcAft>
             <a:buNone/>
           </a:pPr>
-          <a:endParaRPr lang="en-US" sz="1100" kern="1200"/>
+          <a:endParaRPr lang="en-US" sz="2300" kern="1200">
+            <a:latin typeface="Times New Roman" panose="02020603050405020304" pitchFamily="18" charset="0"/>
+            <a:cs typeface="Times New Roman" panose="02020603050405020304" pitchFamily="18" charset="0"/>
+          </a:endParaRPr>
         </a:p>
       </dsp:txBody>
       <dsp:txXfrm rot="-5400000">
-        <a:off x="1310546" y="3579664"/>
-        <a:ext cx="237839" cy="231232"/>
+        <a:off x="1273861" y="3882389"/>
+        <a:ext cx="311210" cy="302565"/>
       </dsp:txXfrm>
     </dsp:sp>
     <dsp:sp modelId="{9F524941-7A89-6D4D-A311-EA8C15B7B605}">
@@ -2119,8 +2754,8 @@
       </dsp:nvSpPr>
       <dsp:spPr>
         <a:xfrm>
-          <a:off x="636670" y="3965050"/>
-          <a:ext cx="1585590" cy="880883"/>
+          <a:off x="588340" y="4386665"/>
+          <a:ext cx="1682249" cy="783777"/>
         </a:xfrm>
         <a:prstGeom prst="roundRect">
           <a:avLst>
@@ -2192,12 +2827,12 @@
         </a:fontRef>
       </dsp:style>
       <dsp:txBody>
-        <a:bodyPr spcFirstLastPara="0" vert="horz" wrap="square" lIns="49530" tIns="49530" rIns="49530" bIns="49530" numCol="1" spcCol="1270" anchor="ctr" anchorCtr="0">
+        <a:bodyPr spcFirstLastPara="0" vert="horz" wrap="square" lIns="53340" tIns="53340" rIns="53340" bIns="53340" numCol="1" spcCol="1270" anchor="ctr" anchorCtr="0">
           <a:noAutofit/>
         </a:bodyPr>
         <a:lstStyle/>
         <a:p>
-          <a:pPr marL="0" lvl="0" indent="0" algn="ctr" defTabSz="577850">
+          <a:pPr marL="0" lvl="0" indent="0" algn="ctr" defTabSz="622300">
             <a:lnSpc>
               <a:spcPct val="90000"/>
             </a:lnSpc>
@@ -2209,12 +2844,39 @@
             </a:spcAft>
             <a:buNone/>
           </a:pPr>
-          <a:endParaRPr lang="en-US" sz="1300" kern="1200"/>
+          <a:r>
+            <a:rPr lang="en-US" sz="1400" b="1" kern="1200" dirty="0">
+              <a:latin typeface="Times New Roman" panose="02020603050405020304" pitchFamily="18" charset="0"/>
+              <a:cs typeface="Times New Roman" panose="02020603050405020304" pitchFamily="18" charset="0"/>
+            </a:rPr>
+            <a:t>450 cows</a:t>
+          </a:r>
+        </a:p>
+        <a:p>
+          <a:pPr marL="0" lvl="0" indent="0" algn="ctr" defTabSz="622300">
+            <a:lnSpc>
+              <a:spcPct val="90000"/>
+            </a:lnSpc>
+            <a:spcBef>
+              <a:spcPct val="0"/>
+            </a:spcBef>
+            <a:spcAft>
+              <a:spcPct val="35000"/>
+            </a:spcAft>
+            <a:buNone/>
+          </a:pPr>
+          <a:r>
+            <a:rPr lang="en-US" sz="1400" kern="1200" dirty="0">
+              <a:latin typeface="Times New Roman" panose="02020603050405020304" pitchFamily="18" charset="0"/>
+              <a:cs typeface="Times New Roman" panose="02020603050405020304" pitchFamily="18" charset="0"/>
+            </a:rPr>
+            <a:t>~ 0.31 M records</a:t>
+          </a:r>
         </a:p>
       </dsp:txBody>
       <dsp:txXfrm>
-        <a:off x="662470" y="3990850"/>
-        <a:ext cx="1533990" cy="829283"/>
+        <a:off x="611296" y="4409621"/>
+        <a:ext cx="1636337" cy="737865"/>
       </dsp:txXfrm>
     </dsp:sp>
     <dsp:sp modelId="{9832284A-FC4C-B54D-9A24-074AFD27F0C9}">
@@ -2224,8 +2886,8 @@
       </dsp:nvSpPr>
       <dsp:spPr>
         <a:xfrm rot="5400000">
-          <a:off x="1264299" y="4867956"/>
-          <a:ext cx="330331" cy="396397"/>
+          <a:off x="1206632" y="5208211"/>
+          <a:ext cx="445666" cy="518684"/>
         </a:xfrm>
         <a:prstGeom prst="rightArrow">
           <a:avLst>
@@ -2296,7 +2958,7 @@
         </a:bodyPr>
         <a:lstStyle/>
         <a:p>
-          <a:pPr marL="0" lvl="0" indent="0" algn="ctr" defTabSz="488950">
+          <a:pPr marL="0" lvl="0" indent="0" algn="ctr" defTabSz="1066800">
             <a:lnSpc>
               <a:spcPct val="90000"/>
             </a:lnSpc>
@@ -2308,12 +2970,15 @@
             </a:spcAft>
             <a:buNone/>
           </a:pPr>
-          <a:endParaRPr lang="en-US" sz="1100" kern="1200"/>
+          <a:endParaRPr lang="en-US" sz="2400" kern="1200">
+            <a:latin typeface="Times New Roman" panose="02020603050405020304" pitchFamily="18" charset="0"/>
+            <a:cs typeface="Times New Roman" panose="02020603050405020304" pitchFamily="18" charset="0"/>
+          </a:endParaRPr>
         </a:p>
       </dsp:txBody>
       <dsp:txXfrm rot="-5400000">
-        <a:off x="1310546" y="4900989"/>
-        <a:ext cx="237839" cy="231232"/>
+        <a:off x="1273860" y="5244720"/>
+        <a:ext cx="311210" cy="311966"/>
       </dsp:txXfrm>
     </dsp:sp>
     <dsp:sp modelId="{87784E64-F689-6E4F-9054-EDFCCC761DEC}">
@@ -2323,8 +2988,8 @@
       </dsp:nvSpPr>
       <dsp:spPr>
         <a:xfrm>
-          <a:off x="636670" y="5286375"/>
-          <a:ext cx="1585590" cy="880883"/>
+          <a:off x="588340" y="5764664"/>
+          <a:ext cx="1682249" cy="783777"/>
         </a:xfrm>
         <a:prstGeom prst="roundRect">
           <a:avLst>
@@ -2396,12 +3061,12 @@
         </a:fontRef>
       </dsp:style>
       <dsp:txBody>
-        <a:bodyPr spcFirstLastPara="0" vert="horz" wrap="square" lIns="49530" tIns="49530" rIns="49530" bIns="49530" numCol="1" spcCol="1270" anchor="ctr" anchorCtr="0">
+        <a:bodyPr spcFirstLastPara="0" vert="horz" wrap="square" lIns="45720" tIns="45720" rIns="45720" bIns="45720" numCol="1" spcCol="1270" anchor="ctr" anchorCtr="0">
           <a:noAutofit/>
         </a:bodyPr>
         <a:lstStyle/>
         <a:p>
-          <a:pPr marL="0" lvl="0" indent="0" algn="ctr" defTabSz="577850">
+          <a:pPr marL="0" lvl="0" indent="0" algn="ctr" defTabSz="533400">
             <a:lnSpc>
               <a:spcPct val="90000"/>
             </a:lnSpc>
@@ -2413,12 +3078,39 @@
             </a:spcAft>
             <a:buNone/>
           </a:pPr>
-          <a:endParaRPr lang="en-US" sz="1300" kern="1200"/>
+          <a:r>
+            <a:rPr lang="en-US" sz="1200" b="1" kern="1200" dirty="0">
+              <a:latin typeface="Times New Roman" panose="02020603050405020304" pitchFamily="18" charset="0"/>
+              <a:cs typeface="Times New Roman" panose="02020603050405020304" pitchFamily="18" charset="0"/>
+            </a:rPr>
+            <a:t>448 cows</a:t>
+          </a:r>
+        </a:p>
+        <a:p>
+          <a:pPr marL="0" lvl="0" indent="0" algn="ctr" defTabSz="533400">
+            <a:lnSpc>
+              <a:spcPct val="90000"/>
+            </a:lnSpc>
+            <a:spcBef>
+              <a:spcPct val="0"/>
+            </a:spcBef>
+            <a:spcAft>
+              <a:spcPct val="35000"/>
+            </a:spcAft>
+            <a:buNone/>
+          </a:pPr>
+          <a:r>
+            <a:rPr lang="en-US" sz="1200" kern="1200" dirty="0">
+              <a:latin typeface="Times New Roman" panose="02020603050405020304" pitchFamily="18" charset="0"/>
+              <a:cs typeface="Times New Roman" panose="02020603050405020304" pitchFamily="18" charset="0"/>
+            </a:rPr>
+            <a:t>~ 0.31 M records</a:t>
+          </a:r>
         </a:p>
       </dsp:txBody>
       <dsp:txXfrm>
-        <a:off x="662470" y="5312175"/>
-        <a:ext cx="1533990" cy="829283"/>
+        <a:off x="611296" y="5787620"/>
+        <a:ext cx="1636337" cy="737865"/>
       </dsp:txXfrm>
     </dsp:sp>
     <dsp:sp modelId="{60A5F579-8817-964E-BDCF-1F0522C69BD4}">
@@ -2428,8 +3120,8 @@
       </dsp:nvSpPr>
       <dsp:spPr>
         <a:xfrm rot="5400000">
-          <a:off x="1264299" y="6189281"/>
-          <a:ext cx="330331" cy="396397"/>
+          <a:off x="1129377" y="6788569"/>
+          <a:ext cx="622203" cy="272278"/>
         </a:xfrm>
         <a:prstGeom prst="rightArrow">
           <a:avLst>
@@ -2500,7 +3192,7 @@
         </a:bodyPr>
         <a:lstStyle/>
         <a:p>
-          <a:pPr marL="0" lvl="0" indent="0" algn="ctr" defTabSz="488950">
+          <a:pPr marL="0" lvl="0" indent="0" algn="ctr" defTabSz="1866900">
             <a:lnSpc>
               <a:spcPct val="90000"/>
             </a:lnSpc>
@@ -2512,12 +3204,15 @@
             </a:spcAft>
             <a:buNone/>
           </a:pPr>
-          <a:endParaRPr lang="en-US" sz="1100" kern="1200"/>
+          <a:endParaRPr lang="en-US" sz="4200" kern="1200">
+            <a:latin typeface="Times New Roman" panose="02020603050405020304" pitchFamily="18" charset="0"/>
+            <a:cs typeface="Times New Roman" panose="02020603050405020304" pitchFamily="18" charset="0"/>
+          </a:endParaRPr>
         </a:p>
       </dsp:txBody>
       <dsp:txXfrm rot="-5400000">
-        <a:off x="1310546" y="6222314"/>
-        <a:ext cx="237839" cy="231232"/>
+        <a:off x="1358796" y="6613607"/>
+        <a:ext cx="163366" cy="540520"/>
       </dsp:txXfrm>
     </dsp:sp>
     <dsp:sp modelId="{2B1B973E-ADE0-8C49-BFF4-FDB5967037DE}">
@@ -2527,8 +3222,8 @@
       </dsp:nvSpPr>
       <dsp:spPr>
         <a:xfrm>
-          <a:off x="636670" y="6607700"/>
-          <a:ext cx="1585590" cy="880883"/>
+          <a:off x="588340" y="7257155"/>
+          <a:ext cx="1682249" cy="891675"/>
         </a:xfrm>
         <a:prstGeom prst="roundRect">
           <a:avLst>
@@ -2600,12 +3295,12 @@
         </a:fontRef>
       </dsp:style>
       <dsp:txBody>
-        <a:bodyPr spcFirstLastPara="0" vert="horz" wrap="square" lIns="49530" tIns="49530" rIns="49530" bIns="49530" numCol="1" spcCol="1270" anchor="ctr" anchorCtr="0">
+        <a:bodyPr spcFirstLastPara="0" vert="horz" wrap="square" lIns="45720" tIns="45720" rIns="45720" bIns="45720" numCol="1" spcCol="1270" anchor="ctr" anchorCtr="0">
           <a:noAutofit/>
         </a:bodyPr>
         <a:lstStyle/>
         <a:p>
-          <a:pPr marL="0" lvl="0" indent="0" algn="ctr" defTabSz="577850">
+          <a:pPr marL="0" lvl="0" indent="0" algn="ctr" defTabSz="533400">
             <a:lnSpc>
               <a:spcPct val="90000"/>
             </a:lnSpc>
@@ -2617,12 +3312,60 @@
             </a:spcAft>
             <a:buNone/>
           </a:pPr>
-          <a:endParaRPr lang="en-US" sz="1300" kern="1200"/>
+          <a:r>
+            <a:rPr lang="en-US" sz="1200" b="1" kern="1200" dirty="0">
+              <a:latin typeface="Times New Roman" panose="02020603050405020304" pitchFamily="18" charset="0"/>
+              <a:cs typeface="Times New Roman" panose="02020603050405020304" pitchFamily="18" charset="0"/>
+            </a:rPr>
+            <a:t>Train set</a:t>
+          </a:r>
+        </a:p>
+        <a:p>
+          <a:pPr marL="0" lvl="0" indent="0" algn="ctr" defTabSz="533400">
+            <a:lnSpc>
+              <a:spcPct val="90000"/>
+            </a:lnSpc>
+            <a:spcBef>
+              <a:spcPct val="0"/>
+            </a:spcBef>
+            <a:spcAft>
+              <a:spcPct val="35000"/>
+            </a:spcAft>
+            <a:buNone/>
+          </a:pPr>
+          <a:r>
+            <a:rPr lang="en-US" sz="1200" b="1" kern="1200" dirty="0">
+              <a:latin typeface="Times New Roman" panose="02020603050405020304" pitchFamily="18" charset="0"/>
+              <a:cs typeface="Times New Roman" panose="02020603050405020304" pitchFamily="18" charset="0"/>
+            </a:rPr>
+            <a:t>448 cows</a:t>
+          </a:r>
+        </a:p>
+        <a:p>
+          <a:pPr marL="0" lvl="0" indent="0" algn="ctr" defTabSz="533400">
+            <a:lnSpc>
+              <a:spcPct val="90000"/>
+            </a:lnSpc>
+            <a:spcBef>
+              <a:spcPct val="0"/>
+            </a:spcBef>
+            <a:spcAft>
+              <a:spcPct val="35000"/>
+            </a:spcAft>
+            <a:buNone/>
+          </a:pPr>
+          <a:r>
+            <a:rPr lang="en-US" sz="1200" kern="1200" dirty="0">
+              <a:latin typeface="Times New Roman" panose="02020603050405020304" pitchFamily="18" charset="0"/>
+              <a:cs typeface="Times New Roman" panose="02020603050405020304" pitchFamily="18" charset="0"/>
+            </a:rPr>
+            <a:t>~ 0.25 M records (80%; same cows older records)</a:t>
+          </a:r>
         </a:p>
       </dsp:txBody>
       <dsp:txXfrm>
-        <a:off x="662470" y="6633500"/>
-        <a:ext cx="1533990" cy="829283"/>
+        <a:off x="614456" y="7283271"/>
+        <a:ext cx="1630017" cy="839443"/>
       </dsp:txXfrm>
     </dsp:sp>
     <dsp:sp modelId="{26677FBF-9A1B-634D-9BB1-A8FCD65A0E38}">
@@ -2632,8 +3375,8 @@
       </dsp:nvSpPr>
       <dsp:spPr>
         <a:xfrm rot="5400000">
-          <a:off x="1264299" y="7510606"/>
-          <a:ext cx="330331" cy="396397"/>
+          <a:off x="858209" y="8115436"/>
+          <a:ext cx="374698" cy="518684"/>
         </a:xfrm>
         <a:prstGeom prst="rightArrow">
           <a:avLst>
@@ -2704,7 +3447,7 @@
         </a:bodyPr>
         <a:lstStyle/>
         <a:p>
-          <a:pPr marL="0" lvl="0" indent="0" algn="ctr" defTabSz="488950">
+          <a:pPr marL="0" lvl="0" indent="0" algn="ctr" defTabSz="889000">
             <a:lnSpc>
               <a:spcPct val="90000"/>
             </a:lnSpc>
@@ -2716,12 +3459,15 @@
             </a:spcAft>
             <a:buNone/>
           </a:pPr>
-          <a:endParaRPr lang="en-US" sz="1100" kern="1200"/>
+          <a:endParaRPr lang="en-US" sz="2000" kern="1200">
+            <a:latin typeface="Times New Roman" panose="02020603050405020304" pitchFamily="18" charset="0"/>
+            <a:cs typeface="Times New Roman" panose="02020603050405020304" pitchFamily="18" charset="0"/>
+          </a:endParaRPr>
         </a:p>
       </dsp:txBody>
       <dsp:txXfrm rot="-5400000">
-        <a:off x="1310546" y="7543639"/>
-        <a:ext cx="237839" cy="231232"/>
+        <a:off x="889954" y="8187429"/>
+        <a:ext cx="311210" cy="262289"/>
       </dsp:txXfrm>
     </dsp:sp>
     <dsp:sp modelId="{0BC5DB9D-6CA0-F744-B03B-293B7D6321C2}">
@@ -2731,8 +3477,8 @@
       </dsp:nvSpPr>
       <dsp:spPr>
         <a:xfrm>
-          <a:off x="636670" y="7929026"/>
-          <a:ext cx="1585590" cy="880883"/>
+          <a:off x="588340" y="8574843"/>
+          <a:ext cx="1682249" cy="783777"/>
         </a:xfrm>
         <a:prstGeom prst="roundRect">
           <a:avLst>
@@ -2804,12 +3550,12 @@
         </a:fontRef>
       </dsp:style>
       <dsp:txBody>
-        <a:bodyPr spcFirstLastPara="0" vert="horz" wrap="square" lIns="49530" tIns="49530" rIns="49530" bIns="49530" numCol="1" spcCol="1270" anchor="ctr" anchorCtr="0">
+        <a:bodyPr spcFirstLastPara="0" vert="horz" wrap="square" lIns="45720" tIns="45720" rIns="45720" bIns="45720" numCol="1" spcCol="1270" anchor="ctr" anchorCtr="0">
           <a:noAutofit/>
         </a:bodyPr>
         <a:lstStyle/>
         <a:p>
-          <a:pPr marL="0" lvl="0" indent="0" algn="ctr" defTabSz="577850">
+          <a:pPr marL="0" lvl="0" indent="0" algn="ctr" defTabSz="533400">
             <a:lnSpc>
               <a:spcPct val="90000"/>
             </a:lnSpc>
@@ -2821,12 +3567,18 @@
             </a:spcAft>
             <a:buNone/>
           </a:pPr>
-          <a:endParaRPr lang="en-US" sz="1300" kern="1200"/>
+          <a:r>
+            <a:rPr lang="en-US" sz="1200" b="1" kern="1200" dirty="0">
+              <a:latin typeface="Times New Roman" panose="02020603050405020304" pitchFamily="18" charset="0"/>
+              <a:cs typeface="Times New Roman" panose="02020603050405020304" pitchFamily="18" charset="0"/>
+            </a:rPr>
+            <a:t>Feature engineering – randomized search</a:t>
+          </a:r>
         </a:p>
       </dsp:txBody>
       <dsp:txXfrm>
-        <a:off x="662470" y="7954826"/>
-        <a:ext cx="1533990" cy="829283"/>
+        <a:off x="611296" y="8597799"/>
+        <a:ext cx="1636337" cy="737865"/>
       </dsp:txXfrm>
     </dsp:sp>
   </dsp:spTree>
@@ -6971,14 +7723,14 @@
             <p:ph idx="1"/>
             <p:extLst>
               <p:ext uri="{D42A27DB-BD31-4B8C-83A1-F6EECF244321}">
-                <p14:modId xmlns:p14="http://schemas.microsoft.com/office/powerpoint/2010/main" val="1544620236"/>
+                <p14:modId xmlns:p14="http://schemas.microsoft.com/office/powerpoint/2010/main" val="3836097877"/>
               </p:ext>
             </p:extLst>
           </p:nvPr>
         </p:nvGraphicFramePr>
         <p:xfrm>
-          <a:off x="156118" y="2594060"/>
-          <a:ext cx="2858931" cy="8810985"/>
+          <a:off x="-17898" y="2552871"/>
+          <a:ext cx="2858931" cy="9367281"/>
         </p:xfrm>
         <a:graphic>
           <a:graphicData uri="http://schemas.openxmlformats.org/drawingml/2006/diagram">
@@ -7092,8 +7844,8 @@
         </p:nvSpPr>
         <p:spPr>
           <a:xfrm>
-            <a:off x="4642043" y="10054375"/>
-            <a:ext cx="1583473" cy="369332"/>
+            <a:off x="4778713" y="5826913"/>
+            <a:ext cx="1347598" cy="369332"/>
           </a:xfrm>
           <a:prstGeom prst="rect">
             <a:avLst/>
@@ -7107,7 +7859,7 @@
           <a:lstStyle/>
           <a:p>
             <a:r>
-              <a:rPr lang="en-US" dirty="0">
+              <a:rPr lang="en-US" b="1" dirty="0">
                 <a:latin typeface="Times New Roman" panose="02020603050405020304" pitchFamily="18" charset="0"/>
                 <a:cs typeface="Times New Roman" panose="02020603050405020304" pitchFamily="18" charset="0"/>
               </a:rPr>
@@ -7130,8 +7882,8 @@
         </p:nvSpPr>
         <p:spPr>
           <a:xfrm>
-            <a:off x="4716965" y="10557524"/>
-            <a:ext cx="1583473" cy="646331"/>
+            <a:off x="4523890" y="9181634"/>
+            <a:ext cx="1980118" cy="369332"/>
           </a:xfrm>
           <a:prstGeom prst="rect">
             <a:avLst/>
@@ -7145,11 +7897,11 @@
           <a:lstStyle/>
           <a:p>
             <a:r>
-              <a:rPr lang="en-US" dirty="0">
+              <a:rPr lang="en-US" b="1" dirty="0">
                 <a:latin typeface="Times New Roman" panose="02020603050405020304" pitchFamily="18" charset="0"/>
                 <a:cs typeface="Times New Roman" panose="02020603050405020304" pitchFamily="18" charset="0"/>
               </a:rPr>
-              <a:t>Future Directions:</a:t>
+              <a:t>Future Directions</a:t>
             </a:r>
           </a:p>
         </p:txBody>
@@ -7168,8 +7920,8 @@
         </p:nvSpPr>
         <p:spPr>
           <a:xfrm>
-            <a:off x="4433306" y="3240682"/>
-            <a:ext cx="1792210" cy="646331"/>
+            <a:off x="4991868" y="2166110"/>
+            <a:ext cx="921289" cy="369332"/>
           </a:xfrm>
           <a:prstGeom prst="rect">
             <a:avLst/>
@@ -7183,18 +7935,12 @@
           <a:lstStyle/>
           <a:p>
             <a:r>
-              <a:rPr lang="en-US" dirty="0">
+              <a:rPr lang="en-US" b="1" dirty="0">
                 <a:latin typeface="Times New Roman" panose="02020603050405020304" pitchFamily="18" charset="0"/>
                 <a:cs typeface="Times New Roman" panose="02020603050405020304" pitchFamily="18" charset="0"/>
               </a:rPr>
               <a:t>Results</a:t>
             </a:r>
-          </a:p>
-          <a:p>
-            <a:endParaRPr lang="en-US" dirty="0">
-              <a:latin typeface="Times New Roman" panose="02020603050405020304" pitchFamily="18" charset="0"/>
-              <a:cs typeface="Times New Roman" panose="02020603050405020304" pitchFamily="18" charset="0"/>
-            </a:endParaRPr>
           </a:p>
         </p:txBody>
       </p:sp>
@@ -7212,8 +7958,8 @@
         </p:nvSpPr>
         <p:spPr>
           <a:xfrm>
-            <a:off x="1548311" y="2190358"/>
-            <a:ext cx="1070797" cy="646331"/>
+            <a:off x="241186" y="2140885"/>
+            <a:ext cx="2494639" cy="369332"/>
           </a:xfrm>
           <a:prstGeom prst="rect">
             <a:avLst/>
@@ -7228,18 +7974,12 @@
           <a:p>
             <a:pPr algn="ctr"/>
             <a:r>
-              <a:rPr lang="en-US" dirty="0">
+              <a:rPr lang="en-US" b="1" dirty="0">
                 <a:latin typeface="Times New Roman" panose="02020603050405020304" pitchFamily="18" charset="0"/>
                 <a:cs typeface="Times New Roman" panose="02020603050405020304" pitchFamily="18" charset="0"/>
               </a:rPr>
-              <a:t>Methods</a:t>
-            </a:r>
-          </a:p>
-          <a:p>
-            <a:endParaRPr lang="en-US" dirty="0">
-              <a:latin typeface="Times New Roman" panose="02020603050405020304" pitchFamily="18" charset="0"/>
-              <a:cs typeface="Times New Roman" panose="02020603050405020304" pitchFamily="18" charset="0"/>
-            </a:endParaRPr>
+              <a:t>Materials and Methods</a:t>
+            </a:r>
           </a:p>
         </p:txBody>
       </p:sp>
@@ -7257,8 +7997,8 @@
         </p:nvGrpSpPr>
         <p:grpSpPr>
           <a:xfrm rot="16200000">
-            <a:off x="2021881" y="3123630"/>
-            <a:ext cx="198200" cy="996254"/>
+            <a:off x="2051642" y="3300289"/>
+            <a:ext cx="198200" cy="1170166"/>
             <a:chOff x="1231266" y="937014"/>
             <a:chExt cx="396397" cy="330331"/>
           </a:xfrm>
@@ -7396,8 +8136,8 @@
         </p:nvGrpSpPr>
         <p:grpSpPr>
           <a:xfrm>
-            <a:off x="2674915" y="3298590"/>
-            <a:ext cx="1191091" cy="646331"/>
+            <a:off x="2772682" y="3770497"/>
+            <a:ext cx="1063575" cy="646331"/>
             <a:chOff x="636670" y="1322400"/>
             <a:chExt cx="1611391" cy="880883"/>
           </a:xfrm>
@@ -7524,10 +8264,16 @@
                 <a:buNone/>
               </a:pPr>
               <a:r>
-                <a:rPr lang="en-US" sz="1300" dirty="0"/>
+                <a:rPr lang="en-US" sz="1200" b="1" dirty="0">
+                  <a:latin typeface="Times New Roman" panose="02020603050405020304" pitchFamily="18" charset="0"/>
+                  <a:cs typeface="Times New Roman" panose="02020603050405020304" pitchFamily="18" charset="0"/>
+                </a:rPr>
                 <a:t>Missing IDs</a:t>
               </a:r>
-              <a:endParaRPr lang="en-US" sz="1300" kern="1200" dirty="0"/>
+              <a:endParaRPr lang="en-US" sz="1200" b="1" kern="1200" dirty="0">
+                <a:latin typeface="Times New Roman" panose="02020603050405020304" pitchFamily="18" charset="0"/>
+                <a:cs typeface="Times New Roman" panose="02020603050405020304" pitchFamily="18" charset="0"/>
+              </a:endParaRPr>
             </a:p>
             <a:p>
               <a:pPr marL="0" lvl="0" indent="0" algn="ctr" defTabSz="577850">
@@ -7543,13 +8289,1808 @@
                 <a:buNone/>
               </a:pPr>
               <a:r>
-                <a:rPr lang="en-US" sz="1300" kern="1200" dirty="0"/>
+                <a:rPr lang="en-US" sz="1200" kern="1200" dirty="0">
+                  <a:latin typeface="Times New Roman" panose="02020603050405020304" pitchFamily="18" charset="0"/>
+                  <a:cs typeface="Times New Roman" panose="02020603050405020304" pitchFamily="18" charset="0"/>
+                </a:rPr>
                 <a:t>~1.7 M records</a:t>
               </a:r>
             </a:p>
           </p:txBody>
         </p:sp>
       </p:grpSp>
+      <p:pic>
+        <p:nvPicPr>
+          <p:cNvPr id="20" name="Picture 19">
+            <a:extLst>
+              <a:ext uri="{FF2B5EF4-FFF2-40B4-BE49-F238E27FC236}">
+                <a16:creationId xmlns:a16="http://schemas.microsoft.com/office/drawing/2014/main" id="{387C9C44-345E-5BB8-2CD6-28A9093AB0A0}"/>
+              </a:ext>
+            </a:extLst>
+          </p:cNvPr>
+          <p:cNvPicPr>
+            <a:picLocks noChangeAspect="1"/>
+          </p:cNvPicPr>
+          <p:nvPr/>
+        </p:nvPicPr>
+        <p:blipFill>
+          <a:blip r:embed="rId7"/>
+          <a:stretch>
+            <a:fillRect/>
+          </a:stretch>
+        </p:blipFill>
+        <p:spPr>
+          <a:xfrm>
+            <a:off x="4417284" y="3790662"/>
+            <a:ext cx="2052251" cy="1742027"/>
+          </a:xfrm>
+          <a:prstGeom prst="rect">
+            <a:avLst/>
+          </a:prstGeom>
+        </p:spPr>
+      </p:pic>
+      <p:sp>
+        <p:nvSpPr>
+          <p:cNvPr id="21" name="TextBox 20">
+            <a:extLst>
+              <a:ext uri="{FF2B5EF4-FFF2-40B4-BE49-F238E27FC236}">
+                <a16:creationId xmlns:a16="http://schemas.microsoft.com/office/drawing/2014/main" id="{64963BAA-912D-5FC0-C390-B49EFA05A969}"/>
+              </a:ext>
+            </a:extLst>
+          </p:cNvPr>
+          <p:cNvSpPr txBox="1"/>
+          <p:nvPr/>
+        </p:nvSpPr>
+        <p:spPr>
+          <a:xfrm>
+            <a:off x="-48470" y="3745560"/>
+            <a:ext cx="1383767" cy="461665"/>
+          </a:xfrm>
+          <a:prstGeom prst="rect">
+            <a:avLst/>
+          </a:prstGeom>
+          <a:noFill/>
+        </p:spPr>
+        <p:txBody>
+          <a:bodyPr wrap="square" rtlCol="0">
+            <a:spAutoFit/>
+          </a:bodyPr>
+          <a:lstStyle/>
+          <a:p>
+            <a:r>
+              <a:rPr lang="en-US" sz="1200" dirty="0">
+                <a:latin typeface="Times New Roman" panose="02020603050405020304" pitchFamily="18" charset="0"/>
+                <a:cs typeface="Times New Roman" panose="02020603050405020304" pitchFamily="18" charset="0"/>
+              </a:rPr>
+              <a:t>Dropped duplicates (56K records)</a:t>
+            </a:r>
+          </a:p>
+        </p:txBody>
+      </p:sp>
+      <p:sp>
+        <p:nvSpPr>
+          <p:cNvPr id="31" name="TextBox 30">
+            <a:extLst>
+              <a:ext uri="{FF2B5EF4-FFF2-40B4-BE49-F238E27FC236}">
+                <a16:creationId xmlns:a16="http://schemas.microsoft.com/office/drawing/2014/main" id="{A3DE8E7F-5AF2-9B70-44D8-8C1C2B6B0EC8}"/>
+              </a:ext>
+            </a:extLst>
+          </p:cNvPr>
+          <p:cNvSpPr txBox="1"/>
+          <p:nvPr/>
+        </p:nvSpPr>
+        <p:spPr>
+          <a:xfrm>
+            <a:off x="-48470" y="5110816"/>
+            <a:ext cx="1434709" cy="461665"/>
+          </a:xfrm>
+          <a:prstGeom prst="rect">
+            <a:avLst/>
+          </a:prstGeom>
+          <a:noFill/>
+        </p:spPr>
+        <p:txBody>
+          <a:bodyPr wrap="square" rtlCol="0">
+            <a:spAutoFit/>
+          </a:bodyPr>
+          <a:lstStyle/>
+          <a:p>
+            <a:r>
+              <a:rPr lang="en-US" sz="1200" dirty="0">
+                <a:latin typeface="Times New Roman" panose="02020603050405020304" pitchFamily="18" charset="0"/>
+                <a:cs typeface="Times New Roman" panose="02020603050405020304" pitchFamily="18" charset="0"/>
+              </a:rPr>
+              <a:t>Dropped 2 records without DIM</a:t>
+            </a:r>
+          </a:p>
+        </p:txBody>
+      </p:sp>
+      <p:sp>
+        <p:nvSpPr>
+          <p:cNvPr id="32" name="TextBox 31">
+            <a:extLst>
+              <a:ext uri="{FF2B5EF4-FFF2-40B4-BE49-F238E27FC236}">
+                <a16:creationId xmlns:a16="http://schemas.microsoft.com/office/drawing/2014/main" id="{96E2AF48-E58A-079D-DBA8-D5FC11BE81C2}"/>
+              </a:ext>
+            </a:extLst>
+          </p:cNvPr>
+          <p:cNvSpPr txBox="1"/>
+          <p:nvPr/>
+        </p:nvSpPr>
+        <p:spPr>
+          <a:xfrm>
+            <a:off x="1565658" y="5102846"/>
+            <a:ext cx="2357744" cy="461665"/>
+          </a:xfrm>
+          <a:prstGeom prst="rect">
+            <a:avLst/>
+          </a:prstGeom>
+          <a:noFill/>
+        </p:spPr>
+        <p:txBody>
+          <a:bodyPr wrap="square" rtlCol="0">
+            <a:spAutoFit/>
+          </a:bodyPr>
+          <a:lstStyle/>
+          <a:p>
+            <a:r>
+              <a:rPr lang="en-US" sz="1200" dirty="0">
+                <a:latin typeface="Times New Roman" panose="02020603050405020304" pitchFamily="18" charset="0"/>
+                <a:cs typeface="Times New Roman" panose="02020603050405020304" pitchFamily="18" charset="0"/>
+              </a:rPr>
+              <a:t>Z-score standardization to remove outliers (&gt; 2 SD) ~ 0.7 M records</a:t>
+            </a:r>
+          </a:p>
+        </p:txBody>
+      </p:sp>
+      <p:sp>
+        <p:nvSpPr>
+          <p:cNvPr id="33" name="TextBox 32">
+            <a:extLst>
+              <a:ext uri="{FF2B5EF4-FFF2-40B4-BE49-F238E27FC236}">
+                <a16:creationId xmlns:a16="http://schemas.microsoft.com/office/drawing/2014/main" id="{168B7169-0D8F-C3E8-0ECC-FC72C94C1F61}"/>
+              </a:ext>
+            </a:extLst>
+          </p:cNvPr>
+          <p:cNvSpPr txBox="1"/>
+          <p:nvPr/>
+        </p:nvSpPr>
+        <p:spPr>
+          <a:xfrm>
+            <a:off x="1601789" y="6426082"/>
+            <a:ext cx="1407205" cy="461665"/>
+          </a:xfrm>
+          <a:prstGeom prst="rect">
+            <a:avLst/>
+          </a:prstGeom>
+          <a:noFill/>
+        </p:spPr>
+        <p:txBody>
+          <a:bodyPr wrap="square" rtlCol="0">
+            <a:spAutoFit/>
+          </a:bodyPr>
+          <a:lstStyle/>
+          <a:p>
+            <a:r>
+              <a:rPr lang="en-US" sz="1200" dirty="0">
+                <a:latin typeface="Times New Roman" panose="02020603050405020304" pitchFamily="18" charset="0"/>
+                <a:cs typeface="Times New Roman" panose="02020603050405020304" pitchFamily="18" charset="0"/>
+              </a:rPr>
+              <a:t>Randomly selected 5% of the cows</a:t>
+            </a:r>
+          </a:p>
+        </p:txBody>
+      </p:sp>
+      <p:sp>
+        <p:nvSpPr>
+          <p:cNvPr id="34" name="TextBox 33">
+            <a:extLst>
+              <a:ext uri="{FF2B5EF4-FFF2-40B4-BE49-F238E27FC236}">
+                <a16:creationId xmlns:a16="http://schemas.microsoft.com/office/drawing/2014/main" id="{1D201D78-C395-54A0-40EF-650FEFC801DF}"/>
+              </a:ext>
+            </a:extLst>
+          </p:cNvPr>
+          <p:cNvSpPr txBox="1"/>
+          <p:nvPr/>
+        </p:nvSpPr>
+        <p:spPr>
+          <a:xfrm>
+            <a:off x="1601789" y="7777509"/>
+            <a:ext cx="1439431" cy="461665"/>
+          </a:xfrm>
+          <a:prstGeom prst="rect">
+            <a:avLst/>
+          </a:prstGeom>
+          <a:noFill/>
+        </p:spPr>
+        <p:txBody>
+          <a:bodyPr wrap="square" rtlCol="0">
+            <a:spAutoFit/>
+          </a:bodyPr>
+          <a:lstStyle/>
+          <a:p>
+            <a:r>
+              <a:rPr lang="en-US" sz="1200" dirty="0">
+                <a:latin typeface="Times New Roman" panose="02020603050405020304" pitchFamily="18" charset="0"/>
+                <a:cs typeface="Times New Roman" panose="02020603050405020304" pitchFamily="18" charset="0"/>
+              </a:rPr>
+              <a:t>Removed 2 cows with &lt; 5 records</a:t>
+            </a:r>
+          </a:p>
+        </p:txBody>
+      </p:sp>
+      <p:sp>
+        <p:nvSpPr>
+          <p:cNvPr id="35" name="TextBox 34">
+            <a:extLst>
+              <a:ext uri="{FF2B5EF4-FFF2-40B4-BE49-F238E27FC236}">
+                <a16:creationId xmlns:a16="http://schemas.microsoft.com/office/drawing/2014/main" id="{75B2C6E6-20FF-EB81-74FA-E6645B446254}"/>
+              </a:ext>
+            </a:extLst>
+          </p:cNvPr>
+          <p:cNvSpPr txBox="1"/>
+          <p:nvPr/>
+        </p:nvSpPr>
+        <p:spPr>
+          <a:xfrm>
+            <a:off x="2212810" y="8467477"/>
+            <a:ext cx="1377895" cy="461665"/>
+          </a:xfrm>
+          <a:prstGeom prst="rect">
+            <a:avLst/>
+          </a:prstGeom>
+          <a:noFill/>
+        </p:spPr>
+        <p:txBody>
+          <a:bodyPr wrap="square" rtlCol="0">
+            <a:spAutoFit/>
+          </a:bodyPr>
+          <a:lstStyle/>
+          <a:p>
+            <a:r>
+              <a:rPr lang="en-US" sz="1200" b="1" dirty="0">
+                <a:latin typeface="Times New Roman" panose="02020603050405020304" pitchFamily="18" charset="0"/>
+                <a:cs typeface="Times New Roman" panose="02020603050405020304" pitchFamily="18" charset="0"/>
+              </a:rPr>
+              <a:t>Ranked by cow ID, then by date</a:t>
+            </a:r>
+          </a:p>
+        </p:txBody>
+      </p:sp>
+      <p:sp>
+        <p:nvSpPr>
+          <p:cNvPr id="37" name="Right Arrow 36">
+            <a:extLst>
+              <a:ext uri="{FF2B5EF4-FFF2-40B4-BE49-F238E27FC236}">
+                <a16:creationId xmlns:a16="http://schemas.microsoft.com/office/drawing/2014/main" id="{8A21A21B-E0D8-4545-8A63-7C29DE3B36A8}"/>
+              </a:ext>
+            </a:extLst>
+          </p:cNvPr>
+          <p:cNvSpPr/>
+          <p:nvPr/>
+        </p:nvSpPr>
+        <p:spPr>
+          <a:xfrm rot="1622265">
+            <a:off x="1525444" y="9287838"/>
+            <a:ext cx="899877" cy="272302"/>
+          </a:xfrm>
+          <a:prstGeom prst="rightArrow">
+            <a:avLst>
+              <a:gd name="adj1" fmla="val 60000"/>
+              <a:gd name="adj2" fmla="val 50000"/>
+            </a:avLst>
+          </a:prstGeom>
+        </p:spPr>
+        <p:style>
+          <a:lnRef idx="0">
+            <a:schemeClr val="lt1">
+              <a:hueOff val="0"/>
+              <a:satOff val="0"/>
+              <a:lumOff val="0"/>
+              <a:alphaOff val="0"/>
+            </a:schemeClr>
+          </a:lnRef>
+          <a:fillRef idx="2">
+            <a:schemeClr val="accent2">
+              <a:hueOff val="5154890"/>
+              <a:satOff val="-14794"/>
+              <a:lumOff val="-23687"/>
+              <a:alphaOff val="0"/>
+            </a:schemeClr>
+          </a:fillRef>
+          <a:effectRef idx="1">
+            <a:schemeClr val="accent2">
+              <a:hueOff val="5154890"/>
+              <a:satOff val="-14794"/>
+              <a:lumOff val="-23687"/>
+              <a:alphaOff val="0"/>
+            </a:schemeClr>
+          </a:effectRef>
+          <a:fontRef idx="minor">
+            <a:schemeClr val="dk1"/>
+          </a:fontRef>
+        </p:style>
+        <p:txBody>
+          <a:bodyPr/>
+          <a:lstStyle/>
+          <a:p>
+            <a:endParaRPr lang="en-US" dirty="0"/>
+          </a:p>
+        </p:txBody>
+      </p:sp>
+      <p:grpSp>
+        <p:nvGrpSpPr>
+          <p:cNvPr id="41" name="Group 40">
+            <a:extLst>
+              <a:ext uri="{FF2B5EF4-FFF2-40B4-BE49-F238E27FC236}">
+                <a16:creationId xmlns:a16="http://schemas.microsoft.com/office/drawing/2014/main" id="{2E638973-A36C-7D09-C2A1-9CA434F208C5}"/>
+              </a:ext>
+            </a:extLst>
+          </p:cNvPr>
+          <p:cNvGrpSpPr/>
+          <p:nvPr/>
+        </p:nvGrpSpPr>
+        <p:grpSpPr>
+          <a:xfrm>
+            <a:off x="2405155" y="9192839"/>
+            <a:ext cx="1716959" cy="1017427"/>
+            <a:chOff x="697301" y="7486557"/>
+            <a:chExt cx="1500292" cy="751499"/>
+          </a:xfrm>
+          <a:scene3d>
+            <a:camera prst="orthographicFront"/>
+            <a:lightRig rig="flat" dir="t"/>
+          </a:scene3d>
+        </p:grpSpPr>
+        <p:sp>
+          <p:nvSpPr>
+            <p:cNvPr id="42" name="Rounded Rectangle 41">
+              <a:extLst>
+                <a:ext uri="{FF2B5EF4-FFF2-40B4-BE49-F238E27FC236}">
+                  <a16:creationId xmlns:a16="http://schemas.microsoft.com/office/drawing/2014/main" id="{82F3FBDC-AAB8-A227-762E-A869A80004F7}"/>
+                </a:ext>
+              </a:extLst>
+            </p:cNvPr>
+            <p:cNvSpPr/>
+            <p:nvPr/>
+          </p:nvSpPr>
+          <p:spPr>
+            <a:xfrm>
+              <a:off x="697301" y="7507941"/>
+              <a:ext cx="1464327" cy="730115"/>
+            </a:xfrm>
+            <a:prstGeom prst="roundRect">
+              <a:avLst>
+                <a:gd name="adj" fmla="val 10000"/>
+              </a:avLst>
+            </a:prstGeom>
+            <a:sp3d prstMaterial="dkEdge">
+              <a:bevelT w="8200" h="38100"/>
+            </a:sp3d>
+          </p:spPr>
+          <p:style>
+            <a:lnRef idx="0">
+              <a:schemeClr val="lt1">
+                <a:hueOff val="0"/>
+                <a:satOff val="0"/>
+                <a:lumOff val="0"/>
+                <a:alphaOff val="0"/>
+              </a:schemeClr>
+            </a:lnRef>
+            <a:fillRef idx="2">
+              <a:schemeClr val="accent2">
+                <a:hueOff val="5369677"/>
+                <a:satOff val="-15411"/>
+                <a:lumOff val="-24674"/>
+                <a:alphaOff val="0"/>
+              </a:schemeClr>
+            </a:fillRef>
+            <a:effectRef idx="1">
+              <a:schemeClr val="accent2">
+                <a:hueOff val="5369677"/>
+                <a:satOff val="-15411"/>
+                <a:lumOff val="-24674"/>
+                <a:alphaOff val="0"/>
+              </a:schemeClr>
+            </a:effectRef>
+            <a:fontRef idx="minor">
+              <a:schemeClr val="dk1"/>
+            </a:fontRef>
+          </p:style>
+          <p:txBody>
+            <a:bodyPr/>
+            <a:lstStyle/>
+            <a:p>
+              <a:endParaRPr lang="en-US"/>
+            </a:p>
+          </p:txBody>
+        </p:sp>
+        <p:sp>
+          <p:nvSpPr>
+            <p:cNvPr id="43" name="Rounded Rectangle 4">
+              <a:extLst>
+                <a:ext uri="{FF2B5EF4-FFF2-40B4-BE49-F238E27FC236}">
+                  <a16:creationId xmlns:a16="http://schemas.microsoft.com/office/drawing/2014/main" id="{E0F461F7-D034-B3C0-FF9B-07E8BECFEFDD}"/>
+                </a:ext>
+              </a:extLst>
+            </p:cNvPr>
+            <p:cNvSpPr txBox="1"/>
+            <p:nvPr/>
+          </p:nvSpPr>
+          <p:spPr>
+            <a:xfrm>
+              <a:off x="718685" y="7486557"/>
+              <a:ext cx="1478908" cy="730115"/>
+            </a:xfrm>
+            <a:prstGeom prst="rect">
+              <a:avLst/>
+            </a:prstGeom>
+            <a:sp3d/>
+          </p:spPr>
+          <p:style>
+            <a:lnRef idx="0">
+              <a:scrgbClr r="0" g="0" b="0"/>
+            </a:lnRef>
+            <a:fillRef idx="0">
+              <a:scrgbClr r="0" g="0" b="0"/>
+            </a:fillRef>
+            <a:effectRef idx="0">
+              <a:scrgbClr r="0" g="0" b="0"/>
+            </a:effectRef>
+            <a:fontRef idx="minor">
+              <a:schemeClr val="dk1"/>
+            </a:fontRef>
+          </p:style>
+          <p:txBody>
+            <a:bodyPr spcFirstLastPara="0" vert="horz" wrap="square" lIns="53340" tIns="53340" rIns="53340" bIns="53340" numCol="1" spcCol="1270" anchor="ctr" anchorCtr="0">
+              <a:noAutofit/>
+            </a:bodyPr>
+            <a:lstStyle/>
+            <a:p>
+              <a:pPr marL="0" lvl="0" indent="0" algn="ctr" defTabSz="622300">
+                <a:lnSpc>
+                  <a:spcPct val="90000"/>
+                </a:lnSpc>
+                <a:spcBef>
+                  <a:spcPct val="0"/>
+                </a:spcBef>
+                <a:spcAft>
+                  <a:spcPct val="35000"/>
+                </a:spcAft>
+                <a:buNone/>
+              </a:pPr>
+              <a:r>
+                <a:rPr lang="en-US" sz="1200" b="1" kern="1200" dirty="0">
+                  <a:latin typeface="Times New Roman" panose="02020603050405020304" pitchFamily="18" charset="0"/>
+                  <a:cs typeface="Times New Roman" panose="02020603050405020304" pitchFamily="18" charset="0"/>
+                </a:rPr>
+                <a:t>Test set </a:t>
+              </a:r>
+            </a:p>
+            <a:p>
+              <a:pPr marL="0" lvl="0" indent="0" algn="ctr" defTabSz="622300">
+                <a:lnSpc>
+                  <a:spcPct val="90000"/>
+                </a:lnSpc>
+                <a:spcBef>
+                  <a:spcPct val="0"/>
+                </a:spcBef>
+                <a:spcAft>
+                  <a:spcPct val="35000"/>
+                </a:spcAft>
+                <a:buNone/>
+              </a:pPr>
+              <a:r>
+                <a:rPr lang="en-US" sz="1200" b="1" dirty="0">
+                  <a:latin typeface="Times New Roman" panose="02020603050405020304" pitchFamily="18" charset="0"/>
+                  <a:cs typeface="Times New Roman" panose="02020603050405020304" pitchFamily="18" charset="0"/>
+                </a:rPr>
+                <a:t>448 cows</a:t>
+              </a:r>
+            </a:p>
+            <a:p>
+              <a:pPr marL="0" lvl="0" indent="0" algn="ctr" defTabSz="622300">
+                <a:lnSpc>
+                  <a:spcPct val="90000"/>
+                </a:lnSpc>
+                <a:spcBef>
+                  <a:spcPct val="0"/>
+                </a:spcBef>
+                <a:spcAft>
+                  <a:spcPct val="35000"/>
+                </a:spcAft>
+                <a:buNone/>
+              </a:pPr>
+              <a:r>
+                <a:rPr lang="en-US" sz="1200" kern="1200" dirty="0">
+                  <a:latin typeface="Times New Roman" panose="02020603050405020304" pitchFamily="18" charset="0"/>
+                  <a:cs typeface="Times New Roman" panose="02020603050405020304" pitchFamily="18" charset="0"/>
+                </a:rPr>
+                <a:t>~ 0.06 M records (20%; same cows newer records)</a:t>
+              </a:r>
+            </a:p>
+          </p:txBody>
+        </p:sp>
+      </p:grpSp>
+      <p:sp>
+        <p:nvSpPr>
+          <p:cNvPr id="46" name="Rounded Rectangle 4">
+            <a:extLst>
+              <a:ext uri="{FF2B5EF4-FFF2-40B4-BE49-F238E27FC236}">
+                <a16:creationId xmlns:a16="http://schemas.microsoft.com/office/drawing/2014/main" id="{7DE1D0F5-717B-7A37-FBFB-DA7D9B774396}"/>
+              </a:ext>
+            </a:extLst>
+          </p:cNvPr>
+          <p:cNvSpPr txBox="1"/>
+          <p:nvPr/>
+        </p:nvSpPr>
+        <p:spPr>
+          <a:xfrm>
+            <a:off x="2624903" y="2466019"/>
+            <a:ext cx="1356963" cy="1237888"/>
+          </a:xfrm>
+          <a:prstGeom prst="rect">
+            <a:avLst/>
+          </a:prstGeom>
+          <a:solidFill>
+            <a:schemeClr val="accent2">
+              <a:lumMod val="20000"/>
+              <a:lumOff val="80000"/>
+            </a:schemeClr>
+          </a:solidFill>
+          <a:scene3d>
+            <a:camera prst="orthographicFront"/>
+            <a:lightRig rig="flat" dir="t"/>
+          </a:scene3d>
+          <a:sp3d/>
+        </p:spPr>
+        <p:style>
+          <a:lnRef idx="0">
+            <a:scrgbClr r="0" g="0" b="0"/>
+          </a:lnRef>
+          <a:fillRef idx="0">
+            <a:scrgbClr r="0" g="0" b="0"/>
+          </a:fillRef>
+          <a:effectRef idx="0">
+            <a:scrgbClr r="0" g="0" b="0"/>
+          </a:effectRef>
+          <a:fontRef idx="minor">
+            <a:schemeClr val="dk1"/>
+          </a:fontRef>
+        </p:style>
+        <p:txBody>
+          <a:bodyPr spcFirstLastPara="0" vert="horz" wrap="square" lIns="45720" tIns="45720" rIns="45720" bIns="45720" numCol="1" spcCol="1270" anchor="ctr" anchorCtr="0">
+            <a:noAutofit/>
+          </a:bodyPr>
+          <a:lstStyle/>
+          <a:p>
+            <a:pPr marL="0" lvl="0" indent="0" defTabSz="533400">
+              <a:spcBef>
+                <a:spcPct val="0"/>
+              </a:spcBef>
+              <a:buNone/>
+            </a:pPr>
+            <a:r>
+              <a:rPr lang="en-US" sz="1050" b="1" kern="1200" dirty="0">
+                <a:latin typeface="Times New Roman" panose="02020603050405020304" pitchFamily="18" charset="0"/>
+                <a:cs typeface="Times New Roman" panose="02020603050405020304" pitchFamily="18" charset="0"/>
+              </a:rPr>
+              <a:t>Features: </a:t>
+            </a:r>
+          </a:p>
+          <a:p>
+            <a:pPr marL="171450" indent="-171450" defTabSz="533400">
+              <a:spcBef>
+                <a:spcPct val="0"/>
+              </a:spcBef>
+              <a:buFont typeface="Arial" panose="020B0604020202020204" pitchFamily="34" charset="0"/>
+              <a:buChar char="•"/>
+            </a:pPr>
+            <a:r>
+              <a:rPr lang="en-US" sz="1050" dirty="0">
+                <a:latin typeface="Times New Roman" panose="02020603050405020304" pitchFamily="18" charset="0"/>
+                <a:cs typeface="Times New Roman" panose="02020603050405020304" pitchFamily="18" charset="0"/>
+              </a:rPr>
+              <a:t>milking</a:t>
+            </a:r>
+            <a:endParaRPr lang="en-US" sz="1050" kern="1200" dirty="0">
+              <a:latin typeface="Times New Roman" panose="02020603050405020304" pitchFamily="18" charset="0"/>
+              <a:cs typeface="Times New Roman" panose="02020603050405020304" pitchFamily="18" charset="0"/>
+            </a:endParaRPr>
+          </a:p>
+          <a:p>
+            <a:pPr marL="171450" lvl="0" indent="-171450" defTabSz="533400">
+              <a:spcBef>
+                <a:spcPct val="0"/>
+              </a:spcBef>
+              <a:buFont typeface="Arial" panose="020B0604020202020204" pitchFamily="34" charset="0"/>
+              <a:buChar char="•"/>
+            </a:pPr>
+            <a:r>
+              <a:rPr lang="en-US" sz="1050" kern="1200" dirty="0">
+                <a:latin typeface="Times New Roman" panose="02020603050405020304" pitchFamily="18" charset="0"/>
+                <a:cs typeface="Times New Roman" panose="02020603050405020304" pitchFamily="18" charset="0"/>
+              </a:rPr>
+              <a:t>average milk flow, </a:t>
+            </a:r>
+          </a:p>
+          <a:p>
+            <a:pPr marL="171450" lvl="0" indent="-171450" defTabSz="533400">
+              <a:spcBef>
+                <a:spcPct val="0"/>
+              </a:spcBef>
+              <a:buFont typeface="Arial" panose="020B0604020202020204" pitchFamily="34" charset="0"/>
+              <a:buChar char="•"/>
+            </a:pPr>
+            <a:r>
+              <a:rPr lang="en-US" sz="1050" kern="1200" dirty="0">
+                <a:latin typeface="Times New Roman" panose="02020603050405020304" pitchFamily="18" charset="0"/>
+                <a:cs typeface="Times New Roman" panose="02020603050405020304" pitchFamily="18" charset="0"/>
+              </a:rPr>
+              <a:t>30 – 60s milk flow, </a:t>
+            </a:r>
+          </a:p>
+          <a:p>
+            <a:pPr marL="171450" lvl="0" indent="-171450" defTabSz="533400">
+              <a:spcBef>
+                <a:spcPct val="0"/>
+              </a:spcBef>
+              <a:buFont typeface="Arial" panose="020B0604020202020204" pitchFamily="34" charset="0"/>
+              <a:buChar char="•"/>
+            </a:pPr>
+            <a:r>
+              <a:rPr lang="en-US" sz="1050" kern="1200" dirty="0">
+                <a:latin typeface="Times New Roman" panose="02020603050405020304" pitchFamily="18" charset="0"/>
+                <a:cs typeface="Times New Roman" panose="02020603050405020304" pitchFamily="18" charset="0"/>
+              </a:rPr>
+              <a:t>2-min session yield, </a:t>
+            </a:r>
+          </a:p>
+          <a:p>
+            <a:pPr marL="171450" lvl="0" indent="-171450" defTabSz="533400">
+              <a:spcBef>
+                <a:spcPct val="0"/>
+              </a:spcBef>
+              <a:buFont typeface="Arial" panose="020B0604020202020204" pitchFamily="34" charset="0"/>
+              <a:buChar char="•"/>
+            </a:pPr>
+            <a:r>
+              <a:rPr lang="en-US" sz="1050" kern="1200" dirty="0">
+                <a:latin typeface="Times New Roman" panose="02020603050405020304" pitchFamily="18" charset="0"/>
+                <a:cs typeface="Times New Roman" panose="02020603050405020304" pitchFamily="18" charset="0"/>
+              </a:rPr>
+              <a:t>yield per milking, </a:t>
+            </a:r>
+          </a:p>
+          <a:p>
+            <a:pPr marL="171450" lvl="0" indent="-171450" defTabSz="533400">
+              <a:spcBef>
+                <a:spcPct val="0"/>
+              </a:spcBef>
+              <a:buFont typeface="Arial" panose="020B0604020202020204" pitchFamily="34" charset="0"/>
+              <a:buChar char="•"/>
+            </a:pPr>
+            <a:r>
+              <a:rPr lang="en-US" sz="1050" kern="1200" dirty="0">
+                <a:latin typeface="Times New Roman" panose="02020603050405020304" pitchFamily="18" charset="0"/>
+                <a:cs typeface="Times New Roman" panose="02020603050405020304" pitchFamily="18" charset="0"/>
+              </a:rPr>
+              <a:t>milking duration, </a:t>
+            </a:r>
+          </a:p>
+          <a:p>
+            <a:pPr marL="0" lvl="0" indent="0" defTabSz="533400">
+              <a:spcBef>
+                <a:spcPct val="0"/>
+              </a:spcBef>
+              <a:buNone/>
+            </a:pPr>
+            <a:r>
+              <a:rPr lang="en-US" sz="1050" b="1" dirty="0">
+                <a:latin typeface="Times New Roman" panose="02020603050405020304" pitchFamily="18" charset="0"/>
+                <a:cs typeface="Times New Roman" panose="02020603050405020304" pitchFamily="18" charset="0"/>
+              </a:rPr>
+              <a:t>Label: </a:t>
+            </a:r>
+            <a:r>
+              <a:rPr lang="en-US" sz="1050" dirty="0">
+                <a:latin typeface="Times New Roman" panose="02020603050405020304" pitchFamily="18" charset="0"/>
+                <a:cs typeface="Times New Roman" panose="02020603050405020304" pitchFamily="18" charset="0"/>
+              </a:rPr>
+              <a:t>cow ID</a:t>
+            </a:r>
+            <a:endParaRPr lang="en-US" sz="1050" kern="1200" dirty="0">
+              <a:latin typeface="Times New Roman" panose="02020603050405020304" pitchFamily="18" charset="0"/>
+              <a:cs typeface="Times New Roman" panose="02020603050405020304" pitchFamily="18" charset="0"/>
+            </a:endParaRPr>
+          </a:p>
+        </p:txBody>
+      </p:sp>
+      <p:sp>
+        <p:nvSpPr>
+          <p:cNvPr id="50" name="Rounded Rectangle 4">
+            <a:extLst>
+              <a:ext uri="{FF2B5EF4-FFF2-40B4-BE49-F238E27FC236}">
+                <a16:creationId xmlns:a16="http://schemas.microsoft.com/office/drawing/2014/main" id="{630353C5-4BB3-6ECB-AC51-D3493CF4559F}"/>
+              </a:ext>
+            </a:extLst>
+          </p:cNvPr>
+          <p:cNvSpPr txBox="1"/>
+          <p:nvPr/>
+        </p:nvSpPr>
+        <p:spPr>
+          <a:xfrm>
+            <a:off x="2534681" y="11057668"/>
+            <a:ext cx="1381281" cy="1049460"/>
+          </a:xfrm>
+          <a:prstGeom prst="rect">
+            <a:avLst/>
+          </a:prstGeom>
+          <a:solidFill>
+            <a:schemeClr val="accent6">
+              <a:lumMod val="20000"/>
+              <a:lumOff val="80000"/>
+            </a:schemeClr>
+          </a:solidFill>
+          <a:scene3d>
+            <a:camera prst="orthographicFront"/>
+            <a:lightRig rig="flat" dir="t"/>
+          </a:scene3d>
+          <a:sp3d/>
+        </p:spPr>
+        <p:style>
+          <a:lnRef idx="0">
+            <a:scrgbClr r="0" g="0" b="0"/>
+          </a:lnRef>
+          <a:fillRef idx="0">
+            <a:scrgbClr r="0" g="0" b="0"/>
+          </a:fillRef>
+          <a:effectRef idx="0">
+            <a:scrgbClr r="0" g="0" b="0"/>
+          </a:effectRef>
+          <a:fontRef idx="minor">
+            <a:schemeClr val="dk1"/>
+          </a:fontRef>
+        </p:style>
+        <p:txBody>
+          <a:bodyPr spcFirstLastPara="0" vert="horz" wrap="square" lIns="45720" tIns="45720" rIns="45720" bIns="45720" numCol="1" spcCol="1270" anchor="ctr" anchorCtr="0">
+            <a:noAutofit/>
+          </a:bodyPr>
+          <a:lstStyle/>
+          <a:p>
+            <a:pPr marL="0" lvl="0" indent="0" defTabSz="533400">
+              <a:spcBef>
+                <a:spcPct val="0"/>
+              </a:spcBef>
+              <a:buNone/>
+            </a:pPr>
+            <a:r>
+              <a:rPr lang="en-US" sz="1050" b="1" kern="1200" dirty="0">
+                <a:latin typeface="Times New Roman" panose="02020603050405020304" pitchFamily="18" charset="0"/>
+                <a:cs typeface="Times New Roman" panose="02020603050405020304" pitchFamily="18" charset="0"/>
+              </a:rPr>
+              <a:t>Features: </a:t>
+            </a:r>
+          </a:p>
+          <a:p>
+            <a:pPr marL="171450" indent="-171450" defTabSz="533400">
+              <a:spcBef>
+                <a:spcPct val="0"/>
+              </a:spcBef>
+              <a:buFont typeface="Arial" panose="020B0604020202020204" pitchFamily="34" charset="0"/>
+              <a:buChar char="•"/>
+            </a:pPr>
+            <a:r>
+              <a:rPr lang="en-US" sz="1050" strike="sngStrike" dirty="0">
+                <a:latin typeface="Times New Roman" panose="02020603050405020304" pitchFamily="18" charset="0"/>
+                <a:cs typeface="Times New Roman" panose="02020603050405020304" pitchFamily="18" charset="0"/>
+              </a:rPr>
+              <a:t>milking</a:t>
+            </a:r>
+            <a:endParaRPr lang="en-US" sz="1050" kern="1200" dirty="0">
+              <a:latin typeface="Times New Roman" panose="02020603050405020304" pitchFamily="18" charset="0"/>
+              <a:cs typeface="Times New Roman" panose="02020603050405020304" pitchFamily="18" charset="0"/>
+            </a:endParaRPr>
+          </a:p>
+          <a:p>
+            <a:pPr marL="171450" lvl="0" indent="-171450" defTabSz="533400">
+              <a:spcBef>
+                <a:spcPct val="0"/>
+              </a:spcBef>
+              <a:buFont typeface="Arial" panose="020B0604020202020204" pitchFamily="34" charset="0"/>
+              <a:buChar char="•"/>
+            </a:pPr>
+            <a:r>
+              <a:rPr lang="en-US" sz="1050" kern="1200" dirty="0">
+                <a:latin typeface="Times New Roman" panose="02020603050405020304" pitchFamily="18" charset="0"/>
+                <a:cs typeface="Times New Roman" panose="02020603050405020304" pitchFamily="18" charset="0"/>
+              </a:rPr>
+              <a:t>average milk flow, </a:t>
+            </a:r>
+          </a:p>
+          <a:p>
+            <a:pPr marL="171450" lvl="0" indent="-171450" defTabSz="533400">
+              <a:spcBef>
+                <a:spcPct val="0"/>
+              </a:spcBef>
+              <a:buFont typeface="Arial" panose="020B0604020202020204" pitchFamily="34" charset="0"/>
+              <a:buChar char="•"/>
+            </a:pPr>
+            <a:r>
+              <a:rPr lang="en-US" sz="1050" kern="1200" dirty="0">
+                <a:latin typeface="Times New Roman" panose="02020603050405020304" pitchFamily="18" charset="0"/>
+                <a:cs typeface="Times New Roman" panose="02020603050405020304" pitchFamily="18" charset="0"/>
+              </a:rPr>
+              <a:t>30 – 60s milk flow, </a:t>
+            </a:r>
+          </a:p>
+          <a:p>
+            <a:pPr marL="171450" lvl="0" indent="-171450" defTabSz="533400">
+              <a:spcBef>
+                <a:spcPct val="0"/>
+              </a:spcBef>
+              <a:buFont typeface="Arial" panose="020B0604020202020204" pitchFamily="34" charset="0"/>
+              <a:buChar char="•"/>
+            </a:pPr>
+            <a:r>
+              <a:rPr lang="en-US" sz="1050" kern="1200" dirty="0">
+                <a:latin typeface="Times New Roman" panose="02020603050405020304" pitchFamily="18" charset="0"/>
+                <a:cs typeface="Times New Roman" panose="02020603050405020304" pitchFamily="18" charset="0"/>
+              </a:rPr>
+              <a:t>2-min session yield, </a:t>
+            </a:r>
+          </a:p>
+          <a:p>
+            <a:pPr marL="171450" lvl="0" indent="-171450" defTabSz="533400">
+              <a:spcBef>
+                <a:spcPct val="0"/>
+              </a:spcBef>
+              <a:buFont typeface="Arial" panose="020B0604020202020204" pitchFamily="34" charset="0"/>
+              <a:buChar char="•"/>
+            </a:pPr>
+            <a:r>
+              <a:rPr lang="en-US" sz="1050" kern="1200" dirty="0">
+                <a:latin typeface="Times New Roman" panose="02020603050405020304" pitchFamily="18" charset="0"/>
+                <a:cs typeface="Times New Roman" panose="02020603050405020304" pitchFamily="18" charset="0"/>
+              </a:rPr>
+              <a:t>yield per milking, </a:t>
+            </a:r>
+          </a:p>
+          <a:p>
+            <a:pPr marL="171450" lvl="0" indent="-171450" defTabSz="533400">
+              <a:spcBef>
+                <a:spcPct val="0"/>
+              </a:spcBef>
+              <a:buFont typeface="Arial" panose="020B0604020202020204" pitchFamily="34" charset="0"/>
+              <a:buChar char="•"/>
+            </a:pPr>
+            <a:r>
+              <a:rPr lang="en-US" sz="1050" kern="1200" dirty="0">
+                <a:latin typeface="Times New Roman" panose="02020603050405020304" pitchFamily="18" charset="0"/>
+                <a:cs typeface="Times New Roman" panose="02020603050405020304" pitchFamily="18" charset="0"/>
+              </a:rPr>
+              <a:t>milking duration </a:t>
+            </a:r>
+          </a:p>
+        </p:txBody>
+      </p:sp>
+      <p:grpSp>
+        <p:nvGrpSpPr>
+          <p:cNvPr id="51" name="Group 50">
+            <a:extLst>
+              <a:ext uri="{FF2B5EF4-FFF2-40B4-BE49-F238E27FC236}">
+                <a16:creationId xmlns:a16="http://schemas.microsoft.com/office/drawing/2014/main" id="{EADF9F0D-E6D6-5B05-A0A6-9C2113F948C8}"/>
+              </a:ext>
+            </a:extLst>
+          </p:cNvPr>
+          <p:cNvGrpSpPr/>
+          <p:nvPr/>
+        </p:nvGrpSpPr>
+        <p:grpSpPr>
+          <a:xfrm rot="10800000">
+            <a:off x="1491676" y="10720090"/>
+            <a:ext cx="519191" cy="375064"/>
+            <a:chOff x="1169869" y="8160196"/>
+            <a:chExt cx="519191" cy="375064"/>
+          </a:xfrm>
+        </p:grpSpPr>
+        <p:sp>
+          <p:nvSpPr>
+            <p:cNvPr id="52" name="Right Arrow 51">
+              <a:extLst>
+                <a:ext uri="{FF2B5EF4-FFF2-40B4-BE49-F238E27FC236}">
+                  <a16:creationId xmlns:a16="http://schemas.microsoft.com/office/drawing/2014/main" id="{3DF5929E-5364-947E-398C-1C35FB60BEA8}"/>
+                </a:ext>
+              </a:extLst>
+            </p:cNvPr>
+            <p:cNvSpPr/>
+            <p:nvPr/>
+          </p:nvSpPr>
+          <p:spPr>
+            <a:xfrm rot="5400000">
+              <a:off x="1241933" y="8088132"/>
+              <a:ext cx="375064" cy="519191"/>
+            </a:xfrm>
+            <a:prstGeom prst="rightArrow">
+              <a:avLst>
+                <a:gd name="adj1" fmla="val 60000"/>
+                <a:gd name="adj2" fmla="val 50000"/>
+              </a:avLst>
+            </a:prstGeom>
+          </p:spPr>
+          <p:style>
+            <a:lnRef idx="0">
+              <a:schemeClr val="lt1">
+                <a:hueOff val="0"/>
+                <a:satOff val="0"/>
+                <a:lumOff val="0"/>
+                <a:alphaOff val="0"/>
+              </a:schemeClr>
+            </a:lnRef>
+            <a:fillRef idx="2">
+              <a:schemeClr val="accent2">
+                <a:hueOff val="6443612"/>
+                <a:satOff val="-18493"/>
+                <a:lumOff val="-29609"/>
+                <a:alphaOff val="0"/>
+              </a:schemeClr>
+            </a:fillRef>
+            <a:effectRef idx="1">
+              <a:schemeClr val="accent2">
+                <a:hueOff val="6443612"/>
+                <a:satOff val="-18493"/>
+                <a:lumOff val="-29609"/>
+                <a:alphaOff val="0"/>
+              </a:schemeClr>
+            </a:effectRef>
+            <a:fontRef idx="minor">
+              <a:schemeClr val="dk1"/>
+            </a:fontRef>
+          </p:style>
+          <p:txBody>
+            <a:bodyPr/>
+            <a:lstStyle/>
+            <a:p>
+              <a:endParaRPr lang="en-US"/>
+            </a:p>
+          </p:txBody>
+        </p:sp>
+        <p:sp>
+          <p:nvSpPr>
+            <p:cNvPr id="53" name="Right Arrow 4">
+              <a:extLst>
+                <a:ext uri="{FF2B5EF4-FFF2-40B4-BE49-F238E27FC236}">
+                  <a16:creationId xmlns:a16="http://schemas.microsoft.com/office/drawing/2014/main" id="{043FBC30-ED76-5386-6ECC-6974158D3DF8}"/>
+                </a:ext>
+              </a:extLst>
+            </p:cNvPr>
+            <p:cNvSpPr txBox="1"/>
+            <p:nvPr/>
+          </p:nvSpPr>
+          <p:spPr>
+            <a:xfrm>
+              <a:off x="1273708" y="8160196"/>
+              <a:ext cx="311515" cy="262545"/>
+            </a:xfrm>
+            <a:prstGeom prst="rect">
+              <a:avLst/>
+            </a:prstGeom>
+          </p:spPr>
+          <p:style>
+            <a:lnRef idx="0">
+              <a:scrgbClr r="0" g="0" b="0"/>
+            </a:lnRef>
+            <a:fillRef idx="0">
+              <a:scrgbClr r="0" g="0" b="0"/>
+            </a:fillRef>
+            <a:effectRef idx="0">
+              <a:scrgbClr r="0" g="0" b="0"/>
+            </a:effectRef>
+            <a:fontRef idx="minor">
+              <a:schemeClr val="dk1"/>
+            </a:fontRef>
+          </p:style>
+          <p:txBody>
+            <a:bodyPr spcFirstLastPara="0" vert="horz" wrap="square" lIns="0" tIns="0" rIns="0" bIns="0" numCol="1" spcCol="1270" anchor="ctr" anchorCtr="0">
+              <a:noAutofit/>
+            </a:bodyPr>
+            <a:lstStyle/>
+            <a:p>
+              <a:pPr marL="0" lvl="0" indent="0" algn="ctr" defTabSz="444500">
+                <a:lnSpc>
+                  <a:spcPct val="90000"/>
+                </a:lnSpc>
+                <a:spcBef>
+                  <a:spcPct val="0"/>
+                </a:spcBef>
+                <a:spcAft>
+                  <a:spcPct val="35000"/>
+                </a:spcAft>
+                <a:buNone/>
+              </a:pPr>
+              <a:endParaRPr lang="en-US" sz="1000" kern="1200">
+                <a:latin typeface="Times New Roman" panose="02020603050405020304" pitchFamily="18" charset="0"/>
+                <a:cs typeface="Times New Roman" panose="02020603050405020304" pitchFamily="18" charset="0"/>
+              </a:endParaRPr>
+            </a:p>
+          </p:txBody>
+        </p:sp>
+      </p:grpSp>
+      <p:grpSp>
+        <p:nvGrpSpPr>
+          <p:cNvPr id="54" name="Group 53">
+            <a:extLst>
+              <a:ext uri="{FF2B5EF4-FFF2-40B4-BE49-F238E27FC236}">
+                <a16:creationId xmlns:a16="http://schemas.microsoft.com/office/drawing/2014/main" id="{CC4539D4-1BB6-6956-8A8A-27F6876F8BD3}"/>
+              </a:ext>
+            </a:extLst>
+          </p:cNvPr>
+          <p:cNvGrpSpPr/>
+          <p:nvPr/>
+        </p:nvGrpSpPr>
+        <p:grpSpPr>
+          <a:xfrm rot="13302679">
+            <a:off x="2177392" y="10107937"/>
+            <a:ext cx="877251" cy="1176690"/>
+            <a:chOff x="924236" y="8160196"/>
+            <a:chExt cx="1023071" cy="375064"/>
+          </a:xfrm>
+        </p:grpSpPr>
+        <p:sp>
+          <p:nvSpPr>
+            <p:cNvPr id="55" name="Right Arrow 54">
+              <a:extLst>
+                <a:ext uri="{FF2B5EF4-FFF2-40B4-BE49-F238E27FC236}">
+                  <a16:creationId xmlns:a16="http://schemas.microsoft.com/office/drawing/2014/main" id="{6912814A-9D52-5975-5241-3EAA74EA42E3}"/>
+                </a:ext>
+              </a:extLst>
+            </p:cNvPr>
+            <p:cNvSpPr/>
+            <p:nvPr/>
+          </p:nvSpPr>
+          <p:spPr>
+            <a:xfrm rot="5400000">
+              <a:off x="1241933" y="8088132"/>
+              <a:ext cx="375064" cy="519191"/>
+            </a:xfrm>
+            <a:prstGeom prst="rightArrow">
+              <a:avLst>
+                <a:gd name="adj1" fmla="val 60000"/>
+                <a:gd name="adj2" fmla="val 50000"/>
+              </a:avLst>
+            </a:prstGeom>
+            <a:gradFill>
+              <a:gsLst>
+                <a:gs pos="0">
+                  <a:schemeClr val="accent2">
+                    <a:hueOff val="6443612"/>
+                    <a:satOff val="-18493"/>
+                    <a:alphaOff val="0"/>
+                    <a:satMod val="105000"/>
+                    <a:tint val="67000"/>
+                    <a:lumMod val="0"/>
+                    <a:lumOff val="100000"/>
+                  </a:schemeClr>
+                </a:gs>
+                <a:gs pos="50000">
+                  <a:schemeClr val="accent2">
+                    <a:hueOff val="6443612"/>
+                    <a:satOff val="-18493"/>
+                    <a:lumOff val="-29609"/>
+                    <a:alphaOff val="0"/>
+                    <a:lumMod val="105000"/>
+                    <a:satMod val="103000"/>
+                    <a:tint val="73000"/>
+                  </a:schemeClr>
+                </a:gs>
+                <a:gs pos="100000">
+                  <a:schemeClr val="accent2">
+                    <a:hueOff val="6443612"/>
+                    <a:satOff val="-18493"/>
+                    <a:lumOff val="-29609"/>
+                    <a:alphaOff val="0"/>
+                    <a:lumMod val="105000"/>
+                    <a:satMod val="109000"/>
+                    <a:tint val="81000"/>
+                  </a:schemeClr>
+                </a:gs>
+              </a:gsLst>
+            </a:gradFill>
+          </p:spPr>
+          <p:style>
+            <a:lnRef idx="0">
+              <a:schemeClr val="lt1">
+                <a:hueOff val="0"/>
+                <a:satOff val="0"/>
+                <a:lumOff val="0"/>
+                <a:alphaOff val="0"/>
+              </a:schemeClr>
+            </a:lnRef>
+            <a:fillRef idx="2">
+              <a:schemeClr val="accent2">
+                <a:hueOff val="6443612"/>
+                <a:satOff val="-18493"/>
+                <a:lumOff val="-29609"/>
+                <a:alphaOff val="0"/>
+              </a:schemeClr>
+            </a:fillRef>
+            <a:effectRef idx="1">
+              <a:schemeClr val="accent2">
+                <a:hueOff val="6443612"/>
+                <a:satOff val="-18493"/>
+                <a:lumOff val="-29609"/>
+                <a:alphaOff val="0"/>
+              </a:schemeClr>
+            </a:effectRef>
+            <a:fontRef idx="minor">
+              <a:schemeClr val="dk1"/>
+            </a:fontRef>
+          </p:style>
+          <p:txBody>
+            <a:bodyPr/>
+            <a:lstStyle/>
+            <a:p>
+              <a:endParaRPr lang="en-US"/>
+            </a:p>
+          </p:txBody>
+        </p:sp>
+        <p:sp>
+          <p:nvSpPr>
+            <p:cNvPr id="56" name="Right Arrow 4">
+              <a:extLst>
+                <a:ext uri="{FF2B5EF4-FFF2-40B4-BE49-F238E27FC236}">
+                  <a16:creationId xmlns:a16="http://schemas.microsoft.com/office/drawing/2014/main" id="{1F45248A-0214-B952-1895-FDA04CFACFF3}"/>
+                </a:ext>
+              </a:extLst>
+            </p:cNvPr>
+            <p:cNvSpPr txBox="1"/>
+            <p:nvPr/>
+          </p:nvSpPr>
+          <p:spPr>
+            <a:xfrm rot="5501074">
+              <a:off x="1264006" y="7820855"/>
+              <a:ext cx="343532" cy="1023071"/>
+            </a:xfrm>
+            <a:prstGeom prst="rect">
+              <a:avLst/>
+            </a:prstGeom>
+          </p:spPr>
+          <p:style>
+            <a:lnRef idx="0">
+              <a:scrgbClr r="0" g="0" b="0"/>
+            </a:lnRef>
+            <a:fillRef idx="0">
+              <a:scrgbClr r="0" g="0" b="0"/>
+            </a:fillRef>
+            <a:effectRef idx="0">
+              <a:scrgbClr r="0" g="0" b="0"/>
+            </a:effectRef>
+            <a:fontRef idx="minor">
+              <a:schemeClr val="dk1"/>
+            </a:fontRef>
+          </p:style>
+          <p:txBody>
+            <a:bodyPr spcFirstLastPara="0" vert="horz" wrap="square" lIns="0" tIns="0" rIns="0" bIns="0" numCol="1" spcCol="1270" anchor="ctr" anchorCtr="0">
+              <a:noAutofit/>
+            </a:bodyPr>
+            <a:lstStyle/>
+            <a:p>
+              <a:pPr marL="0" lvl="0" indent="0" algn="ctr" defTabSz="444500">
+                <a:lnSpc>
+                  <a:spcPct val="90000"/>
+                </a:lnSpc>
+                <a:spcBef>
+                  <a:spcPct val="0"/>
+                </a:spcBef>
+                <a:spcAft>
+                  <a:spcPct val="35000"/>
+                </a:spcAft>
+                <a:buNone/>
+              </a:pPr>
+              <a:r>
+                <a:rPr lang="en-US" sz="1400" b="1" kern="1200" dirty="0">
+                  <a:latin typeface="Times New Roman" panose="02020603050405020304" pitchFamily="18" charset="0"/>
+                  <a:cs typeface="Times New Roman" panose="02020603050405020304" pitchFamily="18" charset="0"/>
+                </a:rPr>
+                <a:t>Final Model</a:t>
+              </a:r>
+            </a:p>
+          </p:txBody>
+        </p:sp>
+      </p:grpSp>
+      <p:sp>
+        <p:nvSpPr>
+          <p:cNvPr id="57" name="TextBox 56">
+            <a:extLst>
+              <a:ext uri="{FF2B5EF4-FFF2-40B4-BE49-F238E27FC236}">
+                <a16:creationId xmlns:a16="http://schemas.microsoft.com/office/drawing/2014/main" id="{F2C9370C-5F7A-87AF-A4A5-D9791D9FA94F}"/>
+              </a:ext>
+            </a:extLst>
+          </p:cNvPr>
+          <p:cNvSpPr txBox="1"/>
+          <p:nvPr/>
+        </p:nvSpPr>
+        <p:spPr>
+          <a:xfrm>
+            <a:off x="4328593" y="2466019"/>
+            <a:ext cx="2247840" cy="1384995"/>
+          </a:xfrm>
+          <a:prstGeom prst="rect">
+            <a:avLst/>
+          </a:prstGeom>
+          <a:noFill/>
+          <a:ln w="19050">
+            <a:noFill/>
+            <a:prstDash val="sysDot"/>
+          </a:ln>
+        </p:spPr>
+        <p:txBody>
+          <a:bodyPr wrap="square" rtlCol="0">
+            <a:spAutoFit/>
+          </a:bodyPr>
+          <a:lstStyle/>
+          <a:p>
+            <a:pPr marL="285750" indent="-285750">
+              <a:buFont typeface="Arial" panose="020B0604020202020204" pitchFamily="34" charset="0"/>
+              <a:buChar char="•"/>
+            </a:pPr>
+            <a:r>
+              <a:rPr lang="en-US" sz="1400" dirty="0">
+                <a:latin typeface="Times New Roman" panose="02020603050405020304" pitchFamily="18" charset="0"/>
+                <a:cs typeface="Times New Roman" panose="02020603050405020304" pitchFamily="18" charset="0"/>
+              </a:rPr>
+              <a:t>Top – 1 accuracy: 3.6% </a:t>
+            </a:r>
+          </a:p>
+          <a:p>
+            <a:pPr marL="285750" indent="-285750">
+              <a:buFont typeface="Arial" panose="020B0604020202020204" pitchFamily="34" charset="0"/>
+              <a:buChar char="•"/>
+            </a:pPr>
+            <a:r>
+              <a:rPr lang="en-US" sz="1400" dirty="0">
+                <a:latin typeface="Times New Roman" panose="02020603050405020304" pitchFamily="18" charset="0"/>
+                <a:cs typeface="Times New Roman" panose="02020603050405020304" pitchFamily="18" charset="0"/>
+              </a:rPr>
+              <a:t>Top – 5 accuracy: 13.1%</a:t>
+            </a:r>
+          </a:p>
+          <a:p>
+            <a:pPr marL="285750" indent="-285750">
+              <a:buFont typeface="Arial" panose="020B0604020202020204" pitchFamily="34" charset="0"/>
+              <a:buChar char="•"/>
+            </a:pPr>
+            <a:r>
+              <a:rPr lang="en-US" sz="1400" dirty="0">
+                <a:latin typeface="Times New Roman" panose="02020603050405020304" pitchFamily="18" charset="0"/>
+                <a:cs typeface="Times New Roman" panose="02020603050405020304" pitchFamily="18" charset="0"/>
+              </a:rPr>
+              <a:t>Precision: 3.1%</a:t>
+            </a:r>
+          </a:p>
+          <a:p>
+            <a:pPr marL="285750" indent="-285750">
+              <a:buFont typeface="Arial" panose="020B0604020202020204" pitchFamily="34" charset="0"/>
+              <a:buChar char="•"/>
+            </a:pPr>
+            <a:r>
+              <a:rPr lang="en-US" sz="1400" dirty="0">
+                <a:latin typeface="Times New Roman" panose="02020603050405020304" pitchFamily="18" charset="0"/>
+                <a:cs typeface="Times New Roman" panose="02020603050405020304" pitchFamily="18" charset="0"/>
+              </a:rPr>
+              <a:t>Recall: 3.6%</a:t>
+            </a:r>
+          </a:p>
+          <a:p>
+            <a:pPr marL="285750" indent="-285750">
+              <a:buFont typeface="Arial" panose="020B0604020202020204" pitchFamily="34" charset="0"/>
+              <a:buChar char="•"/>
+            </a:pPr>
+            <a:r>
+              <a:rPr lang="en-US" sz="1400" dirty="0">
+                <a:latin typeface="Times New Roman" panose="02020603050405020304" pitchFamily="18" charset="0"/>
+                <a:cs typeface="Times New Roman" panose="02020603050405020304" pitchFamily="18" charset="0"/>
+              </a:rPr>
+              <a:t>F-1 score: 0.044 ± 0.007</a:t>
+            </a:r>
+          </a:p>
+          <a:p>
+            <a:pPr marL="285750" indent="-285750">
+              <a:buFont typeface="Arial" panose="020B0604020202020204" pitchFamily="34" charset="0"/>
+              <a:buChar char="•"/>
+            </a:pPr>
+            <a:r>
+              <a:rPr lang="en-US" sz="1400" dirty="0">
+                <a:latin typeface="Times New Roman" panose="02020603050405020304" pitchFamily="18" charset="0"/>
+                <a:cs typeface="Times New Roman" panose="02020603050405020304" pitchFamily="18" charset="0"/>
+              </a:rPr>
+              <a:t>Confusion matrix:</a:t>
+            </a:r>
+          </a:p>
+        </p:txBody>
+      </p:sp>
+      <p:sp>
+        <p:nvSpPr>
+          <p:cNvPr id="59" name="Rounded Rectangle 58">
+            <a:extLst>
+              <a:ext uri="{FF2B5EF4-FFF2-40B4-BE49-F238E27FC236}">
+                <a16:creationId xmlns:a16="http://schemas.microsoft.com/office/drawing/2014/main" id="{2A63506B-CE5B-F017-8A9F-7B9E68AD5292}"/>
+              </a:ext>
+            </a:extLst>
+          </p:cNvPr>
+          <p:cNvSpPr/>
+          <p:nvPr/>
+        </p:nvSpPr>
+        <p:spPr>
+          <a:xfrm>
+            <a:off x="4196091" y="2207741"/>
+            <a:ext cx="2494639" cy="3397692"/>
+          </a:xfrm>
+          <a:prstGeom prst="roundRect">
+            <a:avLst/>
+          </a:prstGeom>
+          <a:noFill/>
+          <a:ln w="19050">
+            <a:prstDash val="dash"/>
+          </a:ln>
+        </p:spPr>
+        <p:style>
+          <a:lnRef idx="2">
+            <a:schemeClr val="accent1">
+              <a:shade val="15000"/>
+            </a:schemeClr>
+          </a:lnRef>
+          <a:fillRef idx="1">
+            <a:schemeClr val="accent1"/>
+          </a:fillRef>
+          <a:effectRef idx="0">
+            <a:schemeClr val="accent1"/>
+          </a:effectRef>
+          <a:fontRef idx="minor">
+            <a:schemeClr val="lt1"/>
+          </a:fontRef>
+        </p:style>
+        <p:txBody>
+          <a:bodyPr rtlCol="0" anchor="ctr"/>
+          <a:lstStyle/>
+          <a:p>
+            <a:pPr algn="ctr"/>
+            <a:endParaRPr lang="en-US"/>
+          </a:p>
+        </p:txBody>
+      </p:sp>
+      <p:sp>
+        <p:nvSpPr>
+          <p:cNvPr id="60" name="Rounded Rectangle 59">
+            <a:extLst>
+              <a:ext uri="{FF2B5EF4-FFF2-40B4-BE49-F238E27FC236}">
+                <a16:creationId xmlns:a16="http://schemas.microsoft.com/office/drawing/2014/main" id="{13EF09E5-0607-B1F1-F7C5-E1DD501A546D}"/>
+              </a:ext>
+            </a:extLst>
+          </p:cNvPr>
+          <p:cNvSpPr/>
+          <p:nvPr/>
+        </p:nvSpPr>
+        <p:spPr>
+          <a:xfrm>
+            <a:off x="4196091" y="5737219"/>
+            <a:ext cx="2505618" cy="3244199"/>
+          </a:xfrm>
+          <a:prstGeom prst="roundRect">
+            <a:avLst/>
+          </a:prstGeom>
+          <a:noFill/>
+          <a:ln w="19050">
+            <a:prstDash val="dash"/>
+          </a:ln>
+        </p:spPr>
+        <p:style>
+          <a:lnRef idx="2">
+            <a:schemeClr val="accent1">
+              <a:shade val="15000"/>
+            </a:schemeClr>
+          </a:lnRef>
+          <a:fillRef idx="1">
+            <a:schemeClr val="accent1"/>
+          </a:fillRef>
+          <a:effectRef idx="0">
+            <a:schemeClr val="accent1"/>
+          </a:effectRef>
+          <a:fontRef idx="minor">
+            <a:schemeClr val="lt1"/>
+          </a:fontRef>
+        </p:style>
+        <p:txBody>
+          <a:bodyPr rtlCol="0" anchor="ctr"/>
+          <a:lstStyle/>
+          <a:p>
+            <a:pPr algn="ctr"/>
+            <a:endParaRPr lang="en-US"/>
+          </a:p>
+        </p:txBody>
+      </p:sp>
+      <p:sp>
+        <p:nvSpPr>
+          <p:cNvPr id="61" name="TextBox 60">
+            <a:extLst>
+              <a:ext uri="{FF2B5EF4-FFF2-40B4-BE49-F238E27FC236}">
+                <a16:creationId xmlns:a16="http://schemas.microsoft.com/office/drawing/2014/main" id="{78060164-7FB2-140B-184D-64A573D43F53}"/>
+              </a:ext>
+            </a:extLst>
+          </p:cNvPr>
+          <p:cNvSpPr txBox="1"/>
+          <p:nvPr/>
+        </p:nvSpPr>
+        <p:spPr>
+          <a:xfrm>
+            <a:off x="4200878" y="6189398"/>
+            <a:ext cx="2505618" cy="2893100"/>
+          </a:xfrm>
+          <a:prstGeom prst="rect">
+            <a:avLst/>
+          </a:prstGeom>
+          <a:noFill/>
+          <a:ln w="19050">
+            <a:noFill/>
+            <a:prstDash val="sysDot"/>
+          </a:ln>
+        </p:spPr>
+        <p:txBody>
+          <a:bodyPr wrap="square" rtlCol="0">
+            <a:spAutoFit/>
+          </a:bodyPr>
+          <a:lstStyle/>
+          <a:p>
+            <a:pPr marL="285750" indent="-285750">
+              <a:buFont typeface="Arial" panose="020B0604020202020204" pitchFamily="34" charset="0"/>
+              <a:buChar char="•"/>
+            </a:pPr>
+            <a:r>
+              <a:rPr lang="en-US" sz="1400" dirty="0">
+                <a:latin typeface="Times New Roman" panose="02020603050405020304" pitchFamily="18" charset="0"/>
+                <a:cs typeface="Times New Roman" panose="02020603050405020304" pitchFamily="18" charset="0"/>
+              </a:rPr>
+              <a:t>Internal validity: </a:t>
+            </a:r>
+          </a:p>
+          <a:p>
+            <a:pPr marL="742950" lvl="1" indent="-285750">
+              <a:buFont typeface="Arial" panose="020B0604020202020204" pitchFamily="34" charset="0"/>
+              <a:buChar char="•"/>
+            </a:pPr>
+            <a:r>
+              <a:rPr lang="en-US" sz="1400" dirty="0">
+                <a:latin typeface="Times New Roman" panose="02020603050405020304" pitchFamily="18" charset="0"/>
+                <a:cs typeface="Times New Roman" panose="02020603050405020304" pitchFamily="18" charset="0"/>
+              </a:rPr>
+              <a:t>model trained on 448 cows (a small subset of the records)</a:t>
+            </a:r>
+          </a:p>
+          <a:p>
+            <a:pPr marL="285750" indent="-285750">
+              <a:buFont typeface="Arial" panose="020B0604020202020204" pitchFamily="34" charset="0"/>
+              <a:buChar char="•"/>
+            </a:pPr>
+            <a:r>
+              <a:rPr lang="en-US" sz="1400" dirty="0">
+                <a:latin typeface="Times New Roman" panose="02020603050405020304" pitchFamily="18" charset="0"/>
+                <a:cs typeface="Times New Roman" panose="02020603050405020304" pitchFamily="18" charset="0"/>
+              </a:rPr>
+              <a:t>External validity: </a:t>
+            </a:r>
+          </a:p>
+          <a:p>
+            <a:pPr marL="742950" lvl="1" indent="-285750">
+              <a:buFont typeface="Arial" panose="020B0604020202020204" pitchFamily="34" charset="0"/>
+              <a:buChar char="•"/>
+            </a:pPr>
+            <a:r>
+              <a:rPr lang="en-US" sz="1400" dirty="0">
+                <a:latin typeface="Times New Roman" panose="02020603050405020304" pitchFamily="18" charset="0"/>
+                <a:cs typeface="Times New Roman" panose="02020603050405020304" pitchFamily="18" charset="0"/>
+              </a:rPr>
+              <a:t>based on 1 farm’s record</a:t>
+            </a:r>
+          </a:p>
+          <a:p>
+            <a:pPr marL="285750" indent="-285750">
+              <a:buFont typeface="Arial" panose="020B0604020202020204" pitchFamily="34" charset="0"/>
+              <a:buChar char="•"/>
+            </a:pPr>
+            <a:r>
+              <a:rPr lang="en-US" sz="1400" dirty="0">
+                <a:latin typeface="Times New Roman" panose="02020603050405020304" pitchFamily="18" charset="0"/>
+                <a:cs typeface="Times New Roman" panose="02020603050405020304" pitchFamily="18" charset="0"/>
+              </a:rPr>
+              <a:t>High computational cost</a:t>
+            </a:r>
+          </a:p>
+          <a:p>
+            <a:pPr marL="285750" indent="-285750">
+              <a:buFont typeface="Arial" panose="020B0604020202020204" pitchFamily="34" charset="0"/>
+              <a:buChar char="•"/>
+            </a:pPr>
+            <a:r>
+              <a:rPr lang="en-US" sz="1400" dirty="0">
+                <a:latin typeface="Times New Roman" panose="02020603050405020304" pitchFamily="18" charset="0"/>
+                <a:cs typeface="Times New Roman" panose="02020603050405020304" pitchFamily="18" charset="0"/>
+              </a:rPr>
+              <a:t>Unable to predict unknown cow IDs</a:t>
+            </a:r>
+          </a:p>
+          <a:p>
+            <a:pPr marL="285750" indent="-285750">
+              <a:buFont typeface="Arial" panose="020B0604020202020204" pitchFamily="34" charset="0"/>
+              <a:buChar char="•"/>
+            </a:pPr>
+            <a:r>
+              <a:rPr lang="en-US" sz="1400" dirty="0">
+                <a:latin typeface="Times New Roman" panose="02020603050405020304" pitchFamily="18" charset="0"/>
+                <a:cs typeface="Times New Roman" panose="02020603050405020304" pitchFamily="18" charset="0"/>
+              </a:rPr>
+              <a:t>Random forest as a “black-box” model</a:t>
+            </a:r>
+          </a:p>
+          <a:p>
+            <a:pPr marL="285750" indent="-285750">
+              <a:buFont typeface="Arial" panose="020B0604020202020204" pitchFamily="34" charset="0"/>
+              <a:buChar char="•"/>
+            </a:pPr>
+            <a:endParaRPr lang="en-US" sz="1400" dirty="0">
+              <a:latin typeface="Times New Roman" panose="02020603050405020304" pitchFamily="18" charset="0"/>
+              <a:cs typeface="Times New Roman" panose="02020603050405020304" pitchFamily="18" charset="0"/>
+            </a:endParaRPr>
+          </a:p>
+        </p:txBody>
+      </p:sp>
+      <p:sp>
+        <p:nvSpPr>
+          <p:cNvPr id="62" name="TextBox 61">
+            <a:extLst>
+              <a:ext uri="{FF2B5EF4-FFF2-40B4-BE49-F238E27FC236}">
+                <a16:creationId xmlns:a16="http://schemas.microsoft.com/office/drawing/2014/main" id="{918C2D8C-4B89-0F62-F711-B650DCE380BA}"/>
+              </a:ext>
+            </a:extLst>
+          </p:cNvPr>
+          <p:cNvSpPr txBox="1"/>
+          <p:nvPr/>
+        </p:nvSpPr>
+        <p:spPr>
+          <a:xfrm>
+            <a:off x="548161" y="9201934"/>
+            <a:ext cx="1731845" cy="369332"/>
+          </a:xfrm>
+          <a:prstGeom prst="rect">
+            <a:avLst/>
+          </a:prstGeom>
+          <a:solidFill>
+            <a:schemeClr val="accent6">
+              <a:lumMod val="40000"/>
+              <a:lumOff val="60000"/>
+            </a:schemeClr>
+          </a:solidFill>
+        </p:spPr>
+        <p:txBody>
+          <a:bodyPr wrap="square" rtlCol="0">
+            <a:spAutoFit/>
+          </a:bodyPr>
+          <a:lstStyle/>
+          <a:p>
+            <a:r>
+              <a:rPr lang="en-US" b="1" dirty="0">
+                <a:latin typeface="Times New Roman" panose="02020603050405020304" pitchFamily="18" charset="0"/>
+                <a:cs typeface="Times New Roman" panose="02020603050405020304" pitchFamily="18" charset="0"/>
+              </a:rPr>
+              <a:t>Random Forest</a:t>
+            </a:r>
+          </a:p>
+        </p:txBody>
+      </p:sp>
+      <p:sp>
+        <p:nvSpPr>
+          <p:cNvPr id="63" name="TextBox 62">
+            <a:extLst>
+              <a:ext uri="{FF2B5EF4-FFF2-40B4-BE49-F238E27FC236}">
+                <a16:creationId xmlns:a16="http://schemas.microsoft.com/office/drawing/2014/main" id="{E798CF97-6B28-7CEF-8896-0D767DA2B450}"/>
+              </a:ext>
+            </a:extLst>
+          </p:cNvPr>
+          <p:cNvSpPr txBox="1"/>
+          <p:nvPr/>
+        </p:nvSpPr>
+        <p:spPr>
+          <a:xfrm>
+            <a:off x="4189847" y="9493962"/>
+            <a:ext cx="2497706" cy="2462213"/>
+          </a:xfrm>
+          <a:prstGeom prst="rect">
+            <a:avLst/>
+          </a:prstGeom>
+          <a:noFill/>
+          <a:ln w="19050">
+            <a:noFill/>
+            <a:prstDash val="sysDot"/>
+          </a:ln>
+        </p:spPr>
+        <p:txBody>
+          <a:bodyPr wrap="square" rtlCol="0">
+            <a:spAutoFit/>
+          </a:bodyPr>
+          <a:lstStyle/>
+          <a:p>
+            <a:pPr marL="285750" indent="-285750">
+              <a:buFont typeface="Arial" panose="020B0604020202020204" pitchFamily="34" charset="0"/>
+              <a:buChar char="•"/>
+            </a:pPr>
+            <a:r>
+              <a:rPr lang="en-US" sz="1400" dirty="0">
+                <a:latin typeface="Times New Roman" panose="02020603050405020304" pitchFamily="18" charset="0"/>
+                <a:cs typeface="Times New Roman" panose="02020603050405020304" pitchFamily="18" charset="0"/>
+              </a:rPr>
+              <a:t>Cloud-based approach</a:t>
+            </a:r>
+          </a:p>
+          <a:p>
+            <a:pPr marL="285750" indent="-285750">
+              <a:buFont typeface="Arial" panose="020B0604020202020204" pitchFamily="34" charset="0"/>
+              <a:buChar char="•"/>
+            </a:pPr>
+            <a:r>
+              <a:rPr lang="en-US" sz="1400" dirty="0">
+                <a:latin typeface="Times New Roman" panose="02020603050405020304" pitchFamily="18" charset="0"/>
+                <a:cs typeface="Times New Roman" panose="02020603050405020304" pitchFamily="18" charset="0"/>
+              </a:rPr>
+              <a:t>Representative samples from different farms</a:t>
+            </a:r>
+          </a:p>
+          <a:p>
+            <a:pPr marL="285750" indent="-285750">
+              <a:buFont typeface="Arial" panose="020B0604020202020204" pitchFamily="34" charset="0"/>
+              <a:buChar char="•"/>
+            </a:pPr>
+            <a:r>
+              <a:rPr lang="en-US" sz="1400" dirty="0">
+                <a:latin typeface="Times New Roman" panose="02020603050405020304" pitchFamily="18" charset="0"/>
+                <a:cs typeface="Times New Roman" panose="02020603050405020304" pitchFamily="18" charset="0"/>
+              </a:rPr>
+              <a:t>Explore other machine learning methods:</a:t>
+            </a:r>
+          </a:p>
+          <a:p>
+            <a:pPr marL="742950" lvl="1" indent="-285750">
+              <a:buFont typeface="Arial" panose="020B0604020202020204" pitchFamily="34" charset="0"/>
+              <a:buChar char="•"/>
+            </a:pPr>
+            <a:r>
+              <a:rPr lang="en-US" sz="1400" dirty="0">
+                <a:latin typeface="Times New Roman" panose="02020603050405020304" pitchFamily="18" charset="0"/>
+                <a:cs typeface="Times New Roman" panose="02020603050405020304" pitchFamily="18" charset="0"/>
+              </a:rPr>
+              <a:t>K – nearest neighbors</a:t>
+            </a:r>
+          </a:p>
+          <a:p>
+            <a:pPr marL="742950" lvl="1" indent="-285750">
+              <a:buFont typeface="Arial" panose="020B0604020202020204" pitchFamily="34" charset="0"/>
+              <a:buChar char="•"/>
+            </a:pPr>
+            <a:r>
+              <a:rPr lang="en-US" sz="1400" dirty="0">
+                <a:latin typeface="Times New Roman" panose="02020603050405020304" pitchFamily="18" charset="0"/>
+                <a:cs typeface="Times New Roman" panose="02020603050405020304" pitchFamily="18" charset="0"/>
+              </a:rPr>
+              <a:t>Neural networks</a:t>
+            </a:r>
+          </a:p>
+          <a:p>
+            <a:pPr marL="285750" indent="-285750">
+              <a:buFont typeface="Arial" panose="020B0604020202020204" pitchFamily="34" charset="0"/>
+              <a:buChar char="•"/>
+            </a:pPr>
+            <a:r>
+              <a:rPr lang="en-US" sz="1400" dirty="0">
+                <a:latin typeface="Times New Roman" panose="02020603050405020304" pitchFamily="18" charset="0"/>
+                <a:cs typeface="Times New Roman" panose="02020603050405020304" pitchFamily="18" charset="0"/>
+              </a:rPr>
+              <a:t>Multilabel classification:</a:t>
+            </a:r>
+          </a:p>
+          <a:p>
+            <a:pPr marL="742950" lvl="1" indent="-285750">
+              <a:buFont typeface="Arial" panose="020B0604020202020204" pitchFamily="34" charset="0"/>
+              <a:buChar char="•"/>
+            </a:pPr>
+            <a:r>
+              <a:rPr lang="en-US" sz="1400" dirty="0">
+                <a:latin typeface="Times New Roman" panose="02020603050405020304" pitchFamily="18" charset="0"/>
+                <a:cs typeface="Times New Roman" panose="02020603050405020304" pitchFamily="18" charset="0"/>
+              </a:rPr>
+              <a:t>Predicting cow ID and associated cow records features?</a:t>
+            </a:r>
+          </a:p>
+        </p:txBody>
+      </p:sp>
+      <p:sp>
+        <p:nvSpPr>
+          <p:cNvPr id="65" name="Rounded Rectangle 64">
+            <a:extLst>
+              <a:ext uri="{FF2B5EF4-FFF2-40B4-BE49-F238E27FC236}">
+                <a16:creationId xmlns:a16="http://schemas.microsoft.com/office/drawing/2014/main" id="{323056C3-62F8-FEAA-4D64-4D95D744EDA7}"/>
+              </a:ext>
+            </a:extLst>
+          </p:cNvPr>
+          <p:cNvSpPr/>
+          <p:nvPr/>
+        </p:nvSpPr>
+        <p:spPr>
+          <a:xfrm>
+            <a:off x="4189847" y="9162734"/>
+            <a:ext cx="2511861" cy="2893099"/>
+          </a:xfrm>
+          <a:prstGeom prst="roundRect">
+            <a:avLst/>
+          </a:prstGeom>
+          <a:noFill/>
+          <a:ln w="19050">
+            <a:prstDash val="dash"/>
+          </a:ln>
+        </p:spPr>
+        <p:style>
+          <a:lnRef idx="2">
+            <a:schemeClr val="accent1">
+              <a:shade val="15000"/>
+            </a:schemeClr>
+          </a:lnRef>
+          <a:fillRef idx="1">
+            <a:schemeClr val="accent1"/>
+          </a:fillRef>
+          <a:effectRef idx="0">
+            <a:schemeClr val="accent1"/>
+          </a:effectRef>
+          <a:fontRef idx="minor">
+            <a:schemeClr val="lt1"/>
+          </a:fontRef>
+        </p:style>
+        <p:txBody>
+          <a:bodyPr rtlCol="0" anchor="ctr"/>
+          <a:lstStyle/>
+          <a:p>
+            <a:pPr algn="ctr"/>
+            <a:endParaRPr lang="en-US"/>
+          </a:p>
+        </p:txBody>
+      </p:sp>
+      <p:pic>
+        <p:nvPicPr>
+          <p:cNvPr id="70" name="Picture 69" descr="GEA CowView Locates Cattle Via Active RFID - RFID JOURNAL">
+            <a:extLst>
+              <a:ext uri="{FF2B5EF4-FFF2-40B4-BE49-F238E27FC236}">
+                <a16:creationId xmlns:a16="http://schemas.microsoft.com/office/drawing/2014/main" id="{C5F96D71-DCD3-CB0E-AE44-430191729F31}"/>
+              </a:ext>
+            </a:extLst>
+          </p:cNvPr>
+          <p:cNvPicPr>
+            <a:picLocks noChangeAspect="1"/>
+          </p:cNvPicPr>
+          <p:nvPr/>
+        </p:nvPicPr>
+        <p:blipFill>
+          <a:blip r:embed="rId8"/>
+          <a:srcRect/>
+          <a:stretch>
+            <a:fillRect/>
+          </a:stretch>
+        </p:blipFill>
+        <p:spPr>
+          <a:xfrm>
+            <a:off x="2591972" y="6749242"/>
+            <a:ext cx="1424997" cy="997497"/>
+          </a:xfrm>
+          <a:prstGeom prst="rect">
+            <a:avLst/>
+          </a:prstGeom>
+        </p:spPr>
+      </p:pic>
     </p:spTree>
     <p:extLst>
       <p:ext uri="{BB962C8B-B14F-4D97-AF65-F5344CB8AC3E}">

</xml_diff>